<commit_message>
Apply CTC public names (Switch 1, Mast 2L, OS S-R, Mast 2035/2036) and refresh wiring docs.
Keep MQTT systemNames and ISNX frozen; rewire CATS Master 4 and USS v74; restamp Desktop v85. Re-Discover SML after reload.

Co-authored-by: Cursor <cursoragent@cursor.com>
</commit_message>
<xml_diff>
--- a/docs/wiring/Wiring_Schematic.pptx
+++ b/docs/wiring/Wiring_Schematic.pptx
@@ -19502,7 +19502,7 @@
                         <a:defRPr sz="800"/>
                       </a:pPr>
                       <a:r>
-                        <a:t>Switch 113</a:t>
+                        <a:t>Switch 35</a:t>
                       </a:r>
                     </a:p>
                   </a:txBody>
@@ -19562,7 +19562,7 @@
                         <a:defRPr sz="800"/>
                       </a:pPr>
                       <a:r>
-                        <a:t>113RA, S1-3, 113RB</a:t>
+                        <a:t>Mast 36RA, S1-3, Mast 36RB</a:t>
                       </a:r>
                     </a:p>
                   </a:txBody>
@@ -19579,7 +19579,7 @@
                         <a:defRPr sz="800"/>
                       </a:pPr>
                       <a:r>
-                        <a:t>Switch 114</a:t>
+                        <a:t>Switch 37</a:t>
                       </a:r>
                     </a:p>
                   </a:txBody>
@@ -19655,7 +19655,7 @@
                         <a:defRPr sz="800"/>
                       </a:pPr>
                       <a:r>
-                        <a:t>114R, 114LB, 114LA</a:t>
+                        <a:t>Head 2036, Mast 38LB, Head 38LA</a:t>
                       </a:r>
                     </a:p>
                   </a:txBody>
@@ -19676,7 +19676,7 @@
                         <a:defRPr sz="800"/>
                       </a:pPr>
                       <a:r>
-                        <a:t>Switch 115</a:t>
+                        <a:t>Switch 39</a:t>
                       </a:r>
                     </a:p>
                   </a:txBody>
@@ -19736,7 +19736,7 @@
                         <a:defRPr sz="800"/>
                       </a:pPr>
                       <a:r>
-                        <a:t>115R, 115LB, 115LA</a:t>
+                        <a:t>Head 2035, Mast 40LB, Head 40LA</a:t>
                       </a:r>
                     </a:p>
                   </a:txBody>
@@ -20024,7 +20024,7 @@
                         <a:defRPr sz="800"/>
                       </a:pPr>
                       <a:r>
-                        <a:t>Switch 110</a:t>
+                        <a:t>Switch 23</a:t>
                       </a:r>
                     </a:p>
                   </a:txBody>
@@ -20054,7 +20054,7 @@
                         <a:defRPr sz="800"/>
                       </a:pPr>
                       <a:r>
-                        <a:t>C2-IN2-4</a:t>
+                        <a:t>C2-IN2-5</a:t>
                       </a:r>
                     </a:p>
                   </a:txBody>
@@ -20069,7 +20069,7 @@
                         <a:defRPr sz="800"/>
                       </a:pPr>
                       <a:r>
-                        <a:t>N:C2-IN1-7, R:C2-IN1-8</a:t>
+                        <a:t>N:C2-IN3-1, R:C2-IN3-2</a:t>
                       </a:r>
                     </a:p>
                   </a:txBody>
@@ -20084,7 +20084,7 @@
                         <a:defRPr sz="800"/>
                       </a:pPr>
                       <a:r>
-                        <a:t>110R, S2-1</a:t>
+                        <a:t>Mast 24L, Mast 24RA, Head 24RB</a:t>
                       </a:r>
                     </a:p>
                   </a:txBody>
@@ -20101,7 +20101,7 @@
                         <a:defRPr sz="800"/>
                       </a:pPr>
                       <a:r>
-                        <a:t>Switch 111</a:t>
+                        <a:t>Switch 31</a:t>
                       </a:r>
                     </a:p>
                   </a:txBody>
@@ -20139,7 +20139,7 @@
                         <a:defRPr sz="800"/>
                       </a:pPr>
                       <a:r>
-                        <a:t>C2-IN2-5</a:t>
+                        <a:t>C2-IN2-4</a:t>
                       </a:r>
                     </a:p>
                   </a:txBody>
@@ -20158,7 +20158,7 @@
                         <a:defRPr sz="800"/>
                       </a:pPr>
                       <a:r>
-                        <a:t>N:C2-IN3-1, R:C2-IN3-2</a:t>
+                        <a:t>N:C2-IN1-7, R:C2-IN1-8</a:t>
                       </a:r>
                     </a:p>
                   </a:txBody>
@@ -20177,7 +20177,7 @@
                         <a:defRPr sz="800"/>
                       </a:pPr>
                       <a:r>
-                        <a:t>111L, 111RA, 111RB</a:t>
+                        <a:t>Head 32R, S2-1</a:t>
                       </a:r>
                     </a:p>
                   </a:txBody>
@@ -20198,7 +20198,7 @@
                         <a:defRPr sz="800"/>
                       </a:pPr>
                       <a:r>
-                        <a:t>Switch 112</a:t>
+                        <a:t>Switch 33</a:t>
                       </a:r>
                     </a:p>
                   </a:txBody>
@@ -20258,7 +20258,7 @@
                         <a:defRPr sz="800"/>
                       </a:pPr>
                       <a:r>
-                        <a:t>112L, 112R</a:t>
+                        <a:t>Mast 34L, Mast 34R</a:t>
                       </a:r>
                     </a:p>
                   </a:txBody>
@@ -20623,7 +20623,7 @@
                         <a:defRPr sz="800"/>
                       </a:pPr>
                       <a:r>
-                        <a:t>Switch 117</a:t>
+                        <a:t>Switch 118</a:t>
                       </a:r>
                     </a:p>
                   </a:txBody>
@@ -20661,7 +20661,7 @@
                         <a:defRPr sz="800"/>
                       </a:pPr>
                       <a:r>
-                        <a:t>C5-IN2-1</a:t>
+                        <a:t>C5-IN2-2</a:t>
                       </a:r>
                     </a:p>
                   </a:txBody>
@@ -20680,7 +20680,7 @@
                         <a:defRPr sz="800"/>
                       </a:pPr>
                       <a:r>
-                        <a:t>N:C5-IN1-1, R:C5-IN1-2</a:t>
+                        <a:t>N:C5-IN1-3, R:C5-IN1-4</a:t>
                       </a:r>
                     </a:p>
                   </a:txBody>
@@ -20698,9 +20698,6 @@
                       <a:pPr>
                         <a:defRPr sz="800"/>
                       </a:pPr>
-                      <a:r>
-                        <a:t>117RA, 117LA, 117LB / 117RB</a:t>
-                      </a:r>
                     </a:p>
                   </a:txBody>
                   <a:tcPr>
@@ -20720,7 +20717,7 @@
                         <a:defRPr sz="800"/>
                       </a:pPr>
                       <a:r>
-                        <a:t>Switch 118</a:t>
+                        <a:t>Switch 119</a:t>
                       </a:r>
                     </a:p>
                   </a:txBody>
@@ -20750,7 +20747,7 @@
                         <a:defRPr sz="800"/>
                       </a:pPr>
                       <a:r>
-                        <a:t>C5-IN2-2</a:t>
+                        <a:t>C5-IN2-3</a:t>
                       </a:r>
                     </a:p>
                   </a:txBody>
@@ -20765,7 +20762,7 @@
                         <a:defRPr sz="800"/>
                       </a:pPr>
                       <a:r>
-                        <a:t>N:C5-IN1-3, R:C5-IN1-4</a:t>
+                        <a:t>N:C5-IN1-5, R:C5-IN1-6</a:t>
                       </a:r>
                     </a:p>
                   </a:txBody>
@@ -20794,7 +20791,7 @@
                         <a:defRPr sz="800"/>
                       </a:pPr>
                       <a:r>
-                        <a:t>Switch 119</a:t>
+                        <a:t>Switch 7</a:t>
                       </a:r>
                     </a:p>
                   </a:txBody>
@@ -20832,7 +20829,7 @@
                         <a:defRPr sz="800"/>
                       </a:pPr>
                       <a:r>
-                        <a:t>C5-IN2-3</a:t>
+                        <a:t>C5-IN2-1</a:t>
                       </a:r>
                     </a:p>
                   </a:txBody>
@@ -20851,7 +20848,7 @@
                         <a:defRPr sz="800"/>
                       </a:pPr>
                       <a:r>
-                        <a:t>N:C5-IN1-5, R:C5-IN1-6</a:t>
+                        <a:t>N:C5-IN1-1, R:C5-IN1-2</a:t>
                       </a:r>
                     </a:p>
                   </a:txBody>
@@ -20869,6 +20866,9 @@
                       <a:pPr>
                         <a:defRPr sz="800"/>
                       </a:pPr>
+                      <a:r>
+                        <a:t>Mast 8RA, Mast 8LA, Head 8LB / Mast 8RB</a:t>
+                      </a:r>
                     </a:p>
                   </a:txBody>
                   <a:tcPr>
@@ -20888,7 +20888,7 @@
                         <a:defRPr sz="800"/>
                       </a:pPr>
                       <a:r>
-                        <a:t>Switch 100</a:t>
+                        <a:t>Switch 1</a:t>
                       </a:r>
                     </a:p>
                   </a:txBody>
@@ -20948,7 +20948,7 @@
                         <a:defRPr sz="800"/>
                       </a:pPr>
                       <a:r>
-                        <a:t>100L</a:t>
+                        <a:t>Mast 2L</a:t>
                       </a:r>
                     </a:p>
                   </a:txBody>
@@ -20965,7 +20965,7 @@
                         <a:defRPr sz="800"/>
                       </a:pPr>
                       <a:r>
-                        <a:t>Switch 101</a:t>
+                        <a:t>Switch 116</a:t>
                       </a:r>
                     </a:p>
                   </a:txBody>
@@ -21003,7 +21003,7 @@
                         <a:defRPr sz="800"/>
                       </a:pPr>
                       <a:r>
-                        <a:t>C6-IN2-2</a:t>
+                        <a:t>C6-IN2-4</a:t>
                       </a:r>
                     </a:p>
                   </a:txBody>
@@ -21022,7 +21022,7 @@
                         <a:defRPr sz="800"/>
                       </a:pPr>
                       <a:r>
-                        <a:t>N:C6-IN1-3, R:C6-IN1-4</a:t>
+                        <a:t>N:C6-IN1-7, R:C6-IN1-8</a:t>
                       </a:r>
                     </a:p>
                   </a:txBody>
@@ -21040,9 +21040,6 @@
                       <a:pPr>
                         <a:defRPr sz="800"/>
                       </a:pPr>
-                      <a:r>
-                        <a:t>S1-1, 101RA, 101RB</a:t>
-                      </a:r>
                     </a:p>
                   </a:txBody>
                   <a:tcPr>
@@ -21208,7 +21205,7 @@
                         <a:defRPr sz="800"/>
                       </a:pPr>
                       <a:r>
-                        <a:t>Switch 102</a:t>
+                        <a:t>Switch 3</a:t>
                       </a:r>
                     </a:p>
                   </a:txBody>
@@ -21238,7 +21235,7 @@
                         <a:defRPr sz="800"/>
                       </a:pPr>
                       <a:r>
-                        <a:t>C6-IN2-3</a:t>
+                        <a:t>C6-IN2-2</a:t>
                       </a:r>
                     </a:p>
                   </a:txBody>
@@ -21253,7 +21250,7 @@
                         <a:defRPr sz="800"/>
                       </a:pPr>
                       <a:r>
-                        <a:t>N:C6-IN1-5, R:C6-IN1-6</a:t>
+                        <a:t>N:C6-IN1-3, R:C6-IN1-4</a:t>
                       </a:r>
                     </a:p>
                   </a:txBody>
@@ -21268,7 +21265,7 @@
                         <a:defRPr sz="800"/>
                       </a:pPr>
                       <a:r>
-                        <a:t>102LA, S3-6, 102LB</a:t>
+                        <a:t>S1-1, Head 4RA, Head 4RB</a:t>
                       </a:r>
                     </a:p>
                   </a:txBody>
@@ -21285,7 +21282,7 @@
                         <a:defRPr sz="800"/>
                       </a:pPr>
                       <a:r>
-                        <a:t>Switch 116</a:t>
+                        <a:t>Switch 5</a:t>
                       </a:r>
                     </a:p>
                   </a:txBody>
@@ -21323,7 +21320,7 @@
                         <a:defRPr sz="800"/>
                       </a:pPr>
                       <a:r>
-                        <a:t>C6-IN2-4</a:t>
+                        <a:t>C6-IN2-3</a:t>
                       </a:r>
                     </a:p>
                   </a:txBody>
@@ -21342,7 +21339,7 @@
                         <a:defRPr sz="800"/>
                       </a:pPr>
                       <a:r>
-                        <a:t>N:C6-IN1-7, R:C6-IN1-8</a:t>
+                        <a:t>N:C6-IN1-5, R:C6-IN1-6</a:t>
                       </a:r>
                     </a:p>
                   </a:txBody>
@@ -21360,6 +21357,9 @@
                       <a:pPr>
                         <a:defRPr sz="800"/>
                       </a:pPr>
+                      <a:r>
+                        <a:t>Head 6LA, S3-6, Mast 6LB</a:t>
+                      </a:r>
                     </a:p>
                   </a:txBody>
                   <a:tcPr>
@@ -23368,7 +23368,7 @@
                         <a:defRPr sz="800"/>
                       </a:pPr>
                       <a:r>
-                        <a:t>117RA Top</a:t>
+                        <a:t>Head 8RA Top</a:t>
                       </a:r>
                     </a:p>
                   </a:txBody>
@@ -23418,7 +23418,7 @@
                         <a:defRPr sz="800"/>
                       </a:pPr>
                       <a:r>
-                        <a:t>117RA Bottom</a:t>
+                        <a:t>Head 8RA Bottom</a:t>
                       </a:r>
                     </a:p>
                   </a:txBody>
@@ -23468,7 +23468,7 @@
                         <a:defRPr sz="800"/>
                       </a:pPr>
                       <a:r>
-                        <a:t>117LB</a:t>
+                        <a:t>Head 8LB</a:t>
                       </a:r>
                     </a:p>
                   </a:txBody>
@@ -23518,7 +23518,7 @@
                         <a:defRPr sz="800"/>
                       </a:pPr>
                       <a:r>
-                        <a:t>117RB Top</a:t>
+                        <a:t>Head 8RB Top</a:t>
                       </a:r>
                     </a:p>
                   </a:txBody>
@@ -23568,7 +23568,7 @@
                         <a:defRPr sz="800"/>
                       </a:pPr>
                       <a:r>
-                        <a:t>117RB Bottom</a:t>
+                        <a:t>Head 8RB Bottom</a:t>
                       </a:r>
                     </a:p>
                   </a:txBody>
@@ -23618,7 +23618,7 @@
                         <a:defRPr sz="800"/>
                       </a:pPr>
                       <a:r>
-                        <a:t>117LA Top</a:t>
+                        <a:t>Head 8LA Top</a:t>
                       </a:r>
                     </a:p>
                   </a:txBody>
@@ -23824,7 +23824,7 @@
                         <a:defRPr sz="800"/>
                       </a:pPr>
                       <a:r>
-                        <a:t>117LA Bottom</a:t>
+                        <a:t>Head 8LA Bottom</a:t>
                       </a:r>
                     </a:p>
                   </a:txBody>
@@ -25174,7 +25174,7 @@
                         <a:defRPr sz="800"/>
                       </a:pPr>
                       <a:r>
-                        <a:t>McKees Rocks</a:t>
+                        <a:t>OS McKees Rocks</a:t>
                       </a:r>
                     </a:p>
                   </a:txBody>
@@ -25224,7 +25224,7 @@
                         <a:defRPr sz="800"/>
                       </a:pPr>
                       <a:r>
-                        <a:t>McKeesport</a:t>
+                        <a:t>OS McKeesport</a:t>
                       </a:r>
                     </a:p>
                   </a:txBody>
@@ -25274,7 +25274,7 @@
                         <a:defRPr sz="800"/>
                       </a:pPr>
                       <a:r>
-                        <a:t>OS 114 / K-2</a:t>
+                        <a:t>OS 37</a:t>
                       </a:r>
                     </a:p>
                   </a:txBody>
@@ -25324,7 +25324,7 @@
                         <a:defRPr sz="800"/>
                       </a:pPr>
                       <a:r>
-                        <a:t>OS 115 / K-1</a:t>
+                        <a:t>OS 39</a:t>
                       </a:r>
                     </a:p>
                   </a:txBody>
@@ -25374,7 +25374,7 @@
                         <a:defRPr sz="800"/>
                       </a:pPr>
                       <a:r>
-                        <a:t>OS 113b</a:t>
+                        <a:t>OS 35b</a:t>
                       </a:r>
                     </a:p>
                   </a:txBody>
@@ -25424,7 +25424,7 @@
                         <a:defRPr sz="800"/>
                       </a:pPr>
                       <a:r>
-                        <a:t>OS 113a</a:t>
+                        <a:t>OS 35a</a:t>
                       </a:r>
                     </a:p>
                   </a:txBody>
@@ -25474,7 +25474,7 @@
                         <a:defRPr sz="800"/>
                       </a:pPr>
                       <a:r>
-                        <a:t>East Lead</a:t>
+                        <a:t>OS East Lead</a:t>
                       </a:r>
                     </a:p>
                   </a:txBody>
@@ -25524,7 +25524,7 @@
                         <a:defRPr sz="800"/>
                       </a:pPr>
                       <a:r>
-                        <a:t>West Main Ext</a:t>
+                        <a:t>OS West Main Ext</a:t>
                       </a:r>
                     </a:p>
                   </a:txBody>
@@ -30717,7 +30717,7 @@
                         <a:defRPr sz="800"/>
                       </a:pPr>
                       <a:r>
-                        <a:t>Main West</a:t>
+                        <a:t>OS Main West</a:t>
                       </a:r>
                     </a:p>
                   </a:txBody>
@@ -30817,7 +30817,7 @@
                         <a:defRPr sz="800"/>
                       </a:pPr>
                       <a:r>
-                        <a:t>Main East</a:t>
+                        <a:t>OS Main East</a:t>
                       </a:r>
                     </a:p>
                   </a:txBody>
@@ -30867,7 +30867,7 @@
                         <a:defRPr sz="800"/>
                       </a:pPr>
                       <a:r>
-                        <a:t>S-5</a:t>
+                        <a:t>OS S-4</a:t>
                       </a:r>
                     </a:p>
                   </a:txBody>
@@ -30917,7 +30917,7 @@
                         <a:defRPr sz="800"/>
                       </a:pPr>
                       <a:r>
-                        <a:t>S-4</a:t>
+                        <a:t>OS S-3</a:t>
                       </a:r>
                     </a:p>
                   </a:txBody>
@@ -30967,7 +30967,7 @@
                         <a:defRPr sz="800"/>
                       </a:pPr>
                       <a:r>
-                        <a:t>S-3</a:t>
+                        <a:t>OS S-2</a:t>
                       </a:r>
                     </a:p>
                   </a:txBody>
@@ -31017,7 +31017,7 @@
                         <a:defRPr sz="800"/>
                       </a:pPr>
                       <a:r>
-                        <a:t>S-2</a:t>
+                        <a:t>OS S-1</a:t>
                       </a:r>
                     </a:p>
                   </a:txBody>
@@ -31067,7 +31067,7 @@
                         <a:defRPr sz="800"/>
                       </a:pPr>
                       <a:r>
-                        <a:t>S-1</a:t>
+                        <a:t>OS S-R</a:t>
                       </a:r>
                     </a:p>
                   </a:txBody>
@@ -31684,7 +31684,7 @@
                         <a:defRPr sz="800"/>
                       </a:pPr>
                       <a:r>
-                        <a:t>102LB Top</a:t>
+                        <a:t>Head 6LB Top</a:t>
                       </a:r>
                     </a:p>
                   </a:txBody>
@@ -31734,7 +31734,7 @@
                         <a:defRPr sz="800"/>
                       </a:pPr>
                       <a:r>
-                        <a:t>102LB Bottom</a:t>
+                        <a:t>Head 6LB Bottom</a:t>
                       </a:r>
                     </a:p>
                   </a:txBody>
@@ -31784,7 +31784,7 @@
                         <a:defRPr sz="800"/>
                       </a:pPr>
                       <a:r>
-                        <a:t>102LA Top</a:t>
+                        <a:t>Head 6LA</a:t>
                       </a:r>
                     </a:p>
                   </a:txBody>
@@ -31834,7 +31834,7 @@
                         <a:defRPr sz="800"/>
                       </a:pPr>
                       <a:r>
-                        <a:t>102LA Bottom</a:t>
+                        <a:t>S3-7 G</a:t>
                       </a:r>
                     </a:p>
                   </a:txBody>
@@ -31884,7 +31884,7 @@
                         <a:defRPr sz="800"/>
                       </a:pPr>
                       <a:r>
-                        <a:t>101RA</a:t>
+                        <a:t>Head 4RA</a:t>
                       </a:r>
                     </a:p>
                   </a:txBody>
@@ -31934,7 +31934,7 @@
                         <a:defRPr sz="800"/>
                       </a:pPr>
                       <a:r>
-                        <a:t>101RB</a:t>
+                        <a:t>Head 4RB</a:t>
                       </a:r>
                     </a:p>
                   </a:txBody>
@@ -32143,7 +32143,7 @@
                         <a:defRPr sz="800"/>
                       </a:pPr>
                       <a:r>
-                        <a:t>100L Top</a:t>
+                        <a:t>Head 2L Top</a:t>
                       </a:r>
                     </a:p>
                   </a:txBody>
@@ -32193,7 +32193,7 @@
                         <a:defRPr sz="800"/>
                       </a:pPr>
                       <a:r>
-                        <a:t>100L Bottom</a:t>
+                        <a:t>Head 2L Bottom</a:t>
                       </a:r>
                     </a:p>
                   </a:txBody>
@@ -33508,7 +33508,7 @@
                         <a:defRPr sz="800"/>
                       </a:pPr>
                       <a:r>
-                        <a:t>OS 116</a:t>
+                        <a:t>OS 13</a:t>
                       </a:r>
                     </a:p>
                   </a:txBody>
@@ -33558,7 +33558,7 @@
                         <a:defRPr sz="800"/>
                       </a:pPr>
                       <a:r>
-                        <a:t>OS 103</a:t>
+                        <a:t>OS 15</a:t>
                       </a:r>
                     </a:p>
                   </a:txBody>
@@ -33608,7 +33608,7 @@
                         <a:defRPr sz="800"/>
                       </a:pPr>
                       <a:r>
-                        <a:t>OS 104</a:t>
+                        <a:t>OS 17</a:t>
                       </a:r>
                     </a:p>
                   </a:txBody>
@@ -33708,7 +33708,7 @@
                         <a:defRPr sz="800"/>
                       </a:pPr>
                       <a:r>
-                        <a:t>OS 105</a:t>
+                        <a:t>OS 19</a:t>
                       </a:r>
                     </a:p>
                   </a:txBody>
@@ -33808,7 +33808,7 @@
                         <a:defRPr sz="800"/>
                       </a:pPr>
                       <a:r>
-                        <a:t>OS 106</a:t>
+                        <a:t>OS 21</a:t>
                       </a:r>
                     </a:p>
                   </a:txBody>
@@ -36281,7 +36281,7 @@
                         <a:defRPr sz="800"/>
                       </a:pPr>
                       <a:r>
-                        <a:t>Barn</a:t>
+                        <a:t>OS Barn</a:t>
                       </a:r>
                     </a:p>
                   </a:txBody>
@@ -36331,7 +36331,7 @@
                         <a:defRPr sz="800"/>
                       </a:pPr>
                       <a:r>
-                        <a:t>OS 118</a:t>
+                        <a:t>OS 11</a:t>
                       </a:r>
                     </a:p>
                   </a:txBody>
@@ -36381,7 +36381,7 @@
                         <a:defRPr sz="800"/>
                       </a:pPr>
                       <a:r>
-                        <a:t>OS 117</a:t>
+                        <a:t>OS 7</a:t>
                       </a:r>
                     </a:p>
                   </a:txBody>
@@ -36431,7 +36431,7 @@
                         <a:defRPr sz="800"/>
                       </a:pPr>
                       <a:r>
-                        <a:t>OS 117b</a:t>
+                        <a:t>OS 7b</a:t>
                       </a:r>
                     </a:p>
                   </a:txBody>
@@ -36481,7 +36481,7 @@
                         <a:defRPr sz="800"/>
                       </a:pPr>
                       <a:r>
-                        <a:t>EH-1</a:t>
+                        <a:t>OS EH-3</a:t>
                       </a:r>
                     </a:p>
                   </a:txBody>
@@ -36531,7 +36531,7 @@
                         <a:defRPr sz="800"/>
                       </a:pPr>
                       <a:r>
-                        <a:t>EH-2</a:t>
+                        <a:t>OS EH-2</a:t>
                       </a:r>
                     </a:p>
                   </a:txBody>
@@ -36581,7 +36581,7 @@
                         <a:defRPr sz="800"/>
                       </a:pPr>
                       <a:r>
-                        <a:t>EH-3</a:t>
+                        <a:t>OS EH-1</a:t>
                       </a:r>
                     </a:p>
                   </a:txBody>
@@ -36631,7 +36631,7 @@
                         <a:defRPr sz="800"/>
                       </a:pPr>
                       <a:r>
-                        <a:t>OS 119</a:t>
+                        <a:t>OS 9</a:t>
                       </a:r>
                     </a:p>
                   </a:txBody>
@@ -39063,7 +39063,7 @@
                         <a:defRPr sz="800"/>
                       </a:pPr>
                       <a:r>
-                        <a:t>OS 101</a:t>
+                        <a:t>OS 3</a:t>
                       </a:r>
                     </a:p>
                   </a:txBody>
@@ -39113,7 +39113,7 @@
                         <a:defRPr sz="800"/>
                       </a:pPr>
                       <a:r>
-                        <a:t>OS 100</a:t>
+                        <a:t>OS 1</a:t>
                       </a:r>
                     </a:p>
                   </a:txBody>
@@ -39163,7 +39163,7 @@
                         <a:defRPr sz="800"/>
                       </a:pPr>
                       <a:r>
-                        <a:t>W-2</a:t>
+                        <a:t>OS W-2</a:t>
                       </a:r>
                     </a:p>
                   </a:txBody>
@@ -39213,7 +39213,7 @@
                         <a:defRPr sz="800"/>
                       </a:pPr>
                       <a:r>
-                        <a:t>W-1</a:t>
+                        <a:t>OS W-1</a:t>
                       </a:r>
                     </a:p>
                   </a:txBody>
@@ -39263,7 +39263,7 @@
                         <a:defRPr sz="800"/>
                       </a:pPr>
                       <a:r>
-                        <a:t>OS 102</a:t>
+                        <a:t>OS 5</a:t>
                       </a:r>
                     </a:p>
                   </a:txBody>
@@ -39313,7 +39313,7 @@
                         <a:defRPr sz="800"/>
                       </a:pPr>
                       <a:r>
-                        <a:t>Brick-Plane</a:t>
+                        <a:t>OS Brick-Plane</a:t>
                       </a:r>
                     </a:p>
                   </a:txBody>
@@ -39363,7 +39363,7 @@
                         <a:defRPr sz="800"/>
                       </a:pPr>
                       <a:r>
-                        <a:t>East Main Ext</a:t>
+                        <a:t>OS East Main Ext</a:t>
                       </a:r>
                     </a:p>
                   </a:txBody>
@@ -39413,7 +39413,7 @@
                         <a:defRPr sz="800"/>
                       </a:pPr>
                       <a:r>
-                        <a:t>Scale</a:t>
+                        <a:t>OS Scale</a:t>
                       </a:r>
                     </a:p>
                   </a:txBody>
@@ -40024,7 +40024,7 @@
                         <a:defRPr sz="800"/>
                       </a:pPr>
                       <a:r>
-                        <a:t>111RA Top</a:t>
+                        <a:t>Head 24RA Top</a:t>
                       </a:r>
                     </a:p>
                   </a:txBody>
@@ -40074,7 +40074,7 @@
                         <a:defRPr sz="800"/>
                       </a:pPr>
                       <a:r>
-                        <a:t>111RA Bottom</a:t>
+                        <a:t>Head 24RA Bottom</a:t>
                       </a:r>
                     </a:p>
                   </a:txBody>
@@ -40124,7 +40124,7 @@
                         <a:defRPr sz="800"/>
                       </a:pPr>
                       <a:r>
-                        <a:t>111L Top</a:t>
+                        <a:t>Head 24L Top</a:t>
                       </a:r>
                     </a:p>
                   </a:txBody>
@@ -40174,7 +40174,7 @@
                         <a:defRPr sz="800"/>
                       </a:pPr>
                       <a:r>
-                        <a:t>111L Bottom</a:t>
+                        <a:t>Head 24L Bottom</a:t>
                       </a:r>
                     </a:p>
                   </a:txBody>
@@ -40224,7 +40224,7 @@
                         <a:defRPr sz="800"/>
                       </a:pPr>
                       <a:r>
-                        <a:t>111RB</a:t>
+                        <a:t>Head 24RB</a:t>
                       </a:r>
                     </a:p>
                   </a:txBody>
@@ -40274,7 +40274,7 @@
                         <a:defRPr sz="800"/>
                       </a:pPr>
                       <a:r>
-                        <a:t>112L Top</a:t>
+                        <a:t>Head 34L Top</a:t>
                       </a:r>
                     </a:p>
                   </a:txBody>
@@ -40480,7 +40480,7 @@
                         <a:defRPr sz="800"/>
                       </a:pPr>
                       <a:r>
-                        <a:t>112L Bottom</a:t>
+                        <a:t>Head 34L Bottom</a:t>
                       </a:r>
                     </a:p>
                   </a:txBody>
@@ -40530,7 +40530,7 @@
                         <a:defRPr sz="800"/>
                       </a:pPr>
                       <a:r>
-                        <a:t>110R</a:t>
+                        <a:t>Head 32R</a:t>
                       </a:r>
                     </a:p>
                   </a:txBody>
@@ -40580,7 +40580,7 @@
                         <a:defRPr sz="800"/>
                       </a:pPr>
                       <a:r>
-                        <a:t>112R Top</a:t>
+                        <a:t>Head 34R Top</a:t>
                       </a:r>
                     </a:p>
                   </a:txBody>
@@ -40630,7 +40630,7 @@
                         <a:defRPr sz="800"/>
                       </a:pPr>
                       <a:r>
-                        <a:t>112R Bottom</a:t>
+                        <a:t>Head 34R Bottom</a:t>
                       </a:r>
                     </a:p>
                   </a:txBody>

</xml_diff>

<commit_message>
Add four 5V OU4 boards and wire both discs on every two-head mast.
Second lamps stay on the same radio as the top disc; C11 uses leftover OU3 instead of a new board. tables.xml is unchanged.

Co-authored-by: Cursor <cursoragent@cursor.com>
</commit_message>
<xml_diff>
--- a/docs/wiring/Wiring_Schematic.pptx
+++ b/docs/wiring/Wiring_Schematic.pptx
@@ -3393,7 +3393,7 @@
                         <a:defRPr sz="1000"/>
                       </a:pPr>
                       <a:r>
-                        <a:t>2</a:t>
+                        <a:t>3</a:t>
                       </a:r>
                     </a:p>
                   </a:txBody>
@@ -3516,7 +3516,7 @@
                         <a:defRPr sz="1000"/>
                       </a:pPr>
                       <a:r>
-                        <a:t>3</a:t>
+                        <a:t>4</a:t>
                       </a:r>
                     </a:p>
                   </a:txBody>
@@ -3635,7 +3635,7 @@
                         <a:defRPr sz="1000"/>
                       </a:pPr>
                       <a:r>
-                        <a:t>2</a:t>
+                        <a:t>3</a:t>
                       </a:r>
                     </a:p>
                   </a:txBody>
@@ -4119,7 +4119,7 @@
                         <a:defRPr sz="1000"/>
                       </a:pPr>
                       <a:r>
-                        <a:t>2</a:t>
+                        <a:t>3</a:t>
                       </a:r>
                     </a:p>
                   </a:txBody>
@@ -23368,7 +23368,7 @@
                         <a:defRPr sz="800"/>
                       </a:pPr>
                       <a:r>
-                        <a:t>Head 40LB G</a:t>
+                        <a:t>Head 40LB T G</a:t>
                       </a:r>
                     </a:p>
                   </a:txBody>
@@ -23418,7 +23418,7 @@
                         <a:defRPr sz="800"/>
                       </a:pPr>
                       <a:r>
-                        <a:t>Head 40LB Y</a:t>
+                        <a:t>Head 40LB T Y</a:t>
                       </a:r>
                     </a:p>
                   </a:txBody>
@@ -23468,7 +23468,7 @@
                         <a:defRPr sz="800"/>
                       </a:pPr>
                       <a:r>
-                        <a:t>Head 40LB R</a:t>
+                        <a:t>Head 40LB T R</a:t>
                       </a:r>
                     </a:p>
                   </a:txBody>
@@ -23518,7 +23518,7 @@
                         <a:defRPr sz="800"/>
                       </a:pPr>
                       <a:r>
-                        <a:t>Head 36RA G</a:t>
+                        <a:t>Head 36RA T G</a:t>
                       </a:r>
                     </a:p>
                   </a:txBody>
@@ -23568,7 +23568,7 @@
                         <a:defRPr sz="800"/>
                       </a:pPr>
                       <a:r>
-                        <a:t>Head 36RA Y</a:t>
+                        <a:t>Head 36RA T Y</a:t>
                       </a:r>
                     </a:p>
                   </a:txBody>
@@ -23618,7 +23618,7 @@
                         <a:defRPr sz="800"/>
                       </a:pPr>
                       <a:r>
-                        <a:t>Head 36RA R</a:t>
+                        <a:t>Head 36RA T R</a:t>
                       </a:r>
                     </a:p>
                   </a:txBody>
@@ -23718,7 +23718,7 @@
                         <a:defRPr sz="800"/>
                       </a:pPr>
                       <a:r>
-                        <a:t>C1 RELAY 1</a:t>
+                        <a:t>Head 38LB B R</a:t>
                       </a:r>
                     </a:p>
                   </a:txBody>
@@ -23827,7 +23827,7 @@
                         <a:defRPr sz="800"/>
                       </a:pPr>
                       <a:r>
-                        <a:t>Head 38LB G</a:t>
+                        <a:t>Head 38LB T G</a:t>
                       </a:r>
                     </a:p>
                   </a:txBody>
@@ -23877,7 +23877,7 @@
                         <a:defRPr sz="800"/>
                       </a:pPr>
                       <a:r>
-                        <a:t>Head 38LB Y</a:t>
+                        <a:t>Head 38LB T Y</a:t>
                       </a:r>
                     </a:p>
                   </a:txBody>
@@ -23927,7 +23927,7 @@
                         <a:defRPr sz="800"/>
                       </a:pPr>
                       <a:r>
-                        <a:t>Head 38LB R</a:t>
+                        <a:t>Head 38LB T R</a:t>
                       </a:r>
                     </a:p>
                   </a:txBody>
@@ -25691,7 +25691,7 @@
                         <a:defRPr sz="800"/>
                       </a:pPr>
                       <a:r>
-                        <a:t>Head 24RA G</a:t>
+                        <a:t>Head 24RA T G</a:t>
                       </a:r>
                     </a:p>
                   </a:txBody>
@@ -25741,7 +25741,7 @@
                         <a:defRPr sz="800"/>
                       </a:pPr>
                       <a:r>
-                        <a:t>Head 24RA Y</a:t>
+                        <a:t>Head 24RA T Y</a:t>
                       </a:r>
                     </a:p>
                   </a:txBody>
@@ -25791,7 +25791,7 @@
                         <a:defRPr sz="800"/>
                       </a:pPr>
                       <a:r>
-                        <a:t>Head 24RA R</a:t>
+                        <a:t>Head 24RA T R</a:t>
                       </a:r>
                     </a:p>
                   </a:txBody>
@@ -25841,7 +25841,7 @@
                         <a:defRPr sz="800"/>
                       </a:pPr>
                       <a:r>
-                        <a:t>Head 24L G</a:t>
+                        <a:t>Head 24L T G</a:t>
                       </a:r>
                     </a:p>
                   </a:txBody>
@@ -25891,7 +25891,7 @@
                         <a:defRPr sz="800"/>
                       </a:pPr>
                       <a:r>
-                        <a:t>Head 24L Y</a:t>
+                        <a:t>Head 24L T Y</a:t>
                       </a:r>
                     </a:p>
                   </a:txBody>
@@ -25941,7 +25941,7 @@
                         <a:defRPr sz="800"/>
                       </a:pPr>
                       <a:r>
-                        <a:t>Head 24L R</a:t>
+                        <a:t>Head 24L T R</a:t>
                       </a:r>
                     </a:p>
                   </a:txBody>
@@ -26200,7 +26200,7 @@
                         <a:defRPr sz="800"/>
                       </a:pPr>
                       <a:r>
-                        <a:t>Head 34L G</a:t>
+                        <a:t>Head 34L T G</a:t>
                       </a:r>
                     </a:p>
                   </a:txBody>
@@ -26250,7 +26250,7 @@
                         <a:defRPr sz="800"/>
                       </a:pPr>
                       <a:r>
-                        <a:t>Head 34L Y</a:t>
+                        <a:t>Head 34L T Y</a:t>
                       </a:r>
                     </a:p>
                   </a:txBody>
@@ -26300,7 +26300,7 @@
                         <a:defRPr sz="800"/>
                       </a:pPr>
                       <a:r>
-                        <a:t>Head 34L R</a:t>
+                        <a:t>Head 34L T R</a:t>
                       </a:r>
                     </a:p>
                   </a:txBody>
@@ -26609,7 +26609,7 @@
                         <a:defRPr sz="800"/>
                       </a:pPr>
                       <a:r>
-                        <a:t>Head 34R G</a:t>
+                        <a:t>Head 34R T G</a:t>
                       </a:r>
                     </a:p>
                   </a:txBody>
@@ -26659,7 +26659,7 @@
                         <a:defRPr sz="800"/>
                       </a:pPr>
                       <a:r>
-                        <a:t>Head 34R Y</a:t>
+                        <a:t>Head 34R T Y</a:t>
                       </a:r>
                     </a:p>
                   </a:txBody>
@@ -26709,7 +26709,7 @@
                         <a:defRPr sz="800"/>
                       </a:pPr>
                       <a:r>
-                        <a:t>Head 34R R</a:t>
+                        <a:t>Head 34R T R</a:t>
                       </a:r>
                     </a:p>
                   </a:txBody>
@@ -26759,7 +26759,7 @@
                         <a:defRPr sz="800"/>
                       </a:pPr>
                       <a:r>
-                        <a:t>S2-7 R</a:t>
+                        <a:t>Head 34R B G</a:t>
                       </a:r>
                     </a:p>
                   </a:txBody>
@@ -26809,7 +26809,7 @@
                         <a:defRPr sz="800"/>
                       </a:pPr>
                       <a:r>
-                        <a:t>S2-7 Y</a:t>
+                        <a:t>Head 34R B Y</a:t>
                       </a:r>
                     </a:p>
                   </a:txBody>
@@ -26858,6 +26858,9 @@
                         </a:spcAft>
                         <a:defRPr sz="800"/>
                       </a:pPr>
+                      <a:r>
+                        <a:t>Head 34R B R</a:t>
+                      </a:r>
                     </a:p>
                   </a:txBody>
                   <a:tcPr anchor="t"/>
@@ -26905,6 +26908,9 @@
                         </a:spcAft>
                         <a:defRPr sz="800"/>
                       </a:pPr>
+                      <a:r>
+                        <a:t>Head 34L B R</a:t>
+                      </a:r>
                     </a:p>
                   </a:txBody>
                   <a:tcPr anchor="t"/>
@@ -28932,7 +28938,7 @@
                         <a:defRPr sz="800"/>
                       </a:pPr>
                       <a:r>
-                        <a:t>Head 6LB G</a:t>
+                        <a:t>Head 6LB T G</a:t>
                       </a:r>
                     </a:p>
                   </a:txBody>
@@ -28982,7 +28988,7 @@
                         <a:defRPr sz="800"/>
                       </a:pPr>
                       <a:r>
-                        <a:t>Head 6LB Y</a:t>
+                        <a:t>Head 6LB T Y</a:t>
                       </a:r>
                     </a:p>
                   </a:txBody>
@@ -29032,7 +29038,7 @@
                         <a:defRPr sz="800"/>
                       </a:pPr>
                       <a:r>
-                        <a:t>Head 6LB R</a:t>
+                        <a:t>Head 6LB T R</a:t>
                       </a:r>
                     </a:p>
                   </a:txBody>
@@ -29391,7 +29397,7 @@
                         <a:defRPr sz="800"/>
                       </a:pPr>
                       <a:r>
-                        <a:t>Head 2L G</a:t>
+                        <a:t>Head 2L T G</a:t>
                       </a:r>
                     </a:p>
                   </a:txBody>
@@ -29441,7 +29447,7 @@
                         <a:defRPr sz="800"/>
                       </a:pPr>
                       <a:r>
-                        <a:t>Head 2L Y</a:t>
+                        <a:t>Head 2L T Y</a:t>
                       </a:r>
                     </a:p>
                   </a:txBody>
@@ -29491,7 +29497,7 @@
                         <a:defRPr sz="800"/>
                       </a:pPr>
                       <a:r>
-                        <a:t>Head 2L R</a:t>
+                        <a:t>Head 2L T R</a:t>
                       </a:r>
                     </a:p>
                   </a:txBody>
@@ -34499,7 +34505,7 @@
                         <a:defRPr sz="800"/>
                       </a:pPr>
                       <a:r>
-                        <a:t>Head 36RB G</a:t>
+                        <a:t>Head 36RB T G</a:t>
                       </a:r>
                     </a:p>
                   </a:txBody>
@@ -34549,7 +34555,7 @@
                         <a:defRPr sz="800"/>
                       </a:pPr>
                       <a:r>
-                        <a:t>Head 36RB R</a:t>
+                        <a:t>Head 36RB T R</a:t>
                       </a:r>
                     </a:p>
                   </a:txBody>
@@ -34599,7 +34605,7 @@
                         <a:defRPr sz="800"/>
                       </a:pPr>
                       <a:r>
-                        <a:t>Head 36RB Y</a:t>
+                        <a:t>Head 36RB T Y</a:t>
                       </a:r>
                     </a:p>
                   </a:txBody>
@@ -35105,7 +35111,7 @@
                         <a:defRPr sz="800"/>
                       </a:pPr>
                       <a:r>
-                        <a:t>S4-7 G</a:t>
+                        <a:t>Head 36RB B G</a:t>
                       </a:r>
                     </a:p>
                   </a:txBody>
@@ -35155,7 +35161,7 @@
                         <a:defRPr sz="800"/>
                       </a:pPr>
                       <a:r>
-                        <a:t>S4-7 R</a:t>
+                        <a:t>Head 36RB B Y</a:t>
                       </a:r>
                     </a:p>
                   </a:txBody>
@@ -35205,7 +35211,7 @@
                         <a:defRPr sz="800"/>
                       </a:pPr>
                       <a:r>
-                        <a:t>S4-7 Y</a:t>
+                        <a:t>Head 36RB B R</a:t>
                       </a:r>
                     </a:p>
                   </a:txBody>
@@ -38501,7 +38507,7 @@
                         <a:defRPr sz="800"/>
                       </a:pPr>
                       <a:r>
-                        <a:t>Head 8RA G</a:t>
+                        <a:t>Head 8RA T G</a:t>
                       </a:r>
                     </a:p>
                   </a:txBody>
@@ -38551,7 +38557,7 @@
                         <a:defRPr sz="800"/>
                       </a:pPr>
                       <a:r>
-                        <a:t>Head 8RA Y</a:t>
+                        <a:t>Head 8RA T Y</a:t>
                       </a:r>
                     </a:p>
                   </a:txBody>
@@ -38601,7 +38607,7 @@
                         <a:defRPr sz="800"/>
                       </a:pPr>
                       <a:r>
-                        <a:t>Head 8RA R</a:t>
+                        <a:t>Head 8RA T R</a:t>
                       </a:r>
                     </a:p>
                   </a:txBody>
@@ -38651,7 +38657,7 @@
                         <a:defRPr sz="800"/>
                       </a:pPr>
                       <a:r>
-                        <a:t>Head 8RB G</a:t>
+                        <a:t>Head 8RB T G</a:t>
                       </a:r>
                     </a:p>
                   </a:txBody>
@@ -38701,7 +38707,7 @@
                         <a:defRPr sz="800"/>
                       </a:pPr>
                       <a:r>
-                        <a:t>Head 8RB R</a:t>
+                        <a:t>Head 8RB T R</a:t>
                       </a:r>
                     </a:p>
                   </a:txBody>
@@ -38751,7 +38757,7 @@
                         <a:defRPr sz="800"/>
                       </a:pPr>
                       <a:r>
-                        <a:t>Head 8RB Y</a:t>
+                        <a:t>Head 8RB T Y</a:t>
                       </a:r>
                     </a:p>
                   </a:txBody>
@@ -39110,7 +39116,7 @@
                         <a:defRPr sz="800"/>
                       </a:pPr>
                       <a:r>
-                        <a:t>Head 8LA G</a:t>
+                        <a:t>Head 8LA T G</a:t>
                       </a:r>
                     </a:p>
                   </a:txBody>
@@ -39160,7 +39166,7 @@
                         <a:defRPr sz="800"/>
                       </a:pPr>
                       <a:r>
-                        <a:t>Head 8LA Y</a:t>
+                        <a:t>Head 8LA T Y</a:t>
                       </a:r>
                     </a:p>
                   </a:txBody>
@@ -39210,7 +39216,7 @@
                         <a:defRPr sz="800"/>
                       </a:pPr>
                       <a:r>
-                        <a:t>Head 8LA R</a:t>
+                        <a:t>Head 8LA T R</a:t>
                       </a:r>
                     </a:p>
                   </a:txBody>
@@ -39309,6 +39315,9 @@
                         </a:spcAft>
                         <a:defRPr sz="800"/>
                       </a:pPr>
+                      <a:r>
+                        <a:t>Head 8LA B R</a:t>
+                      </a:r>
                     </a:p>
                   </a:txBody>
                   <a:tcPr anchor="t"/>

</xml_diff>

<commit_message>
Group each two-head mast onto one DNOU8 so those boards can sit next to their plants.
A neighboring dwarf uses the leftover pins; the ninth lamp spills to the adjacent cluster. Packed MQTT IDs are unchanged.

Co-authored-by: Cursor <cursoragent@cursor.com>
</commit_message>
<xml_diff>
--- a/docs/wiring/Wiring_Schematic.pptx
+++ b/docs/wiring/Wiring_Schematic.pptx
@@ -23368,7 +23368,7 @@
                         <a:defRPr sz="800"/>
                       </a:pPr>
                       <a:r>
-                        <a:t>Head 40LB T G</a:t>
+                        <a:t>Head 36RA T G</a:t>
                       </a:r>
                     </a:p>
                   </a:txBody>
@@ -23418,7 +23418,7 @@
                         <a:defRPr sz="800"/>
                       </a:pPr>
                       <a:r>
-                        <a:t>Head 40LB T Y</a:t>
+                        <a:t>Head 36RA T Y</a:t>
                       </a:r>
                     </a:p>
                   </a:txBody>
@@ -23468,7 +23468,7 @@
                         <a:defRPr sz="800"/>
                       </a:pPr>
                       <a:r>
-                        <a:t>Head 40LB T R</a:t>
+                        <a:t>Head 36RA T R</a:t>
                       </a:r>
                     </a:p>
                   </a:txBody>
@@ -23518,7 +23518,7 @@
                         <a:defRPr sz="800"/>
                       </a:pPr>
                       <a:r>
-                        <a:t>Head 36RA T G</a:t>
+                        <a:t>Head 36RA B G</a:t>
                       </a:r>
                     </a:p>
                   </a:txBody>
@@ -23568,7 +23568,7 @@
                         <a:defRPr sz="800"/>
                       </a:pPr>
                       <a:r>
-                        <a:t>Head 36RA T Y</a:t>
+                        <a:t>Head 36RA B Y</a:t>
                       </a:r>
                     </a:p>
                   </a:txBody>
@@ -23618,7 +23618,7 @@
                         <a:defRPr sz="800"/>
                       </a:pPr>
                       <a:r>
-                        <a:t>Head 36RA T R</a:t>
+                        <a:t>Head 36RA B R</a:t>
                       </a:r>
                     </a:p>
                   </a:txBody>
@@ -23668,7 +23668,7 @@
                         <a:defRPr sz="800"/>
                       </a:pPr>
                       <a:r>
-                        <a:t>Head 38LA G</a:t>
+                        <a:t>Head 40LA R</a:t>
                       </a:r>
                     </a:p>
                   </a:txBody>
@@ -23718,7 +23718,7 @@
                         <a:defRPr sz="800"/>
                       </a:pPr>
                       <a:r>
-                        <a:t>Head 38LB B R</a:t>
+                        <a:t>Head 38LA R</a:t>
                       </a:r>
                     </a:p>
                   </a:txBody>
@@ -23827,7 +23827,7 @@
                         <a:defRPr sz="800"/>
                       </a:pPr>
                       <a:r>
-                        <a:t>Head 38LB T G</a:t>
+                        <a:t>Head 40LB T G</a:t>
                       </a:r>
                     </a:p>
                   </a:txBody>
@@ -23877,7 +23877,7 @@
                         <a:defRPr sz="800"/>
                       </a:pPr>
                       <a:r>
-                        <a:t>Head 38LB T Y</a:t>
+                        <a:t>Head 40LB T Y</a:t>
                       </a:r>
                     </a:p>
                   </a:txBody>
@@ -23927,7 +23927,7 @@
                         <a:defRPr sz="800"/>
                       </a:pPr>
                       <a:r>
-                        <a:t>Head 38LB T R</a:t>
+                        <a:t>Head 40LB T R</a:t>
                       </a:r>
                     </a:p>
                   </a:txBody>
@@ -23977,6 +23977,156 @@
                         <a:defRPr sz="800"/>
                       </a:pPr>
                       <a:r>
+                        <a:t>Head 40LB B G</a:t>
+                      </a:r>
+                    </a:p>
+                  </a:txBody>
+                  <a:tcPr anchor="t"/>
+                </a:tc>
+              </a:tr>
+              <a:tr h="172720">
+                <a:tc>
+                  <a:txBody>
+                    <a:bodyPr/>
+                    <a:lstStyle/>
+                    <a:p>
+                      <a:pPr>
+                        <a:lnSpc>
+                          <a:spcPct val="90000"/>
+                        </a:lnSpc>
+                        <a:spcBef>
+                          <a:spcPts val="0"/>
+                        </a:spcBef>
+                        <a:spcAft>
+                          <a:spcPts val="0"/>
+                        </a:spcAft>
+                        <a:defRPr sz="800"/>
+                      </a:pPr>
+                      <a:r>
+                        <a:t>C1-OU3-5</a:t>
+                      </a:r>
+                    </a:p>
+                  </a:txBody>
+                  <a:tcPr anchor="t"/>
+                </a:tc>
+                <a:tc>
+                  <a:txBody>
+                    <a:bodyPr/>
+                    <a:lstStyle/>
+                    <a:p>
+                      <a:pPr>
+                        <a:lnSpc>
+                          <a:spcPct val="90000"/>
+                        </a:lnSpc>
+                        <a:spcBef>
+                          <a:spcPts val="0"/>
+                        </a:spcBef>
+                        <a:spcAft>
+                          <a:spcPts val="0"/>
+                        </a:spcAft>
+                        <a:defRPr sz="800"/>
+                      </a:pPr>
+                      <a:r>
+                        <a:t>Head 40LB B Y</a:t>
+                      </a:r>
+                    </a:p>
+                  </a:txBody>
+                  <a:tcPr anchor="t"/>
+                </a:tc>
+              </a:tr>
+              <a:tr h="172720">
+                <a:tc>
+                  <a:txBody>
+                    <a:bodyPr/>
+                    <a:lstStyle/>
+                    <a:p>
+                      <a:pPr>
+                        <a:lnSpc>
+                          <a:spcPct val="90000"/>
+                        </a:lnSpc>
+                        <a:spcBef>
+                          <a:spcPts val="0"/>
+                        </a:spcBef>
+                        <a:spcAft>
+                          <a:spcPts val="0"/>
+                        </a:spcAft>
+                        <a:defRPr sz="800"/>
+                      </a:pPr>
+                      <a:r>
+                        <a:t>C1-OU3-6</a:t>
+                      </a:r>
+                    </a:p>
+                  </a:txBody>
+                  <a:tcPr anchor="t"/>
+                </a:tc>
+                <a:tc>
+                  <a:txBody>
+                    <a:bodyPr/>
+                    <a:lstStyle/>
+                    <a:p>
+                      <a:pPr>
+                        <a:lnSpc>
+                          <a:spcPct val="90000"/>
+                        </a:lnSpc>
+                        <a:spcBef>
+                          <a:spcPts val="0"/>
+                        </a:spcBef>
+                        <a:spcAft>
+                          <a:spcPts val="0"/>
+                        </a:spcAft>
+                        <a:defRPr sz="800"/>
+                      </a:pPr>
+                      <a:r>
+                        <a:t>Head 40LB B R</a:t>
+                      </a:r>
+                    </a:p>
+                  </a:txBody>
+                  <a:tcPr anchor="t"/>
+                </a:tc>
+              </a:tr>
+              <a:tr h="172720">
+                <a:tc>
+                  <a:txBody>
+                    <a:bodyPr/>
+                    <a:lstStyle/>
+                    <a:p>
+                      <a:pPr>
+                        <a:lnSpc>
+                          <a:spcPct val="90000"/>
+                        </a:lnSpc>
+                        <a:spcBef>
+                          <a:spcPts val="0"/>
+                        </a:spcBef>
+                        <a:spcAft>
+                          <a:spcPts val="0"/>
+                        </a:spcAft>
+                        <a:defRPr sz="800"/>
+                      </a:pPr>
+                      <a:r>
+                        <a:t>C1-OU3-7</a:t>
+                      </a:r>
+                    </a:p>
+                  </a:txBody>
+                  <a:tcPr anchor="t"/>
+                </a:tc>
+                <a:tc>
+                  <a:txBody>
+                    <a:bodyPr/>
+                    <a:lstStyle/>
+                    <a:p>
+                      <a:pPr>
+                        <a:lnSpc>
+                          <a:spcPct val="90000"/>
+                        </a:lnSpc>
+                        <a:spcBef>
+                          <a:spcPts val="0"/>
+                        </a:spcBef>
+                        <a:spcAft>
+                          <a:spcPts val="0"/>
+                        </a:spcAft>
+                        <a:defRPr sz="800"/>
+                      </a:pPr>
+                      <a:r>
                         <a:t>Head 40LA G</a:t>
                       </a:r>
                     </a:p>
@@ -24003,7 +24153,7 @@
                         <a:defRPr sz="800"/>
                       </a:pPr>
                       <a:r>
-                        <a:t>C1-OU3-5</a:t>
+                        <a:t>C1-OU3-8</a:t>
                       </a:r>
                     </a:p>
                   </a:txBody>
@@ -24028,156 +24178,6 @@
                       </a:pPr>
                       <a:r>
                         <a:t>Head 40LA Y</a:t>
-                      </a:r>
-                    </a:p>
-                  </a:txBody>
-                  <a:tcPr anchor="t"/>
-                </a:tc>
-              </a:tr>
-              <a:tr h="172720">
-                <a:tc>
-                  <a:txBody>
-                    <a:bodyPr/>
-                    <a:lstStyle/>
-                    <a:p>
-                      <a:pPr>
-                        <a:lnSpc>
-                          <a:spcPct val="90000"/>
-                        </a:lnSpc>
-                        <a:spcBef>
-                          <a:spcPts val="0"/>
-                        </a:spcBef>
-                        <a:spcAft>
-                          <a:spcPts val="0"/>
-                        </a:spcAft>
-                        <a:defRPr sz="800"/>
-                      </a:pPr>
-                      <a:r>
-                        <a:t>C1-OU3-6</a:t>
-                      </a:r>
-                    </a:p>
-                  </a:txBody>
-                  <a:tcPr anchor="t"/>
-                </a:tc>
-                <a:tc>
-                  <a:txBody>
-                    <a:bodyPr/>
-                    <a:lstStyle/>
-                    <a:p>
-                      <a:pPr>
-                        <a:lnSpc>
-                          <a:spcPct val="90000"/>
-                        </a:lnSpc>
-                        <a:spcBef>
-                          <a:spcPts val="0"/>
-                        </a:spcBef>
-                        <a:spcAft>
-                          <a:spcPts val="0"/>
-                        </a:spcAft>
-                        <a:defRPr sz="800"/>
-                      </a:pPr>
-                      <a:r>
-                        <a:t>Head 40LA R</a:t>
-                      </a:r>
-                    </a:p>
-                  </a:txBody>
-                  <a:tcPr anchor="t"/>
-                </a:tc>
-              </a:tr>
-              <a:tr h="172720">
-                <a:tc>
-                  <a:txBody>
-                    <a:bodyPr/>
-                    <a:lstStyle/>
-                    <a:p>
-                      <a:pPr>
-                        <a:lnSpc>
-                          <a:spcPct val="90000"/>
-                        </a:lnSpc>
-                        <a:spcBef>
-                          <a:spcPts val="0"/>
-                        </a:spcBef>
-                        <a:spcAft>
-                          <a:spcPts val="0"/>
-                        </a:spcAft>
-                        <a:defRPr sz="800"/>
-                      </a:pPr>
-                      <a:r>
-                        <a:t>C1-OU3-7</a:t>
-                      </a:r>
-                    </a:p>
-                  </a:txBody>
-                  <a:tcPr anchor="t"/>
-                </a:tc>
-                <a:tc>
-                  <a:txBody>
-                    <a:bodyPr/>
-                    <a:lstStyle/>
-                    <a:p>
-                      <a:pPr>
-                        <a:lnSpc>
-                          <a:spcPct val="90000"/>
-                        </a:lnSpc>
-                        <a:spcBef>
-                          <a:spcPts val="0"/>
-                        </a:spcBef>
-                        <a:spcAft>
-                          <a:spcPts val="0"/>
-                        </a:spcAft>
-                        <a:defRPr sz="800"/>
-                      </a:pPr>
-                      <a:r>
-                        <a:t>Head 38LA Y</a:t>
-                      </a:r>
-                    </a:p>
-                  </a:txBody>
-                  <a:tcPr anchor="t"/>
-                </a:tc>
-              </a:tr>
-              <a:tr h="172720">
-                <a:tc>
-                  <a:txBody>
-                    <a:bodyPr/>
-                    <a:lstStyle/>
-                    <a:p>
-                      <a:pPr>
-                        <a:lnSpc>
-                          <a:spcPct val="90000"/>
-                        </a:lnSpc>
-                        <a:spcBef>
-                          <a:spcPts val="0"/>
-                        </a:spcBef>
-                        <a:spcAft>
-                          <a:spcPts val="0"/>
-                        </a:spcAft>
-                        <a:defRPr sz="800"/>
-                      </a:pPr>
-                      <a:r>
-                        <a:t>C1-OU3-8</a:t>
-                      </a:r>
-                    </a:p>
-                  </a:txBody>
-                  <a:tcPr anchor="t"/>
-                </a:tc>
-                <a:tc>
-                  <a:txBody>
-                    <a:bodyPr/>
-                    <a:lstStyle/>
-                    <a:p>
-                      <a:pPr>
-                        <a:lnSpc>
-                          <a:spcPct val="90000"/>
-                        </a:lnSpc>
-                        <a:spcBef>
-                          <a:spcPts val="0"/>
-                        </a:spcBef>
-                        <a:spcAft>
-                          <a:spcPts val="0"/>
-                        </a:spcAft>
-                        <a:defRPr sz="800"/>
-                      </a:pPr>
-                      <a:r>
-                        <a:t>Head 38LA R</a:t>
                       </a:r>
                     </a:p>
                   </a:txBody>
@@ -25841,7 +25841,7 @@
                         <a:defRPr sz="800"/>
                       </a:pPr>
                       <a:r>
-                        <a:t>Head 24L T G</a:t>
+                        <a:t>Head 24RA B G</a:t>
                       </a:r>
                     </a:p>
                   </a:txBody>
@@ -25891,7 +25891,7 @@
                         <a:defRPr sz="800"/>
                       </a:pPr>
                       <a:r>
-                        <a:t>Head 24L T Y</a:t>
+                        <a:t>Head 24RA B Y</a:t>
                       </a:r>
                     </a:p>
                   </a:txBody>
@@ -25941,7 +25941,7 @@
                         <a:defRPr sz="800"/>
                       </a:pPr>
                       <a:r>
-                        <a:t>Head 24L T R</a:t>
+                        <a:t>Head 24RA B R</a:t>
                       </a:r>
                     </a:p>
                   </a:txBody>
@@ -26150,307 +26150,307 @@
                         <a:defRPr sz="800"/>
                       </a:pPr>
                       <a:r>
+                        <a:t>Head 24L T G</a:t>
+                      </a:r>
+                    </a:p>
+                  </a:txBody>
+                  <a:tcPr anchor="t"/>
+                </a:tc>
+              </a:tr>
+              <a:tr h="172720">
+                <a:tc>
+                  <a:txBody>
+                    <a:bodyPr/>
+                    <a:lstStyle/>
+                    <a:p>
+                      <a:pPr>
+                        <a:lnSpc>
+                          <a:spcPct val="90000"/>
+                        </a:lnSpc>
+                        <a:spcBef>
+                          <a:spcPts val="0"/>
+                        </a:spcBef>
+                        <a:spcAft>
+                          <a:spcPts val="0"/>
+                        </a:spcAft>
+                        <a:defRPr sz="800"/>
+                      </a:pPr>
+                      <a:r>
+                        <a:t>C2-OU2-2</a:t>
+                      </a:r>
+                    </a:p>
+                  </a:txBody>
+                  <a:tcPr anchor="t"/>
+                </a:tc>
+                <a:tc>
+                  <a:txBody>
+                    <a:bodyPr/>
+                    <a:lstStyle/>
+                    <a:p>
+                      <a:pPr>
+                        <a:lnSpc>
+                          <a:spcPct val="90000"/>
+                        </a:lnSpc>
+                        <a:spcBef>
+                          <a:spcPts val="0"/>
+                        </a:spcBef>
+                        <a:spcAft>
+                          <a:spcPts val="0"/>
+                        </a:spcAft>
+                        <a:defRPr sz="800"/>
+                      </a:pPr>
+                      <a:r>
+                        <a:t>Head 24L T Y</a:t>
+                      </a:r>
+                    </a:p>
+                  </a:txBody>
+                  <a:tcPr anchor="t"/>
+                </a:tc>
+              </a:tr>
+              <a:tr h="172720">
+                <a:tc>
+                  <a:txBody>
+                    <a:bodyPr/>
+                    <a:lstStyle/>
+                    <a:p>
+                      <a:pPr>
+                        <a:lnSpc>
+                          <a:spcPct val="90000"/>
+                        </a:lnSpc>
+                        <a:spcBef>
+                          <a:spcPts val="0"/>
+                        </a:spcBef>
+                        <a:spcAft>
+                          <a:spcPts val="0"/>
+                        </a:spcAft>
+                        <a:defRPr sz="800"/>
+                      </a:pPr>
+                      <a:r>
+                        <a:t>C2-OU2-3</a:t>
+                      </a:r>
+                    </a:p>
+                  </a:txBody>
+                  <a:tcPr anchor="t"/>
+                </a:tc>
+                <a:tc>
+                  <a:txBody>
+                    <a:bodyPr/>
+                    <a:lstStyle/>
+                    <a:p>
+                      <a:pPr>
+                        <a:lnSpc>
+                          <a:spcPct val="90000"/>
+                        </a:lnSpc>
+                        <a:spcBef>
+                          <a:spcPts val="0"/>
+                        </a:spcBef>
+                        <a:spcAft>
+                          <a:spcPts val="0"/>
+                        </a:spcAft>
+                        <a:defRPr sz="800"/>
+                      </a:pPr>
+                      <a:r>
+                        <a:t>Head 24L T R</a:t>
+                      </a:r>
+                    </a:p>
+                  </a:txBody>
+                  <a:tcPr anchor="t"/>
+                </a:tc>
+              </a:tr>
+              <a:tr h="172720">
+                <a:tc>
+                  <a:txBody>
+                    <a:bodyPr/>
+                    <a:lstStyle/>
+                    <a:p>
+                      <a:pPr>
+                        <a:lnSpc>
+                          <a:spcPct val="90000"/>
+                        </a:lnSpc>
+                        <a:spcBef>
+                          <a:spcPts val="0"/>
+                        </a:spcBef>
+                        <a:spcAft>
+                          <a:spcPts val="0"/>
+                        </a:spcAft>
+                        <a:defRPr sz="800"/>
+                      </a:pPr>
+                      <a:r>
+                        <a:t>C2-OU2-4</a:t>
+                      </a:r>
+                    </a:p>
+                  </a:txBody>
+                  <a:tcPr anchor="t"/>
+                </a:tc>
+                <a:tc>
+                  <a:txBody>
+                    <a:bodyPr/>
+                    <a:lstStyle/>
+                    <a:p>
+                      <a:pPr>
+                        <a:lnSpc>
+                          <a:spcPct val="90000"/>
+                        </a:lnSpc>
+                        <a:spcBef>
+                          <a:spcPts val="0"/>
+                        </a:spcBef>
+                        <a:spcAft>
+                          <a:spcPts val="0"/>
+                        </a:spcAft>
+                        <a:defRPr sz="800"/>
+                      </a:pPr>
+                      <a:r>
+                        <a:t>Head 24L B G</a:t>
+                      </a:r>
+                    </a:p>
+                  </a:txBody>
+                  <a:tcPr anchor="t"/>
+                </a:tc>
+              </a:tr>
+              <a:tr h="172720">
+                <a:tc>
+                  <a:txBody>
+                    <a:bodyPr/>
+                    <a:lstStyle/>
+                    <a:p>
+                      <a:pPr>
+                        <a:lnSpc>
+                          <a:spcPct val="90000"/>
+                        </a:lnSpc>
+                        <a:spcBef>
+                          <a:spcPts val="0"/>
+                        </a:spcBef>
+                        <a:spcAft>
+                          <a:spcPts val="0"/>
+                        </a:spcAft>
+                        <a:defRPr sz="800"/>
+                      </a:pPr>
+                      <a:r>
+                        <a:t>C2-OU2-5</a:t>
+                      </a:r>
+                    </a:p>
+                  </a:txBody>
+                  <a:tcPr anchor="t"/>
+                </a:tc>
+                <a:tc>
+                  <a:txBody>
+                    <a:bodyPr/>
+                    <a:lstStyle/>
+                    <a:p>
+                      <a:pPr>
+                        <a:lnSpc>
+                          <a:spcPct val="90000"/>
+                        </a:lnSpc>
+                        <a:spcBef>
+                          <a:spcPts val="0"/>
+                        </a:spcBef>
+                        <a:spcAft>
+                          <a:spcPts val="0"/>
+                        </a:spcAft>
+                        <a:defRPr sz="800"/>
+                      </a:pPr>
+                      <a:r>
+                        <a:t>Head 24L B Y</a:t>
+                      </a:r>
+                    </a:p>
+                  </a:txBody>
+                  <a:tcPr anchor="t"/>
+                </a:tc>
+              </a:tr>
+              <a:tr h="172720">
+                <a:tc>
+                  <a:txBody>
+                    <a:bodyPr/>
+                    <a:lstStyle/>
+                    <a:p>
+                      <a:pPr>
+                        <a:lnSpc>
+                          <a:spcPct val="90000"/>
+                        </a:lnSpc>
+                        <a:spcBef>
+                          <a:spcPts val="0"/>
+                        </a:spcBef>
+                        <a:spcAft>
+                          <a:spcPts val="0"/>
+                        </a:spcAft>
+                        <a:defRPr sz="800"/>
+                      </a:pPr>
+                      <a:r>
+                        <a:t>C2-OU2-6</a:t>
+                      </a:r>
+                    </a:p>
+                  </a:txBody>
+                  <a:tcPr anchor="t"/>
+                </a:tc>
+                <a:tc>
+                  <a:txBody>
+                    <a:bodyPr/>
+                    <a:lstStyle/>
+                    <a:p>
+                      <a:pPr>
+                        <a:lnSpc>
+                          <a:spcPct val="90000"/>
+                        </a:lnSpc>
+                        <a:spcBef>
+                          <a:spcPts val="0"/>
+                        </a:spcBef>
+                        <a:spcAft>
+                          <a:spcPts val="0"/>
+                        </a:spcAft>
+                        <a:defRPr sz="800"/>
+                      </a:pPr>
+                      <a:r>
+                        <a:t>Head 24L B R</a:t>
+                      </a:r>
+                    </a:p>
+                  </a:txBody>
+                  <a:tcPr anchor="t"/>
+                </a:tc>
+              </a:tr>
+              <a:tr h="172720">
+                <a:tc>
+                  <a:txBody>
+                    <a:bodyPr/>
+                    <a:lstStyle/>
+                    <a:p>
+                      <a:pPr>
+                        <a:lnSpc>
+                          <a:spcPct val="90000"/>
+                        </a:lnSpc>
+                        <a:spcBef>
+                          <a:spcPts val="0"/>
+                        </a:spcBef>
+                        <a:spcAft>
+                          <a:spcPts val="0"/>
+                        </a:spcAft>
+                        <a:defRPr sz="800"/>
+                      </a:pPr>
+                      <a:r>
+                        <a:t>C2-OU2-7</a:t>
+                      </a:r>
+                    </a:p>
+                  </a:txBody>
+                  <a:tcPr anchor="t"/>
+                </a:tc>
+                <a:tc>
+                  <a:txBody>
+                    <a:bodyPr/>
+                    <a:lstStyle/>
+                    <a:p>
+                      <a:pPr>
+                        <a:lnSpc>
+                          <a:spcPct val="90000"/>
+                        </a:lnSpc>
+                        <a:spcBef>
+                          <a:spcPts val="0"/>
+                        </a:spcBef>
+                        <a:spcAft>
+                          <a:spcPts val="0"/>
+                        </a:spcAft>
+                        <a:defRPr sz="800"/>
+                      </a:pPr>
+                      <a:r>
                         <a:t>Head 24RB R</a:t>
-                      </a:r>
-                    </a:p>
-                  </a:txBody>
-                  <a:tcPr anchor="t"/>
-                </a:tc>
-              </a:tr>
-              <a:tr h="172720">
-                <a:tc>
-                  <a:txBody>
-                    <a:bodyPr/>
-                    <a:lstStyle/>
-                    <a:p>
-                      <a:pPr>
-                        <a:lnSpc>
-                          <a:spcPct val="90000"/>
-                        </a:lnSpc>
-                        <a:spcBef>
-                          <a:spcPts val="0"/>
-                        </a:spcBef>
-                        <a:spcAft>
-                          <a:spcPts val="0"/>
-                        </a:spcAft>
-                        <a:defRPr sz="800"/>
-                      </a:pPr>
-                      <a:r>
-                        <a:t>C2-OU2-2</a:t>
-                      </a:r>
-                    </a:p>
-                  </a:txBody>
-                  <a:tcPr anchor="t"/>
-                </a:tc>
-                <a:tc>
-                  <a:txBody>
-                    <a:bodyPr/>
-                    <a:lstStyle/>
-                    <a:p>
-                      <a:pPr>
-                        <a:lnSpc>
-                          <a:spcPct val="90000"/>
-                        </a:lnSpc>
-                        <a:spcBef>
-                          <a:spcPts val="0"/>
-                        </a:spcBef>
-                        <a:spcAft>
-                          <a:spcPts val="0"/>
-                        </a:spcAft>
-                        <a:defRPr sz="800"/>
-                      </a:pPr>
-                      <a:r>
-                        <a:t>Head 34L T G</a:t>
-                      </a:r>
-                    </a:p>
-                  </a:txBody>
-                  <a:tcPr anchor="t"/>
-                </a:tc>
-              </a:tr>
-              <a:tr h="172720">
-                <a:tc>
-                  <a:txBody>
-                    <a:bodyPr/>
-                    <a:lstStyle/>
-                    <a:p>
-                      <a:pPr>
-                        <a:lnSpc>
-                          <a:spcPct val="90000"/>
-                        </a:lnSpc>
-                        <a:spcBef>
-                          <a:spcPts val="0"/>
-                        </a:spcBef>
-                        <a:spcAft>
-                          <a:spcPts val="0"/>
-                        </a:spcAft>
-                        <a:defRPr sz="800"/>
-                      </a:pPr>
-                      <a:r>
-                        <a:t>C2-OU2-3</a:t>
-                      </a:r>
-                    </a:p>
-                  </a:txBody>
-                  <a:tcPr anchor="t"/>
-                </a:tc>
-                <a:tc>
-                  <a:txBody>
-                    <a:bodyPr/>
-                    <a:lstStyle/>
-                    <a:p>
-                      <a:pPr>
-                        <a:lnSpc>
-                          <a:spcPct val="90000"/>
-                        </a:lnSpc>
-                        <a:spcBef>
-                          <a:spcPts val="0"/>
-                        </a:spcBef>
-                        <a:spcAft>
-                          <a:spcPts val="0"/>
-                        </a:spcAft>
-                        <a:defRPr sz="800"/>
-                      </a:pPr>
-                      <a:r>
-                        <a:t>Head 34L T Y</a:t>
-                      </a:r>
-                    </a:p>
-                  </a:txBody>
-                  <a:tcPr anchor="t"/>
-                </a:tc>
-              </a:tr>
-              <a:tr h="172720">
-                <a:tc>
-                  <a:txBody>
-                    <a:bodyPr/>
-                    <a:lstStyle/>
-                    <a:p>
-                      <a:pPr>
-                        <a:lnSpc>
-                          <a:spcPct val="90000"/>
-                        </a:lnSpc>
-                        <a:spcBef>
-                          <a:spcPts val="0"/>
-                        </a:spcBef>
-                        <a:spcAft>
-                          <a:spcPts val="0"/>
-                        </a:spcAft>
-                        <a:defRPr sz="800"/>
-                      </a:pPr>
-                      <a:r>
-                        <a:t>C2-OU2-4</a:t>
-                      </a:r>
-                    </a:p>
-                  </a:txBody>
-                  <a:tcPr anchor="t"/>
-                </a:tc>
-                <a:tc>
-                  <a:txBody>
-                    <a:bodyPr/>
-                    <a:lstStyle/>
-                    <a:p>
-                      <a:pPr>
-                        <a:lnSpc>
-                          <a:spcPct val="90000"/>
-                        </a:lnSpc>
-                        <a:spcBef>
-                          <a:spcPts val="0"/>
-                        </a:spcBef>
-                        <a:spcAft>
-                          <a:spcPts val="0"/>
-                        </a:spcAft>
-                        <a:defRPr sz="800"/>
-                      </a:pPr>
-                      <a:r>
-                        <a:t>Head 34L T R</a:t>
-                      </a:r>
-                    </a:p>
-                  </a:txBody>
-                  <a:tcPr anchor="t"/>
-                </a:tc>
-              </a:tr>
-              <a:tr h="172720">
-                <a:tc>
-                  <a:txBody>
-                    <a:bodyPr/>
-                    <a:lstStyle/>
-                    <a:p>
-                      <a:pPr>
-                        <a:lnSpc>
-                          <a:spcPct val="90000"/>
-                        </a:lnSpc>
-                        <a:spcBef>
-                          <a:spcPts val="0"/>
-                        </a:spcBef>
-                        <a:spcAft>
-                          <a:spcPts val="0"/>
-                        </a:spcAft>
-                        <a:defRPr sz="800"/>
-                      </a:pPr>
-                      <a:r>
-                        <a:t>C2-OU2-5</a:t>
-                      </a:r>
-                    </a:p>
-                  </a:txBody>
-                  <a:tcPr anchor="t"/>
-                </a:tc>
-                <a:tc>
-                  <a:txBody>
-                    <a:bodyPr/>
-                    <a:lstStyle/>
-                    <a:p>
-                      <a:pPr>
-                        <a:lnSpc>
-                          <a:spcPct val="90000"/>
-                        </a:lnSpc>
-                        <a:spcBef>
-                          <a:spcPts val="0"/>
-                        </a:spcBef>
-                        <a:spcAft>
-                          <a:spcPts val="0"/>
-                        </a:spcAft>
-                        <a:defRPr sz="800"/>
-                      </a:pPr>
-                      <a:r>
-                        <a:t>Head 32R G</a:t>
-                      </a:r>
-                    </a:p>
-                  </a:txBody>
-                  <a:tcPr anchor="t"/>
-                </a:tc>
-              </a:tr>
-              <a:tr h="172720">
-                <a:tc>
-                  <a:txBody>
-                    <a:bodyPr/>
-                    <a:lstStyle/>
-                    <a:p>
-                      <a:pPr>
-                        <a:lnSpc>
-                          <a:spcPct val="90000"/>
-                        </a:lnSpc>
-                        <a:spcBef>
-                          <a:spcPts val="0"/>
-                        </a:spcBef>
-                        <a:spcAft>
-                          <a:spcPts val="0"/>
-                        </a:spcAft>
-                        <a:defRPr sz="800"/>
-                      </a:pPr>
-                      <a:r>
-                        <a:t>C2-OU2-6</a:t>
-                      </a:r>
-                    </a:p>
-                  </a:txBody>
-                  <a:tcPr anchor="t"/>
-                </a:tc>
-                <a:tc>
-                  <a:txBody>
-                    <a:bodyPr/>
-                    <a:lstStyle/>
-                    <a:p>
-                      <a:pPr>
-                        <a:lnSpc>
-                          <a:spcPct val="90000"/>
-                        </a:lnSpc>
-                        <a:spcBef>
-                          <a:spcPts val="0"/>
-                        </a:spcBef>
-                        <a:spcAft>
-                          <a:spcPts val="0"/>
-                        </a:spcAft>
-                        <a:defRPr sz="800"/>
-                      </a:pPr>
-                      <a:r>
-                        <a:t>Head 32R Y</a:t>
-                      </a:r>
-                    </a:p>
-                  </a:txBody>
-                  <a:tcPr anchor="t"/>
-                </a:tc>
-              </a:tr>
-              <a:tr h="172720">
-                <a:tc>
-                  <a:txBody>
-                    <a:bodyPr/>
-                    <a:lstStyle/>
-                    <a:p>
-                      <a:pPr>
-                        <a:lnSpc>
-                          <a:spcPct val="90000"/>
-                        </a:lnSpc>
-                        <a:spcBef>
-                          <a:spcPts val="0"/>
-                        </a:spcBef>
-                        <a:spcAft>
-                          <a:spcPts val="0"/>
-                        </a:spcAft>
-                        <a:defRPr sz="800"/>
-                      </a:pPr>
-                      <a:r>
-                        <a:t>C2-OU2-7</a:t>
-                      </a:r>
-                    </a:p>
-                  </a:txBody>
-                  <a:tcPr anchor="t"/>
-                </a:tc>
-                <a:tc>
-                  <a:txBody>
-                    <a:bodyPr/>
-                    <a:lstStyle/>
-                    <a:p>
-                      <a:pPr>
-                        <a:lnSpc>
-                          <a:spcPct val="90000"/>
-                        </a:lnSpc>
-                        <a:spcBef>
-                          <a:spcPts val="0"/>
-                        </a:spcBef>
-                        <a:spcAft>
-                          <a:spcPts val="0"/>
-                        </a:spcAft>
-                        <a:defRPr sz="800"/>
-                      </a:pPr>
-                      <a:r>
-                        <a:t>Head 32R R</a:t>
                       </a:r>
                     </a:p>
                   </a:txBody>
@@ -26609,7 +26609,7 @@
                         <a:defRPr sz="800"/>
                       </a:pPr>
                       <a:r>
-                        <a:t>Head 34R T G</a:t>
+                        <a:t>Head 34L T G</a:t>
                       </a:r>
                     </a:p>
                   </a:txBody>
@@ -26659,7 +26659,7 @@
                         <a:defRPr sz="800"/>
                       </a:pPr>
                       <a:r>
-                        <a:t>Head 34R T Y</a:t>
+                        <a:t>Head 34L T Y</a:t>
                       </a:r>
                     </a:p>
                   </a:txBody>
@@ -26709,7 +26709,7 @@
                         <a:defRPr sz="800"/>
                       </a:pPr>
                       <a:r>
-                        <a:t>Head 34R T R</a:t>
+                        <a:t>Head 34L T R</a:t>
                       </a:r>
                     </a:p>
                   </a:txBody>
@@ -26759,7 +26759,7 @@
                         <a:defRPr sz="800"/>
                       </a:pPr>
                       <a:r>
-                        <a:t>Head 34R B G</a:t>
+                        <a:t>Head 34L B G</a:t>
                       </a:r>
                     </a:p>
                   </a:txBody>
@@ -26809,7 +26809,7 @@
                         <a:defRPr sz="800"/>
                       </a:pPr>
                       <a:r>
-                        <a:t>Head 34R B Y</a:t>
+                        <a:t>Head 34L B Y</a:t>
                       </a:r>
                     </a:p>
                   </a:txBody>
@@ -26859,7 +26859,7 @@
                         <a:defRPr sz="800"/>
                       </a:pPr>
                       <a:r>
-                        <a:t>Head 34R B R</a:t>
+                        <a:t>Head 34L B R</a:t>
                       </a:r>
                     </a:p>
                   </a:txBody>
@@ -26909,7 +26909,7 @@
                         <a:defRPr sz="800"/>
                       </a:pPr>
                       <a:r>
-                        <a:t>Head 34L B R</a:t>
+                        <a:t>Head 32R G</a:t>
                       </a:r>
                     </a:p>
                   </a:txBody>
@@ -26958,6 +26958,9 @@
                         </a:spcAft>
                         <a:defRPr sz="800"/>
                       </a:pPr>
+                      <a:r>
+                        <a:t>Head 32R Y</a:t>
+                      </a:r>
                     </a:p>
                   </a:txBody>
                   <a:tcPr anchor="t"/>
@@ -29088,6 +29091,156 @@
                         <a:defRPr sz="800"/>
                       </a:pPr>
                       <a:r>
+                        <a:t>Head 6LB B G</a:t>
+                      </a:r>
+                    </a:p>
+                  </a:txBody>
+                  <a:tcPr anchor="t"/>
+                </a:tc>
+              </a:tr>
+              <a:tr h="172720">
+                <a:tc>
+                  <a:txBody>
+                    <a:bodyPr/>
+                    <a:lstStyle/>
+                    <a:p>
+                      <a:pPr>
+                        <a:lnSpc>
+                          <a:spcPct val="90000"/>
+                        </a:lnSpc>
+                        <a:spcBef>
+                          <a:spcPts val="0"/>
+                        </a:spcBef>
+                        <a:spcAft>
+                          <a:spcPts val="0"/>
+                        </a:spcAft>
+                        <a:defRPr sz="800"/>
+                      </a:pPr>
+                      <a:r>
+                        <a:t>C3-OU2-5</a:t>
+                      </a:r>
+                    </a:p>
+                  </a:txBody>
+                  <a:tcPr anchor="t"/>
+                </a:tc>
+                <a:tc>
+                  <a:txBody>
+                    <a:bodyPr/>
+                    <a:lstStyle/>
+                    <a:p>
+                      <a:pPr>
+                        <a:lnSpc>
+                          <a:spcPct val="90000"/>
+                        </a:lnSpc>
+                        <a:spcBef>
+                          <a:spcPts val="0"/>
+                        </a:spcBef>
+                        <a:spcAft>
+                          <a:spcPts val="0"/>
+                        </a:spcAft>
+                        <a:defRPr sz="800"/>
+                      </a:pPr>
+                      <a:r>
+                        <a:t>Head 6LB B Y</a:t>
+                      </a:r>
+                    </a:p>
+                  </a:txBody>
+                  <a:tcPr anchor="t"/>
+                </a:tc>
+              </a:tr>
+              <a:tr h="172720">
+                <a:tc>
+                  <a:txBody>
+                    <a:bodyPr/>
+                    <a:lstStyle/>
+                    <a:p>
+                      <a:pPr>
+                        <a:lnSpc>
+                          <a:spcPct val="90000"/>
+                        </a:lnSpc>
+                        <a:spcBef>
+                          <a:spcPts val="0"/>
+                        </a:spcBef>
+                        <a:spcAft>
+                          <a:spcPts val="0"/>
+                        </a:spcAft>
+                        <a:defRPr sz="800"/>
+                      </a:pPr>
+                      <a:r>
+                        <a:t>C3-OU2-6</a:t>
+                      </a:r>
+                    </a:p>
+                  </a:txBody>
+                  <a:tcPr anchor="t"/>
+                </a:tc>
+                <a:tc>
+                  <a:txBody>
+                    <a:bodyPr/>
+                    <a:lstStyle/>
+                    <a:p>
+                      <a:pPr>
+                        <a:lnSpc>
+                          <a:spcPct val="90000"/>
+                        </a:lnSpc>
+                        <a:spcBef>
+                          <a:spcPts val="0"/>
+                        </a:spcBef>
+                        <a:spcAft>
+                          <a:spcPts val="0"/>
+                        </a:spcAft>
+                        <a:defRPr sz="800"/>
+                      </a:pPr>
+                      <a:r>
+                        <a:t>Head 6LB B R</a:t>
+                      </a:r>
+                    </a:p>
+                  </a:txBody>
+                  <a:tcPr anchor="t"/>
+                </a:tc>
+              </a:tr>
+              <a:tr h="172720">
+                <a:tc>
+                  <a:txBody>
+                    <a:bodyPr/>
+                    <a:lstStyle/>
+                    <a:p>
+                      <a:pPr>
+                        <a:lnSpc>
+                          <a:spcPct val="90000"/>
+                        </a:lnSpc>
+                        <a:spcBef>
+                          <a:spcPts val="0"/>
+                        </a:spcBef>
+                        <a:spcAft>
+                          <a:spcPts val="0"/>
+                        </a:spcAft>
+                        <a:defRPr sz="800"/>
+                      </a:pPr>
+                      <a:r>
+                        <a:t>C3-OU2-7</a:t>
+                      </a:r>
+                    </a:p>
+                  </a:txBody>
+                  <a:tcPr anchor="t"/>
+                </a:tc>
+                <a:tc>
+                  <a:txBody>
+                    <a:bodyPr/>
+                    <a:lstStyle/>
+                    <a:p>
+                      <a:pPr>
+                        <a:lnSpc>
+                          <a:spcPct val="90000"/>
+                        </a:lnSpc>
+                        <a:spcBef>
+                          <a:spcPts val="0"/>
+                        </a:spcBef>
+                        <a:spcAft>
+                          <a:spcPts val="0"/>
+                        </a:spcAft>
+                        <a:defRPr sz="800"/>
+                      </a:pPr>
+                      <a:r>
                         <a:t>Head 6LA G</a:t>
                       </a:r>
                     </a:p>
@@ -29114,7 +29267,7 @@
                         <a:defRPr sz="800"/>
                       </a:pPr>
                       <a:r>
-                        <a:t>C3-OU2-5</a:t>
+                        <a:t>C3-OU2-8</a:t>
                       </a:r>
                     </a:p>
                   </a:txBody>
@@ -29139,156 +29292,6 @@
                       </a:pPr>
                       <a:r>
                         <a:t>Head 6LA Y</a:t>
-                      </a:r>
-                    </a:p>
-                  </a:txBody>
-                  <a:tcPr anchor="t"/>
-                </a:tc>
-              </a:tr>
-              <a:tr h="172720">
-                <a:tc>
-                  <a:txBody>
-                    <a:bodyPr/>
-                    <a:lstStyle/>
-                    <a:p>
-                      <a:pPr>
-                        <a:lnSpc>
-                          <a:spcPct val="90000"/>
-                        </a:lnSpc>
-                        <a:spcBef>
-                          <a:spcPts val="0"/>
-                        </a:spcBef>
-                        <a:spcAft>
-                          <a:spcPts val="0"/>
-                        </a:spcAft>
-                        <a:defRPr sz="800"/>
-                      </a:pPr>
-                      <a:r>
-                        <a:t>C3-OU2-6</a:t>
-                      </a:r>
-                    </a:p>
-                  </a:txBody>
-                  <a:tcPr anchor="t"/>
-                </a:tc>
-                <a:tc>
-                  <a:txBody>
-                    <a:bodyPr/>
-                    <a:lstStyle/>
-                    <a:p>
-                      <a:pPr>
-                        <a:lnSpc>
-                          <a:spcPct val="90000"/>
-                        </a:lnSpc>
-                        <a:spcBef>
-                          <a:spcPts val="0"/>
-                        </a:spcBef>
-                        <a:spcAft>
-                          <a:spcPts val="0"/>
-                        </a:spcAft>
-                        <a:defRPr sz="800"/>
-                      </a:pPr>
-                      <a:r>
-                        <a:t>Head 6LA R</a:t>
-                      </a:r>
-                    </a:p>
-                  </a:txBody>
-                  <a:tcPr anchor="t"/>
-                </a:tc>
-              </a:tr>
-              <a:tr h="172720">
-                <a:tc>
-                  <a:txBody>
-                    <a:bodyPr/>
-                    <a:lstStyle/>
-                    <a:p>
-                      <a:pPr>
-                        <a:lnSpc>
-                          <a:spcPct val="90000"/>
-                        </a:lnSpc>
-                        <a:spcBef>
-                          <a:spcPts val="0"/>
-                        </a:spcBef>
-                        <a:spcAft>
-                          <a:spcPts val="0"/>
-                        </a:spcAft>
-                        <a:defRPr sz="800"/>
-                      </a:pPr>
-                      <a:r>
-                        <a:t>C3-OU2-7</a:t>
-                      </a:r>
-                    </a:p>
-                  </a:txBody>
-                  <a:tcPr anchor="t"/>
-                </a:tc>
-                <a:tc>
-                  <a:txBody>
-                    <a:bodyPr/>
-                    <a:lstStyle/>
-                    <a:p>
-                      <a:pPr>
-                        <a:lnSpc>
-                          <a:spcPct val="90000"/>
-                        </a:lnSpc>
-                        <a:spcBef>
-                          <a:spcPts val="0"/>
-                        </a:spcBef>
-                        <a:spcAft>
-                          <a:spcPts val="0"/>
-                        </a:spcAft>
-                        <a:defRPr sz="800"/>
-                      </a:pPr>
-                      <a:r>
-                        <a:t>Head 4RB Y</a:t>
-                      </a:r>
-                    </a:p>
-                  </a:txBody>
-                  <a:tcPr anchor="t"/>
-                </a:tc>
-              </a:tr>
-              <a:tr h="172720">
-                <a:tc>
-                  <a:txBody>
-                    <a:bodyPr/>
-                    <a:lstStyle/>
-                    <a:p>
-                      <a:pPr>
-                        <a:lnSpc>
-                          <a:spcPct val="90000"/>
-                        </a:lnSpc>
-                        <a:spcBef>
-                          <a:spcPts val="0"/>
-                        </a:spcBef>
-                        <a:spcAft>
-                          <a:spcPts val="0"/>
-                        </a:spcAft>
-                        <a:defRPr sz="800"/>
-                      </a:pPr>
-                      <a:r>
-                        <a:t>C3-OU2-8</a:t>
-                      </a:r>
-                    </a:p>
-                  </a:txBody>
-                  <a:tcPr anchor="t"/>
-                </a:tc>
-                <a:tc>
-                  <a:txBody>
-                    <a:bodyPr/>
-                    <a:lstStyle/>
-                    <a:p>
-                      <a:pPr>
-                        <a:lnSpc>
-                          <a:spcPct val="90000"/>
-                        </a:lnSpc>
-                        <a:spcBef>
-                          <a:spcPts val="0"/>
-                        </a:spcBef>
-                        <a:spcAft>
-                          <a:spcPts val="0"/>
-                        </a:spcAft>
-                        <a:defRPr sz="800"/>
-                      </a:pPr>
-                      <a:r>
-                        <a:t>C3 RELAY 1</a:t>
                       </a:r>
                     </a:p>
                   </a:txBody>
@@ -29547,7 +29550,7 @@
                         <a:defRPr sz="800"/>
                       </a:pPr>
                       <a:r>
-                        <a:t>Head 4RA G</a:t>
+                        <a:t>Head 2L B G</a:t>
                       </a:r>
                     </a:p>
                   </a:txBody>
@@ -29597,7 +29600,7 @@
                         <a:defRPr sz="800"/>
                       </a:pPr>
                       <a:r>
-                        <a:t>Head 4RA Y</a:t>
+                        <a:t>Head 2L B Y</a:t>
                       </a:r>
                     </a:p>
                   </a:txBody>
@@ -29647,7 +29650,7 @@
                         <a:defRPr sz="800"/>
                       </a:pPr>
                       <a:r>
-                        <a:t>Head 4RA R</a:t>
+                        <a:t>Head 2L B R</a:t>
                       </a:r>
                     </a:p>
                   </a:txBody>
@@ -29697,7 +29700,7 @@
                         <a:defRPr sz="800"/>
                       </a:pPr>
                       <a:r>
-                        <a:t>Head 4RB G</a:t>
+                        <a:t>Head 6LA R</a:t>
                       </a:r>
                     </a:p>
                   </a:txBody>
@@ -29747,7 +29750,7 @@
                         <a:defRPr sz="800"/>
                       </a:pPr>
                       <a:r>
-                        <a:t>Head 4RB R</a:t>
+                        <a:t>S3-11 R</a:t>
                       </a:r>
                     </a:p>
                   </a:txBody>
@@ -34555,6 +34558,56 @@
                         <a:defRPr sz="800"/>
                       </a:pPr>
                       <a:r>
+                        <a:t>Head 36RB T Y</a:t>
+                      </a:r>
+                    </a:p>
+                  </a:txBody>
+                  <a:tcPr anchor="t"/>
+                </a:tc>
+              </a:tr>
+              <a:tr h="172720">
+                <a:tc>
+                  <a:txBody>
+                    <a:bodyPr/>
+                    <a:lstStyle/>
+                    <a:p>
+                      <a:pPr>
+                        <a:lnSpc>
+                          <a:spcPct val="90000"/>
+                        </a:lnSpc>
+                        <a:spcBef>
+                          <a:spcPts val="0"/>
+                        </a:spcBef>
+                        <a:spcAft>
+                          <a:spcPts val="0"/>
+                        </a:spcAft>
+                        <a:defRPr sz="800"/>
+                      </a:pPr>
+                      <a:r>
+                        <a:t>C11-OU2-3</a:t>
+                      </a:r>
+                    </a:p>
+                  </a:txBody>
+                  <a:tcPr anchor="t"/>
+                </a:tc>
+                <a:tc>
+                  <a:txBody>
+                    <a:bodyPr/>
+                    <a:lstStyle/>
+                    <a:p>
+                      <a:pPr>
+                        <a:lnSpc>
+                          <a:spcPct val="90000"/>
+                        </a:lnSpc>
+                        <a:spcBef>
+                          <a:spcPts val="0"/>
+                        </a:spcBef>
+                        <a:spcAft>
+                          <a:spcPts val="0"/>
+                        </a:spcAft>
+                        <a:defRPr sz="800"/>
+                      </a:pPr>
+                      <a:r>
                         <a:t>Head 36RB T R</a:t>
                       </a:r>
                     </a:p>
@@ -34581,56 +34634,6 @@
                         <a:defRPr sz="800"/>
                       </a:pPr>
                       <a:r>
-                        <a:t>C11-OU2-3</a:t>
-                      </a:r>
-                    </a:p>
-                  </a:txBody>
-                  <a:tcPr anchor="t"/>
-                </a:tc>
-                <a:tc>
-                  <a:txBody>
-                    <a:bodyPr/>
-                    <a:lstStyle/>
-                    <a:p>
-                      <a:pPr>
-                        <a:lnSpc>
-                          <a:spcPct val="90000"/>
-                        </a:lnSpc>
-                        <a:spcBef>
-                          <a:spcPts val="0"/>
-                        </a:spcBef>
-                        <a:spcAft>
-                          <a:spcPts val="0"/>
-                        </a:spcAft>
-                        <a:defRPr sz="800"/>
-                      </a:pPr>
-                      <a:r>
-                        <a:t>Head 36RB T Y</a:t>
-                      </a:r>
-                    </a:p>
-                  </a:txBody>
-                  <a:tcPr anchor="t"/>
-                </a:tc>
-              </a:tr>
-              <a:tr h="172720">
-                <a:tc>
-                  <a:txBody>
-                    <a:bodyPr/>
-                    <a:lstStyle/>
-                    <a:p>
-                      <a:pPr>
-                        <a:lnSpc>
-                          <a:spcPct val="90000"/>
-                        </a:lnSpc>
-                        <a:spcBef>
-                          <a:spcPts val="0"/>
-                        </a:spcBef>
-                        <a:spcAft>
-                          <a:spcPts val="0"/>
-                        </a:spcAft>
-                        <a:defRPr sz="800"/>
-                      </a:pPr>
-                      <a:r>
                         <a:t>C11-OU2-4</a:t>
                       </a:r>
                     </a:p>
@@ -34655,7 +34658,7 @@
                         <a:defRPr sz="800"/>
                       </a:pPr>
                       <a:r>
-                        <a:t>Head 2036 G</a:t>
+                        <a:t>Head 36RB B G</a:t>
                       </a:r>
                     </a:p>
                   </a:txBody>
@@ -34705,7 +34708,7 @@
                         <a:defRPr sz="800"/>
                       </a:pPr>
                       <a:r>
-                        <a:t>Head 2036 R</a:t>
+                        <a:t>Head 36RB B Y</a:t>
                       </a:r>
                     </a:p>
                   </a:txBody>
@@ -34755,7 +34758,7 @@
                         <a:defRPr sz="800"/>
                       </a:pPr>
                       <a:r>
-                        <a:t>Head 2036 Y</a:t>
+                        <a:t>Head 36RB B R</a:t>
                       </a:r>
                     </a:p>
                   </a:txBody>
@@ -34961,6 +34964,156 @@
                         <a:defRPr sz="800"/>
                       </a:pPr>
                       <a:r>
+                        <a:t>Head 2036 G</a:t>
+                      </a:r>
+                    </a:p>
+                  </a:txBody>
+                  <a:tcPr anchor="t"/>
+                </a:tc>
+              </a:tr>
+              <a:tr h="172720">
+                <a:tc>
+                  <a:txBody>
+                    <a:bodyPr/>
+                    <a:lstStyle/>
+                    <a:p>
+                      <a:pPr>
+                        <a:lnSpc>
+                          <a:spcPct val="90000"/>
+                        </a:lnSpc>
+                        <a:spcBef>
+                          <a:spcPts val="0"/>
+                        </a:spcBef>
+                        <a:spcAft>
+                          <a:spcPts val="0"/>
+                        </a:spcAft>
+                        <a:defRPr sz="800"/>
+                      </a:pPr>
+                      <a:r>
+                        <a:t>C11-OU3-2</a:t>
+                      </a:r>
+                    </a:p>
+                  </a:txBody>
+                  <a:tcPr anchor="t"/>
+                </a:tc>
+                <a:tc>
+                  <a:txBody>
+                    <a:bodyPr/>
+                    <a:lstStyle/>
+                    <a:p>
+                      <a:pPr>
+                        <a:lnSpc>
+                          <a:spcPct val="90000"/>
+                        </a:lnSpc>
+                        <a:spcBef>
+                          <a:spcPts val="0"/>
+                        </a:spcBef>
+                        <a:spcAft>
+                          <a:spcPts val="0"/>
+                        </a:spcAft>
+                        <a:defRPr sz="800"/>
+                      </a:pPr>
+                      <a:r>
+                        <a:t>Head 2036 Y</a:t>
+                      </a:r>
+                    </a:p>
+                  </a:txBody>
+                  <a:tcPr anchor="t"/>
+                </a:tc>
+              </a:tr>
+              <a:tr h="172720">
+                <a:tc>
+                  <a:txBody>
+                    <a:bodyPr/>
+                    <a:lstStyle/>
+                    <a:p>
+                      <a:pPr>
+                        <a:lnSpc>
+                          <a:spcPct val="90000"/>
+                        </a:lnSpc>
+                        <a:spcBef>
+                          <a:spcPts val="0"/>
+                        </a:spcBef>
+                        <a:spcAft>
+                          <a:spcPts val="0"/>
+                        </a:spcAft>
+                        <a:defRPr sz="800"/>
+                      </a:pPr>
+                      <a:r>
+                        <a:t>C11-OU3-3</a:t>
+                      </a:r>
+                    </a:p>
+                  </a:txBody>
+                  <a:tcPr anchor="t"/>
+                </a:tc>
+                <a:tc>
+                  <a:txBody>
+                    <a:bodyPr/>
+                    <a:lstStyle/>
+                    <a:p>
+                      <a:pPr>
+                        <a:lnSpc>
+                          <a:spcPct val="90000"/>
+                        </a:lnSpc>
+                        <a:spcBef>
+                          <a:spcPts val="0"/>
+                        </a:spcBef>
+                        <a:spcAft>
+                          <a:spcPts val="0"/>
+                        </a:spcAft>
+                        <a:defRPr sz="800"/>
+                      </a:pPr>
+                      <a:r>
+                        <a:t>Head 2036 R</a:t>
+                      </a:r>
+                    </a:p>
+                  </a:txBody>
+                  <a:tcPr anchor="t"/>
+                </a:tc>
+              </a:tr>
+              <a:tr h="172720">
+                <a:tc>
+                  <a:txBody>
+                    <a:bodyPr/>
+                    <a:lstStyle/>
+                    <a:p>
+                      <a:pPr>
+                        <a:lnSpc>
+                          <a:spcPct val="90000"/>
+                        </a:lnSpc>
+                        <a:spcBef>
+                          <a:spcPts val="0"/>
+                        </a:spcBef>
+                        <a:spcAft>
+                          <a:spcPts val="0"/>
+                        </a:spcAft>
+                        <a:defRPr sz="800"/>
+                      </a:pPr>
+                      <a:r>
+                        <a:t>C11-OU3-4</a:t>
+                      </a:r>
+                    </a:p>
+                  </a:txBody>
+                  <a:tcPr anchor="t"/>
+                </a:tc>
+                <a:tc>
+                  <a:txBody>
+                    <a:bodyPr/>
+                    <a:lstStyle/>
+                    <a:p>
+                      <a:pPr>
+                        <a:lnSpc>
+                          <a:spcPct val="90000"/>
+                        </a:lnSpc>
+                        <a:spcBef>
+                          <a:spcPts val="0"/>
+                        </a:spcBef>
+                        <a:spcAft>
+                          <a:spcPts val="0"/>
+                        </a:spcAft>
+                        <a:defRPr sz="800"/>
+                      </a:pPr>
+                      <a:r>
                         <a:t>Head 2035 G</a:t>
                       </a:r>
                     </a:p>
@@ -34987,7 +35140,57 @@
                         <a:defRPr sz="800"/>
                       </a:pPr>
                       <a:r>
-                        <a:t>C11-OU3-2</a:t>
+                        <a:t>C11-OU3-5</a:t>
+                      </a:r>
+                    </a:p>
+                  </a:txBody>
+                  <a:tcPr anchor="t"/>
+                </a:tc>
+                <a:tc>
+                  <a:txBody>
+                    <a:bodyPr/>
+                    <a:lstStyle/>
+                    <a:p>
+                      <a:pPr>
+                        <a:lnSpc>
+                          <a:spcPct val="90000"/>
+                        </a:lnSpc>
+                        <a:spcBef>
+                          <a:spcPts val="0"/>
+                        </a:spcBef>
+                        <a:spcAft>
+                          <a:spcPts val="0"/>
+                        </a:spcAft>
+                        <a:defRPr sz="800"/>
+                      </a:pPr>
+                      <a:r>
+                        <a:t>Head 2035 Y</a:t>
+                      </a:r>
+                    </a:p>
+                  </a:txBody>
+                  <a:tcPr anchor="t"/>
+                </a:tc>
+              </a:tr>
+              <a:tr h="172720">
+                <a:tc>
+                  <a:txBody>
+                    <a:bodyPr/>
+                    <a:lstStyle/>
+                    <a:p>
+                      <a:pPr>
+                        <a:lnSpc>
+                          <a:spcPct val="90000"/>
+                        </a:lnSpc>
+                        <a:spcBef>
+                          <a:spcPts val="0"/>
+                        </a:spcBef>
+                        <a:spcAft>
+                          <a:spcPts val="0"/>
+                        </a:spcAft>
+                        <a:defRPr sz="800"/>
+                      </a:pPr>
+                      <a:r>
+                        <a:t>C11-OU3-6</a:t>
                       </a:r>
                     </a:p>
                   </a:txBody>
@@ -35012,206 +35215,6 @@
                       </a:pPr>
                       <a:r>
                         <a:t>Head 2035 R</a:t>
-                      </a:r>
-                    </a:p>
-                  </a:txBody>
-                  <a:tcPr anchor="t"/>
-                </a:tc>
-              </a:tr>
-              <a:tr h="172720">
-                <a:tc>
-                  <a:txBody>
-                    <a:bodyPr/>
-                    <a:lstStyle/>
-                    <a:p>
-                      <a:pPr>
-                        <a:lnSpc>
-                          <a:spcPct val="90000"/>
-                        </a:lnSpc>
-                        <a:spcBef>
-                          <a:spcPts val="0"/>
-                        </a:spcBef>
-                        <a:spcAft>
-                          <a:spcPts val="0"/>
-                        </a:spcAft>
-                        <a:defRPr sz="800"/>
-                      </a:pPr>
-                      <a:r>
-                        <a:t>C11-OU3-3</a:t>
-                      </a:r>
-                    </a:p>
-                  </a:txBody>
-                  <a:tcPr anchor="t"/>
-                </a:tc>
-                <a:tc>
-                  <a:txBody>
-                    <a:bodyPr/>
-                    <a:lstStyle/>
-                    <a:p>
-                      <a:pPr>
-                        <a:lnSpc>
-                          <a:spcPct val="90000"/>
-                        </a:lnSpc>
-                        <a:spcBef>
-                          <a:spcPts val="0"/>
-                        </a:spcBef>
-                        <a:spcAft>
-                          <a:spcPts val="0"/>
-                        </a:spcAft>
-                        <a:defRPr sz="800"/>
-                      </a:pPr>
-                      <a:r>
-                        <a:t>Head 2035 Y</a:t>
-                      </a:r>
-                    </a:p>
-                  </a:txBody>
-                  <a:tcPr anchor="t"/>
-                </a:tc>
-              </a:tr>
-              <a:tr h="172720">
-                <a:tc>
-                  <a:txBody>
-                    <a:bodyPr/>
-                    <a:lstStyle/>
-                    <a:p>
-                      <a:pPr>
-                        <a:lnSpc>
-                          <a:spcPct val="90000"/>
-                        </a:lnSpc>
-                        <a:spcBef>
-                          <a:spcPts val="0"/>
-                        </a:spcBef>
-                        <a:spcAft>
-                          <a:spcPts val="0"/>
-                        </a:spcAft>
-                        <a:defRPr sz="800"/>
-                      </a:pPr>
-                      <a:r>
-                        <a:t>C11-OU3-4</a:t>
-                      </a:r>
-                    </a:p>
-                  </a:txBody>
-                  <a:tcPr anchor="t"/>
-                </a:tc>
-                <a:tc>
-                  <a:txBody>
-                    <a:bodyPr/>
-                    <a:lstStyle/>
-                    <a:p>
-                      <a:pPr>
-                        <a:lnSpc>
-                          <a:spcPct val="90000"/>
-                        </a:lnSpc>
-                        <a:spcBef>
-                          <a:spcPts val="0"/>
-                        </a:spcBef>
-                        <a:spcAft>
-                          <a:spcPts val="0"/>
-                        </a:spcAft>
-                        <a:defRPr sz="800"/>
-                      </a:pPr>
-                      <a:r>
-                        <a:t>Head 36RB B G</a:t>
-                      </a:r>
-                    </a:p>
-                  </a:txBody>
-                  <a:tcPr anchor="t"/>
-                </a:tc>
-              </a:tr>
-              <a:tr h="172720">
-                <a:tc>
-                  <a:txBody>
-                    <a:bodyPr/>
-                    <a:lstStyle/>
-                    <a:p>
-                      <a:pPr>
-                        <a:lnSpc>
-                          <a:spcPct val="90000"/>
-                        </a:lnSpc>
-                        <a:spcBef>
-                          <a:spcPts val="0"/>
-                        </a:spcBef>
-                        <a:spcAft>
-                          <a:spcPts val="0"/>
-                        </a:spcAft>
-                        <a:defRPr sz="800"/>
-                      </a:pPr>
-                      <a:r>
-                        <a:t>C11-OU3-5</a:t>
-                      </a:r>
-                    </a:p>
-                  </a:txBody>
-                  <a:tcPr anchor="t"/>
-                </a:tc>
-                <a:tc>
-                  <a:txBody>
-                    <a:bodyPr/>
-                    <a:lstStyle/>
-                    <a:p>
-                      <a:pPr>
-                        <a:lnSpc>
-                          <a:spcPct val="90000"/>
-                        </a:lnSpc>
-                        <a:spcBef>
-                          <a:spcPts val="0"/>
-                        </a:spcBef>
-                        <a:spcAft>
-                          <a:spcPts val="0"/>
-                        </a:spcAft>
-                        <a:defRPr sz="800"/>
-                      </a:pPr>
-                      <a:r>
-                        <a:t>Head 36RB B Y</a:t>
-                      </a:r>
-                    </a:p>
-                  </a:txBody>
-                  <a:tcPr anchor="t"/>
-                </a:tc>
-              </a:tr>
-              <a:tr h="172720">
-                <a:tc>
-                  <a:txBody>
-                    <a:bodyPr/>
-                    <a:lstStyle/>
-                    <a:p>
-                      <a:pPr>
-                        <a:lnSpc>
-                          <a:spcPct val="90000"/>
-                        </a:lnSpc>
-                        <a:spcBef>
-                          <a:spcPts val="0"/>
-                        </a:spcBef>
-                        <a:spcAft>
-                          <a:spcPts val="0"/>
-                        </a:spcAft>
-                        <a:defRPr sz="800"/>
-                      </a:pPr>
-                      <a:r>
-                        <a:t>C11-OU3-6</a:t>
-                      </a:r>
-                    </a:p>
-                  </a:txBody>
-                  <a:tcPr anchor="t"/>
-                </a:tc>
-                <a:tc>
-                  <a:txBody>
-                    <a:bodyPr/>
-                    <a:lstStyle/>
-                    <a:p>
-                      <a:pPr>
-                        <a:lnSpc>
-                          <a:spcPct val="90000"/>
-                        </a:lnSpc>
-                        <a:spcBef>
-                          <a:spcPts val="0"/>
-                        </a:spcBef>
-                        <a:spcAft>
-                          <a:spcPts val="0"/>
-                        </a:spcAft>
-                        <a:defRPr sz="800"/>
-                      </a:pPr>
-                      <a:r>
-                        <a:t>Head 36RB B R</a:t>
                       </a:r>
                     </a:p>
                   </a:txBody>
@@ -38657,7 +38660,7 @@
                         <a:defRPr sz="800"/>
                       </a:pPr>
                       <a:r>
-                        <a:t>Head 8RB T G</a:t>
+                        <a:t>Head 8RA B G</a:t>
                       </a:r>
                     </a:p>
                   </a:txBody>
@@ -38707,7 +38710,7 @@
                         <a:defRPr sz="800"/>
                       </a:pPr>
                       <a:r>
-                        <a:t>Head 8RB T R</a:t>
+                        <a:t>Head 8RA B Y</a:t>
                       </a:r>
                     </a:p>
                   </a:txBody>
@@ -38757,7 +38760,7 @@
                         <a:defRPr sz="800"/>
                       </a:pPr>
                       <a:r>
-                        <a:t>Head 8RB T Y</a:t>
+                        <a:t>Head 8RA B R</a:t>
                       </a:r>
                     </a:p>
                   </a:txBody>
@@ -38966,6 +38969,306 @@
                         <a:defRPr sz="800"/>
                       </a:pPr>
                       <a:r>
+                        <a:t>Head 8LA T G</a:t>
+                      </a:r>
+                    </a:p>
+                  </a:txBody>
+                  <a:tcPr anchor="t"/>
+                </a:tc>
+              </a:tr>
+              <a:tr h="172720">
+                <a:tc>
+                  <a:txBody>
+                    <a:bodyPr/>
+                    <a:lstStyle/>
+                    <a:p>
+                      <a:pPr>
+                        <a:lnSpc>
+                          <a:spcPct val="90000"/>
+                        </a:lnSpc>
+                        <a:spcBef>
+                          <a:spcPts val="0"/>
+                        </a:spcBef>
+                        <a:spcAft>
+                          <a:spcPts val="0"/>
+                        </a:spcAft>
+                        <a:defRPr sz="800"/>
+                      </a:pPr>
+                      <a:r>
+                        <a:t>C13-OU2-2</a:t>
+                      </a:r>
+                    </a:p>
+                  </a:txBody>
+                  <a:tcPr anchor="t"/>
+                </a:tc>
+                <a:tc>
+                  <a:txBody>
+                    <a:bodyPr/>
+                    <a:lstStyle/>
+                    <a:p>
+                      <a:pPr>
+                        <a:lnSpc>
+                          <a:spcPct val="90000"/>
+                        </a:lnSpc>
+                        <a:spcBef>
+                          <a:spcPts val="0"/>
+                        </a:spcBef>
+                        <a:spcAft>
+                          <a:spcPts val="0"/>
+                        </a:spcAft>
+                        <a:defRPr sz="800"/>
+                      </a:pPr>
+                      <a:r>
+                        <a:t>Head 8LA T Y</a:t>
+                      </a:r>
+                    </a:p>
+                  </a:txBody>
+                  <a:tcPr anchor="t"/>
+                </a:tc>
+              </a:tr>
+              <a:tr h="172720">
+                <a:tc>
+                  <a:txBody>
+                    <a:bodyPr/>
+                    <a:lstStyle/>
+                    <a:p>
+                      <a:pPr>
+                        <a:lnSpc>
+                          <a:spcPct val="90000"/>
+                        </a:lnSpc>
+                        <a:spcBef>
+                          <a:spcPts val="0"/>
+                        </a:spcBef>
+                        <a:spcAft>
+                          <a:spcPts val="0"/>
+                        </a:spcAft>
+                        <a:defRPr sz="800"/>
+                      </a:pPr>
+                      <a:r>
+                        <a:t>C13-OU2-3</a:t>
+                      </a:r>
+                    </a:p>
+                  </a:txBody>
+                  <a:tcPr anchor="t"/>
+                </a:tc>
+                <a:tc>
+                  <a:txBody>
+                    <a:bodyPr/>
+                    <a:lstStyle/>
+                    <a:p>
+                      <a:pPr>
+                        <a:lnSpc>
+                          <a:spcPct val="90000"/>
+                        </a:lnSpc>
+                        <a:spcBef>
+                          <a:spcPts val="0"/>
+                        </a:spcBef>
+                        <a:spcAft>
+                          <a:spcPts val="0"/>
+                        </a:spcAft>
+                        <a:defRPr sz="800"/>
+                      </a:pPr>
+                      <a:r>
+                        <a:t>Head 8LA T R</a:t>
+                      </a:r>
+                    </a:p>
+                  </a:txBody>
+                  <a:tcPr anchor="t"/>
+                </a:tc>
+              </a:tr>
+              <a:tr h="172720">
+                <a:tc>
+                  <a:txBody>
+                    <a:bodyPr/>
+                    <a:lstStyle/>
+                    <a:p>
+                      <a:pPr>
+                        <a:lnSpc>
+                          <a:spcPct val="90000"/>
+                        </a:lnSpc>
+                        <a:spcBef>
+                          <a:spcPts val="0"/>
+                        </a:spcBef>
+                        <a:spcAft>
+                          <a:spcPts val="0"/>
+                        </a:spcAft>
+                        <a:defRPr sz="800"/>
+                      </a:pPr>
+                      <a:r>
+                        <a:t>C13-OU2-4</a:t>
+                      </a:r>
+                    </a:p>
+                  </a:txBody>
+                  <a:tcPr anchor="t"/>
+                </a:tc>
+                <a:tc>
+                  <a:txBody>
+                    <a:bodyPr/>
+                    <a:lstStyle/>
+                    <a:p>
+                      <a:pPr>
+                        <a:lnSpc>
+                          <a:spcPct val="90000"/>
+                        </a:lnSpc>
+                        <a:spcBef>
+                          <a:spcPts val="0"/>
+                        </a:spcBef>
+                        <a:spcAft>
+                          <a:spcPts val="0"/>
+                        </a:spcAft>
+                        <a:defRPr sz="800"/>
+                      </a:pPr>
+                      <a:r>
+                        <a:t>Head 8LA B G</a:t>
+                      </a:r>
+                    </a:p>
+                  </a:txBody>
+                  <a:tcPr anchor="t"/>
+                </a:tc>
+              </a:tr>
+              <a:tr h="172720">
+                <a:tc>
+                  <a:txBody>
+                    <a:bodyPr/>
+                    <a:lstStyle/>
+                    <a:p>
+                      <a:pPr>
+                        <a:lnSpc>
+                          <a:spcPct val="90000"/>
+                        </a:lnSpc>
+                        <a:spcBef>
+                          <a:spcPts val="0"/>
+                        </a:spcBef>
+                        <a:spcAft>
+                          <a:spcPts val="0"/>
+                        </a:spcAft>
+                        <a:defRPr sz="800"/>
+                      </a:pPr>
+                      <a:r>
+                        <a:t>C13-OU2-5</a:t>
+                      </a:r>
+                    </a:p>
+                  </a:txBody>
+                  <a:tcPr anchor="t"/>
+                </a:tc>
+                <a:tc>
+                  <a:txBody>
+                    <a:bodyPr/>
+                    <a:lstStyle/>
+                    <a:p>
+                      <a:pPr>
+                        <a:lnSpc>
+                          <a:spcPct val="90000"/>
+                        </a:lnSpc>
+                        <a:spcBef>
+                          <a:spcPts val="0"/>
+                        </a:spcBef>
+                        <a:spcAft>
+                          <a:spcPts val="0"/>
+                        </a:spcAft>
+                        <a:defRPr sz="800"/>
+                      </a:pPr>
+                      <a:r>
+                        <a:t>Head 8LA B Y</a:t>
+                      </a:r>
+                    </a:p>
+                  </a:txBody>
+                  <a:tcPr anchor="t"/>
+                </a:tc>
+              </a:tr>
+              <a:tr h="172720">
+                <a:tc>
+                  <a:txBody>
+                    <a:bodyPr/>
+                    <a:lstStyle/>
+                    <a:p>
+                      <a:pPr>
+                        <a:lnSpc>
+                          <a:spcPct val="90000"/>
+                        </a:lnSpc>
+                        <a:spcBef>
+                          <a:spcPts val="0"/>
+                        </a:spcBef>
+                        <a:spcAft>
+                          <a:spcPts val="0"/>
+                        </a:spcAft>
+                        <a:defRPr sz="800"/>
+                      </a:pPr>
+                      <a:r>
+                        <a:t>C13-OU2-6</a:t>
+                      </a:r>
+                    </a:p>
+                  </a:txBody>
+                  <a:tcPr anchor="t"/>
+                </a:tc>
+                <a:tc>
+                  <a:txBody>
+                    <a:bodyPr/>
+                    <a:lstStyle/>
+                    <a:p>
+                      <a:pPr>
+                        <a:lnSpc>
+                          <a:spcPct val="90000"/>
+                        </a:lnSpc>
+                        <a:spcBef>
+                          <a:spcPts val="0"/>
+                        </a:spcBef>
+                        <a:spcAft>
+                          <a:spcPts val="0"/>
+                        </a:spcAft>
+                        <a:defRPr sz="800"/>
+                      </a:pPr>
+                      <a:r>
+                        <a:t>Head 8LA B R</a:t>
+                      </a:r>
+                    </a:p>
+                  </a:txBody>
+                  <a:tcPr anchor="t"/>
+                </a:tc>
+              </a:tr>
+              <a:tr h="172720">
+                <a:tc>
+                  <a:txBody>
+                    <a:bodyPr/>
+                    <a:lstStyle/>
+                    <a:p>
+                      <a:pPr>
+                        <a:lnSpc>
+                          <a:spcPct val="90000"/>
+                        </a:lnSpc>
+                        <a:spcBef>
+                          <a:spcPts val="0"/>
+                        </a:spcBef>
+                        <a:spcAft>
+                          <a:spcPts val="0"/>
+                        </a:spcAft>
+                        <a:defRPr sz="800"/>
+                      </a:pPr>
+                      <a:r>
+                        <a:t>C13-OU2-7</a:t>
+                      </a:r>
+                    </a:p>
+                  </a:txBody>
+                  <a:tcPr anchor="t"/>
+                </a:tc>
+                <a:tc>
+                  <a:txBody>
+                    <a:bodyPr/>
+                    <a:lstStyle/>
+                    <a:p>
+                      <a:pPr>
+                        <a:lnSpc>
+                          <a:spcPct val="90000"/>
+                        </a:lnSpc>
+                        <a:spcBef>
+                          <a:spcPts val="0"/>
+                        </a:spcBef>
+                        <a:spcAft>
+                          <a:spcPts val="0"/>
+                        </a:spcAft>
+                        <a:defRPr sz="800"/>
+                      </a:pPr>
+                      <a:r>
                         <a:t>Head 8LB G</a:t>
                       </a:r>
                     </a:p>
@@ -38992,7 +39295,7 @@
                         <a:defRPr sz="800"/>
                       </a:pPr>
                       <a:r>
-                        <a:t>C13-OU2-2</a:t>
+                        <a:t>C13-OU2-8</a:t>
                       </a:r>
                     </a:p>
                   </a:txBody>
@@ -39017,306 +39320,6 @@
                       </a:pPr>
                       <a:r>
                         <a:t>Head 8LB Y</a:t>
-                      </a:r>
-                    </a:p>
-                  </a:txBody>
-                  <a:tcPr anchor="t"/>
-                </a:tc>
-              </a:tr>
-              <a:tr h="172720">
-                <a:tc>
-                  <a:txBody>
-                    <a:bodyPr/>
-                    <a:lstStyle/>
-                    <a:p>
-                      <a:pPr>
-                        <a:lnSpc>
-                          <a:spcPct val="90000"/>
-                        </a:lnSpc>
-                        <a:spcBef>
-                          <a:spcPts val="0"/>
-                        </a:spcBef>
-                        <a:spcAft>
-                          <a:spcPts val="0"/>
-                        </a:spcAft>
-                        <a:defRPr sz="800"/>
-                      </a:pPr>
-                      <a:r>
-                        <a:t>C13-OU2-3</a:t>
-                      </a:r>
-                    </a:p>
-                  </a:txBody>
-                  <a:tcPr anchor="t"/>
-                </a:tc>
-                <a:tc>
-                  <a:txBody>
-                    <a:bodyPr/>
-                    <a:lstStyle/>
-                    <a:p>
-                      <a:pPr>
-                        <a:lnSpc>
-                          <a:spcPct val="90000"/>
-                        </a:lnSpc>
-                        <a:spcBef>
-                          <a:spcPts val="0"/>
-                        </a:spcBef>
-                        <a:spcAft>
-                          <a:spcPts val="0"/>
-                        </a:spcAft>
-                        <a:defRPr sz="800"/>
-                      </a:pPr>
-                      <a:r>
-                        <a:t>Head 8LB R</a:t>
-                      </a:r>
-                    </a:p>
-                  </a:txBody>
-                  <a:tcPr anchor="t"/>
-                </a:tc>
-              </a:tr>
-              <a:tr h="172720">
-                <a:tc>
-                  <a:txBody>
-                    <a:bodyPr/>
-                    <a:lstStyle/>
-                    <a:p>
-                      <a:pPr>
-                        <a:lnSpc>
-                          <a:spcPct val="90000"/>
-                        </a:lnSpc>
-                        <a:spcBef>
-                          <a:spcPts val="0"/>
-                        </a:spcBef>
-                        <a:spcAft>
-                          <a:spcPts val="0"/>
-                        </a:spcAft>
-                        <a:defRPr sz="800"/>
-                      </a:pPr>
-                      <a:r>
-                        <a:t>C13-OU2-4</a:t>
-                      </a:r>
-                    </a:p>
-                  </a:txBody>
-                  <a:tcPr anchor="t"/>
-                </a:tc>
-                <a:tc>
-                  <a:txBody>
-                    <a:bodyPr/>
-                    <a:lstStyle/>
-                    <a:p>
-                      <a:pPr>
-                        <a:lnSpc>
-                          <a:spcPct val="90000"/>
-                        </a:lnSpc>
-                        <a:spcBef>
-                          <a:spcPts val="0"/>
-                        </a:spcBef>
-                        <a:spcAft>
-                          <a:spcPts val="0"/>
-                        </a:spcAft>
-                        <a:defRPr sz="800"/>
-                      </a:pPr>
-                      <a:r>
-                        <a:t>Head 8LA T G</a:t>
-                      </a:r>
-                    </a:p>
-                  </a:txBody>
-                  <a:tcPr anchor="t"/>
-                </a:tc>
-              </a:tr>
-              <a:tr h="172720">
-                <a:tc>
-                  <a:txBody>
-                    <a:bodyPr/>
-                    <a:lstStyle/>
-                    <a:p>
-                      <a:pPr>
-                        <a:lnSpc>
-                          <a:spcPct val="90000"/>
-                        </a:lnSpc>
-                        <a:spcBef>
-                          <a:spcPts val="0"/>
-                        </a:spcBef>
-                        <a:spcAft>
-                          <a:spcPts val="0"/>
-                        </a:spcAft>
-                        <a:defRPr sz="800"/>
-                      </a:pPr>
-                      <a:r>
-                        <a:t>C13-OU2-5</a:t>
-                      </a:r>
-                    </a:p>
-                  </a:txBody>
-                  <a:tcPr anchor="t"/>
-                </a:tc>
-                <a:tc>
-                  <a:txBody>
-                    <a:bodyPr/>
-                    <a:lstStyle/>
-                    <a:p>
-                      <a:pPr>
-                        <a:lnSpc>
-                          <a:spcPct val="90000"/>
-                        </a:lnSpc>
-                        <a:spcBef>
-                          <a:spcPts val="0"/>
-                        </a:spcBef>
-                        <a:spcAft>
-                          <a:spcPts val="0"/>
-                        </a:spcAft>
-                        <a:defRPr sz="800"/>
-                      </a:pPr>
-                      <a:r>
-                        <a:t>Head 8LA T Y</a:t>
-                      </a:r>
-                    </a:p>
-                  </a:txBody>
-                  <a:tcPr anchor="t"/>
-                </a:tc>
-              </a:tr>
-              <a:tr h="172720">
-                <a:tc>
-                  <a:txBody>
-                    <a:bodyPr/>
-                    <a:lstStyle/>
-                    <a:p>
-                      <a:pPr>
-                        <a:lnSpc>
-                          <a:spcPct val="90000"/>
-                        </a:lnSpc>
-                        <a:spcBef>
-                          <a:spcPts val="0"/>
-                        </a:spcBef>
-                        <a:spcAft>
-                          <a:spcPts val="0"/>
-                        </a:spcAft>
-                        <a:defRPr sz="800"/>
-                      </a:pPr>
-                      <a:r>
-                        <a:t>C13-OU2-6</a:t>
-                      </a:r>
-                    </a:p>
-                  </a:txBody>
-                  <a:tcPr anchor="t"/>
-                </a:tc>
-                <a:tc>
-                  <a:txBody>
-                    <a:bodyPr/>
-                    <a:lstStyle/>
-                    <a:p>
-                      <a:pPr>
-                        <a:lnSpc>
-                          <a:spcPct val="90000"/>
-                        </a:lnSpc>
-                        <a:spcBef>
-                          <a:spcPts val="0"/>
-                        </a:spcBef>
-                        <a:spcAft>
-                          <a:spcPts val="0"/>
-                        </a:spcAft>
-                        <a:defRPr sz="800"/>
-                      </a:pPr>
-                      <a:r>
-                        <a:t>Head 8LA T R</a:t>
-                      </a:r>
-                    </a:p>
-                  </a:txBody>
-                  <a:tcPr anchor="t"/>
-                </a:tc>
-              </a:tr>
-              <a:tr h="172720">
-                <a:tc>
-                  <a:txBody>
-                    <a:bodyPr/>
-                    <a:lstStyle/>
-                    <a:p>
-                      <a:pPr>
-                        <a:lnSpc>
-                          <a:spcPct val="90000"/>
-                        </a:lnSpc>
-                        <a:spcBef>
-                          <a:spcPts val="0"/>
-                        </a:spcBef>
-                        <a:spcAft>
-                          <a:spcPts val="0"/>
-                        </a:spcAft>
-                        <a:defRPr sz="800"/>
-                      </a:pPr>
-                      <a:r>
-                        <a:t>C13-OU2-7</a:t>
-                      </a:r>
-                    </a:p>
-                  </a:txBody>
-                  <a:tcPr anchor="t"/>
-                </a:tc>
-                <a:tc>
-                  <a:txBody>
-                    <a:bodyPr/>
-                    <a:lstStyle/>
-                    <a:p>
-                      <a:pPr>
-                        <a:lnSpc>
-                          <a:spcPct val="90000"/>
-                        </a:lnSpc>
-                        <a:spcBef>
-                          <a:spcPts val="0"/>
-                        </a:spcBef>
-                        <a:spcAft>
-                          <a:spcPts val="0"/>
-                        </a:spcAft>
-                        <a:defRPr sz="800"/>
-                      </a:pPr>
-                      <a:r>
-                        <a:t>S3-14 Y</a:t>
-                      </a:r>
-                    </a:p>
-                  </a:txBody>
-                  <a:tcPr anchor="t"/>
-                </a:tc>
-              </a:tr>
-              <a:tr h="172720">
-                <a:tc>
-                  <a:txBody>
-                    <a:bodyPr/>
-                    <a:lstStyle/>
-                    <a:p>
-                      <a:pPr>
-                        <a:lnSpc>
-                          <a:spcPct val="90000"/>
-                        </a:lnSpc>
-                        <a:spcBef>
-                          <a:spcPts val="0"/>
-                        </a:spcBef>
-                        <a:spcAft>
-                          <a:spcPts val="0"/>
-                        </a:spcAft>
-                        <a:defRPr sz="800"/>
-                      </a:pPr>
-                      <a:r>
-                        <a:t>C13-OU2-8</a:t>
-                      </a:r>
-                    </a:p>
-                  </a:txBody>
-                  <a:tcPr anchor="t"/>
-                </a:tc>
-                <a:tc>
-                  <a:txBody>
-                    <a:bodyPr/>
-                    <a:lstStyle/>
-                    <a:p>
-                      <a:pPr>
-                        <a:lnSpc>
-                          <a:spcPct val="90000"/>
-                        </a:lnSpc>
-                        <a:spcBef>
-                          <a:spcPts val="0"/>
-                        </a:spcBef>
-                        <a:spcAft>
-                          <a:spcPts val="0"/>
-                        </a:spcAft>
-                        <a:defRPr sz="800"/>
-                      </a:pPr>
-                      <a:r>
-                        <a:t>Head 8LA B R</a:t>
                       </a:r>
                     </a:p>
                   </a:txBody>

</xml_diff>

<commit_message>
Put Digicon heads on the cabinet already at each plant.
C4 takes Brick+Plane, C12 takes East End 34, C2 keeps only the west 24 overflow, C11 takes Princess 40 plus the balloon, and C3 no longer carries signal pins.

Co-authored-by: Cursor <cursoragent@cursor.com>
</commit_message>
<xml_diff>
--- a/docs/wiring/Wiring_Schematic.pptx
+++ b/docs/wiring/Wiring_Schematic.pptx
@@ -3459,7 +3459,7 @@
                         <a:defRPr sz="1000"/>
                       </a:pPr>
                       <a:r>
-                        <a:t>North - Lower (East End signals)</a:t>
+                        <a:t>North - Lower (East End west 24)</a:t>
                       </a:r>
                     </a:p>
                   </a:txBody>
@@ -3516,7 +3516,7 @@
                         <a:defRPr sz="1000"/>
                       </a:pPr>
                       <a:r>
-                        <a:t>4</a:t>
+                        <a:t>3</a:t>
                       </a:r>
                     </a:p>
                   </a:txBody>
@@ -3590,7 +3590,7 @@
                         <a:defRPr sz="1000"/>
                       </a:pPr>
                       <a:r>
-                        <a:t>West - Lower (Plane / Brick)</a:t>
+                        <a:t>West - Lower (103–106 motors)</a:t>
                       </a:r>
                     </a:p>
                   </a:txBody>
@@ -3635,7 +3635,7 @@
                         <a:defRPr sz="1000"/>
                       </a:pPr>
                       <a:r>
-                        <a:t>3</a:t>
+                        <a:t>2</a:t>
                       </a:r>
                     </a:p>
                   </a:txBody>
@@ -3701,7 +3701,7 @@
                         <a:defRPr sz="1000"/>
                       </a:pPr>
                       <a:r>
-                        <a:t>Peninsula - Lower</a:t>
+                        <a:t>West - Lower (Brick / Plane)</a:t>
                       </a:r>
                     </a:p>
                   </a:txBody>
@@ -3758,7 +3758,7 @@
                         <a:defRPr sz="1000"/>
                       </a:pPr>
                       <a:r>
-                        <a:t>2</a:t>
+                        <a:t>3</a:t>
                       </a:r>
                     </a:p>
                   </a:txBody>
@@ -3832,7 +3832,7 @@
                         <a:defRPr sz="1000"/>
                       </a:pPr>
                       <a:r>
-                        <a:t>Helix (Princess overflow)</a:t>
+                        <a:t>Helix (Princess east 40 + balloon)</a:t>
                       </a:r>
                     </a:p>
                   </a:txBody>
@@ -3943,7 +3943,7 @@
                         <a:defRPr sz="1000"/>
                       </a:pPr>
                       <a:r>
-                        <a:t>North - Lower (East End turnouts 107–112)</a:t>
+                        <a:t>North - Lower (East End 34 + turnouts 107–112)</a:t>
                       </a:r>
                     </a:p>
                   </a:txBody>
@@ -23668,7 +23668,7 @@
                         <a:defRPr sz="800"/>
                       </a:pPr>
                       <a:r>
-                        <a:t>Head 40LA R</a:t>
+                        <a:t>Head 38LA R</a:t>
                       </a:r>
                     </a:p>
                   </a:txBody>
@@ -23718,7 +23718,7 @@
                         <a:defRPr sz="800"/>
                       </a:pPr>
                       <a:r>
-                        <a:t>Head 38LA R</a:t>
+                        <a:t>C1 RELAY 1</a:t>
                       </a:r>
                     </a:p>
                   </a:txBody>
@@ -23827,7 +23827,7 @@
                         <a:defRPr sz="800"/>
                       </a:pPr>
                       <a:r>
-                        <a:t>Head 40LB T G</a:t>
+                        <a:t>Head 36RB T G</a:t>
                       </a:r>
                     </a:p>
                   </a:txBody>
@@ -23877,7 +23877,7 @@
                         <a:defRPr sz="800"/>
                       </a:pPr>
                       <a:r>
-                        <a:t>Head 40LB T Y</a:t>
+                        <a:t>Head 36RB T Y</a:t>
                       </a:r>
                     </a:p>
                   </a:txBody>
@@ -23927,7 +23927,7 @@
                         <a:defRPr sz="800"/>
                       </a:pPr>
                       <a:r>
-                        <a:t>Head 40LB T R</a:t>
+                        <a:t>Head 36RB T R</a:t>
                       </a:r>
                     </a:p>
                   </a:txBody>
@@ -23977,7 +23977,7 @@
                         <a:defRPr sz="800"/>
                       </a:pPr>
                       <a:r>
-                        <a:t>Head 40LB B G</a:t>
+                        <a:t>Head 36RB B G</a:t>
                       </a:r>
                     </a:p>
                   </a:txBody>
@@ -24027,7 +24027,7 @@
                         <a:defRPr sz="800"/>
                       </a:pPr>
                       <a:r>
-                        <a:t>Head 40LB B Y</a:t>
+                        <a:t>Head 36RB B Y</a:t>
                       </a:r>
                     </a:p>
                   </a:txBody>
@@ -24077,7 +24077,7 @@
                         <a:defRPr sz="800"/>
                       </a:pPr>
                       <a:r>
-                        <a:t>Head 40LB B R</a:t>
+                        <a:t>Head 36RB B R</a:t>
                       </a:r>
                     </a:p>
                   </a:txBody>
@@ -24126,9 +24126,6 @@
                         </a:spcAft>
                         <a:defRPr sz="800"/>
                       </a:pPr>
-                      <a:r>
-                        <a:t>Head 40LA G</a:t>
-                      </a:r>
                     </a:p>
                   </a:txBody>
                   <a:tcPr anchor="t"/>
@@ -24176,9 +24173,6 @@
                         </a:spcAft>
                         <a:defRPr sz="800"/>
                       </a:pPr>
-                      <a:r>
-                        <a:t>Head 40LA Y</a:t>
-                      </a:r>
                     </a:p>
                   </a:txBody>
                   <a:tcPr anchor="t"/>
@@ -25588,7 +25582,7 @@
               <a:defRPr sz="2800" b="1"/>
             </a:pPr>
             <a:r>
-              <a:t>Node C2 (was C3) - North - Lower (East End signals)</a:t>
+              <a:t>Node C2 (was C3) - North - Lower (East End west 24)</a:t>
             </a:r>
           </a:p>
         </p:txBody>
@@ -26609,7 +26603,7 @@
                         <a:defRPr sz="800"/>
                       </a:pPr>
                       <a:r>
-                        <a:t>Head 34L T G</a:t>
+                        <a:t>S2-6 G</a:t>
                       </a:r>
                     </a:p>
                   </a:txBody>
@@ -26659,7 +26653,7 @@
                         <a:defRPr sz="800"/>
                       </a:pPr>
                       <a:r>
-                        <a:t>Head 34L T Y</a:t>
+                        <a:t>S2-6 R</a:t>
                       </a:r>
                     </a:p>
                   </a:txBody>
@@ -26709,7 +26703,7 @@
                         <a:defRPr sz="800"/>
                       </a:pPr>
                       <a:r>
-                        <a:t>Head 34L T R</a:t>
+                        <a:t>S2-7 G</a:t>
                       </a:r>
                     </a:p>
                   </a:txBody>
@@ -26759,7 +26753,7 @@
                         <a:defRPr sz="800"/>
                       </a:pPr>
                       <a:r>
-                        <a:t>Head 34L B G</a:t>
+                        <a:t>S2-7 R</a:t>
                       </a:r>
                     </a:p>
                   </a:txBody>
@@ -26809,7 +26803,7 @@
                         <a:defRPr sz="800"/>
                       </a:pPr>
                       <a:r>
-                        <a:t>Head 34L B Y</a:t>
+                        <a:t>S2-7 Y</a:t>
                       </a:r>
                     </a:p>
                   </a:txBody>
@@ -26858,9 +26852,6 @@
                         </a:spcAft>
                         <a:defRPr sz="800"/>
                       </a:pPr>
-                      <a:r>
-                        <a:t>Head 34L B R</a:t>
-                      </a:r>
                     </a:p>
                   </a:txBody>
                   <a:tcPr anchor="t"/>
@@ -26908,9 +26899,6 @@
                         </a:spcAft>
                         <a:defRPr sz="800"/>
                       </a:pPr>
-                      <a:r>
-                        <a:t>Head 32R G</a:t>
-                      </a:r>
                     </a:p>
                   </a:txBody>
                   <a:tcPr anchor="t"/>
@@ -26958,9 +26946,6 @@
                         </a:spcAft>
                         <a:defRPr sz="800"/>
                       </a:pPr>
-                      <a:r>
-                        <a:t>Head 32R Y</a:t>
-                      </a:r>
                     </a:p>
                   </a:txBody>
                   <a:tcPr anchor="t"/>
@@ -28379,7 +28364,7 @@
               <a:defRPr sz="2800" b="1"/>
             </a:pPr>
             <a:r>
-              <a:t>Node C3 (was C4) - West - Lower (Plane / Brick)</a:t>
+              <a:t>Node C3 (was C4) - West - Lower (103–106 motors)</a:t>
             </a:r>
           </a:p>
         </p:txBody>
@@ -28941,7 +28926,7 @@
                         <a:defRPr sz="800"/>
                       </a:pPr>
                       <a:r>
-                        <a:t>Head 6LB T G</a:t>
+                        <a:t>S3-6 G</a:t>
                       </a:r>
                     </a:p>
                   </a:txBody>
@@ -28991,7 +28976,7 @@
                         <a:defRPr sz="800"/>
                       </a:pPr>
                       <a:r>
-                        <a:t>Head 6LB T Y</a:t>
+                        <a:t>S3-6 Y</a:t>
                       </a:r>
                     </a:p>
                   </a:txBody>
@@ -29041,7 +29026,7 @@
                         <a:defRPr sz="800"/>
                       </a:pPr>
                       <a:r>
-                        <a:t>Head 6LB T R</a:t>
+                        <a:t>S3-6 R</a:t>
                       </a:r>
                     </a:p>
                   </a:txBody>
@@ -29091,7 +29076,7 @@
                         <a:defRPr sz="800"/>
                       </a:pPr>
                       <a:r>
-                        <a:t>Head 6LB B G</a:t>
+                        <a:t>S3-7 G</a:t>
                       </a:r>
                     </a:p>
                   </a:txBody>
@@ -29141,7 +29126,7 @@
                         <a:defRPr sz="800"/>
                       </a:pPr>
                       <a:r>
-                        <a:t>Head 6LB B Y</a:t>
+                        <a:t>S3-7 Y</a:t>
                       </a:r>
                     </a:p>
                   </a:txBody>
@@ -29191,7 +29176,7 @@
                         <a:defRPr sz="800"/>
                       </a:pPr>
                       <a:r>
-                        <a:t>Head 6LB B R</a:t>
+                        <a:t>S3-7 R</a:t>
                       </a:r>
                     </a:p>
                   </a:txBody>
@@ -29241,7 +29226,7 @@
                         <a:defRPr sz="800"/>
                       </a:pPr>
                       <a:r>
-                        <a:t>Head 6LA G</a:t>
+                        <a:t>S3-11 Y</a:t>
                       </a:r>
                     </a:p>
                   </a:txBody>
@@ -29291,7 +29276,7 @@
                         <a:defRPr sz="800"/>
                       </a:pPr>
                       <a:r>
-                        <a:t>Head 6LA Y</a:t>
+                        <a:t>C3 RELAY 1</a:t>
                       </a:r>
                     </a:p>
                   </a:txBody>
@@ -29400,7 +29385,7 @@
                         <a:defRPr sz="800"/>
                       </a:pPr>
                       <a:r>
-                        <a:t>Head 2L T G</a:t>
+                        <a:t>S3-8 G</a:t>
                       </a:r>
                     </a:p>
                   </a:txBody>
@@ -29450,7 +29435,7 @@
                         <a:defRPr sz="800"/>
                       </a:pPr>
                       <a:r>
-                        <a:t>Head 2L T Y</a:t>
+                        <a:t>S3-8 Y</a:t>
                       </a:r>
                     </a:p>
                   </a:txBody>
@@ -29500,7 +29485,7 @@
                         <a:defRPr sz="800"/>
                       </a:pPr>
                       <a:r>
-                        <a:t>Head 2L T R</a:t>
+                        <a:t>S3-8 R</a:t>
                       </a:r>
                     </a:p>
                   </a:txBody>
@@ -29550,7 +29535,7 @@
                         <a:defRPr sz="800"/>
                       </a:pPr>
                       <a:r>
-                        <a:t>Head 2L B G</a:t>
+                        <a:t>S3-9 G</a:t>
                       </a:r>
                     </a:p>
                   </a:txBody>
@@ -29600,7 +29585,7 @@
                         <a:defRPr sz="800"/>
                       </a:pPr>
                       <a:r>
-                        <a:t>Head 2L B Y</a:t>
+                        <a:t>S3-9 Y</a:t>
                       </a:r>
                     </a:p>
                   </a:txBody>
@@ -29650,7 +29635,7 @@
                         <a:defRPr sz="800"/>
                       </a:pPr>
                       <a:r>
-                        <a:t>Head 2L B R</a:t>
+                        <a:t>S3-9 R</a:t>
                       </a:r>
                     </a:p>
                   </a:txBody>
@@ -29700,7 +29685,7 @@
                         <a:defRPr sz="800"/>
                       </a:pPr>
                       <a:r>
-                        <a:t>Head 6LA R</a:t>
+                        <a:t>S3-11 G</a:t>
                       </a:r>
                     </a:p>
                   </a:txBody>
@@ -31170,7 +31155,7 @@
               <a:defRPr sz="2800" b="1"/>
             </a:pPr>
             <a:r>
-              <a:t>Node C4 (was C6) - Peninsula - Lower</a:t>
+              <a:t>Node C4 (was C6) - West - Lower (Brick / Plane)</a:t>
             </a:r>
           </a:p>
         </p:txBody>
@@ -31732,7 +31717,7 @@
                         <a:defRPr sz="800"/>
                       </a:pPr>
                       <a:r>
-                        <a:t>S3-1 G</a:t>
+                        <a:t>Head 6LB T G</a:t>
                       </a:r>
                     </a:p>
                   </a:txBody>
@@ -31782,7 +31767,7 @@
                         <a:defRPr sz="800"/>
                       </a:pPr>
                       <a:r>
-                        <a:t>S3-1 Y</a:t>
+                        <a:t>Head 6LB T Y</a:t>
                       </a:r>
                     </a:p>
                   </a:txBody>
@@ -31832,7 +31817,7 @@
                         <a:defRPr sz="800"/>
                       </a:pPr>
                       <a:r>
-                        <a:t>S3-1 R</a:t>
+                        <a:t>Head 6LB T R</a:t>
                       </a:r>
                     </a:p>
                   </a:txBody>
@@ -31882,7 +31867,7 @@
                         <a:defRPr sz="800"/>
                       </a:pPr>
                       <a:r>
-                        <a:t>S3-13 G</a:t>
+                        <a:t>Head 6LB B G</a:t>
                       </a:r>
                     </a:p>
                   </a:txBody>
@@ -31932,7 +31917,7 @@
                         <a:defRPr sz="800"/>
                       </a:pPr>
                       <a:r>
-                        <a:t>S3-13 R</a:t>
+                        <a:t>Head 6LB B Y</a:t>
                       </a:r>
                     </a:p>
                   </a:txBody>
@@ -31982,7 +31967,7 @@
                         <a:defRPr sz="800"/>
                       </a:pPr>
                       <a:r>
-                        <a:t>S3-13 Y</a:t>
+                        <a:t>Head 6LB B R</a:t>
                       </a:r>
                     </a:p>
                   </a:txBody>
@@ -32031,6 +32016,9 @@
                         </a:spcAft>
                         <a:defRPr sz="800"/>
                       </a:pPr>
+                      <a:r>
+                        <a:t>Head 6LA G</a:t>
+                      </a:r>
                     </a:p>
                   </a:txBody>
                   <a:tcPr anchor="t"/>
@@ -32079,7 +32067,7 @@
                         <a:defRPr sz="800"/>
                       </a:pPr>
                       <a:r>
-                        <a:t>C4 RELAY 1</a:t>
+                        <a:t>Head 6LA Y</a:t>
                       </a:r>
                     </a:p>
                   </a:txBody>
@@ -32188,7 +32176,7 @@
                         <a:defRPr sz="800"/>
                       </a:pPr>
                       <a:r>
-                        <a:t>S3-2 G</a:t>
+                        <a:t>Head 2L T G</a:t>
                       </a:r>
                     </a:p>
                   </a:txBody>
@@ -32238,7 +32226,7 @@
                         <a:defRPr sz="800"/>
                       </a:pPr>
                       <a:r>
-                        <a:t>S3-2 Y</a:t>
+                        <a:t>Head 2L T Y</a:t>
                       </a:r>
                     </a:p>
                   </a:txBody>
@@ -32288,7 +32276,7 @@
                         <a:defRPr sz="800"/>
                       </a:pPr>
                       <a:r>
-                        <a:t>S3-2 R</a:t>
+                        <a:t>Head 2L T R</a:t>
                       </a:r>
                     </a:p>
                   </a:txBody>
@@ -32338,7 +32326,7 @@
                         <a:defRPr sz="800"/>
                       </a:pPr>
                       <a:r>
-                        <a:t>S3-3 G</a:t>
+                        <a:t>Head 2L B G</a:t>
                       </a:r>
                     </a:p>
                   </a:txBody>
@@ -32388,7 +32376,7 @@
                         <a:defRPr sz="800"/>
                       </a:pPr>
                       <a:r>
-                        <a:t>S3-3 Y</a:t>
+                        <a:t>Head 2L B Y</a:t>
                       </a:r>
                     </a:p>
                   </a:txBody>
@@ -32438,7 +32426,7 @@
                         <a:defRPr sz="800"/>
                       </a:pPr>
                       <a:r>
-                        <a:t>S3-3 R</a:t>
+                        <a:t>Head 2L B R</a:t>
                       </a:r>
                     </a:p>
                   </a:txBody>
@@ -32487,6 +32475,9 @@
                         </a:spcAft>
                         <a:defRPr sz="800"/>
                       </a:pPr>
+                      <a:r>
+                        <a:t>Head 6LA R</a:t>
+                      </a:r>
                     </a:p>
                   </a:txBody>
                   <a:tcPr anchor="t"/>
@@ -33952,7 +33943,7 @@
               <a:defRPr sz="2800" b="1"/>
             </a:pPr>
             <a:r>
-              <a:t>Node C11 (was C7) - Helix (Princess overflow)</a:t>
+              <a:t>Node C11 (was C7) - Helix (Princess east 40 + balloon)</a:t>
             </a:r>
           </a:p>
         </p:txBody>
@@ -34508,7 +34499,7 @@
                         <a:defRPr sz="800"/>
                       </a:pPr>
                       <a:r>
-                        <a:t>Head 36RB T G</a:t>
+                        <a:t>Head 40LB T G</a:t>
                       </a:r>
                     </a:p>
                   </a:txBody>
@@ -34558,7 +34549,7 @@
                         <a:defRPr sz="800"/>
                       </a:pPr>
                       <a:r>
-                        <a:t>Head 36RB T Y</a:t>
+                        <a:t>Head 40LB T Y</a:t>
                       </a:r>
                     </a:p>
                   </a:txBody>
@@ -34608,7 +34599,7 @@
                         <a:defRPr sz="800"/>
                       </a:pPr>
                       <a:r>
-                        <a:t>Head 36RB T R</a:t>
+                        <a:t>Head 40LB T R</a:t>
                       </a:r>
                     </a:p>
                   </a:txBody>
@@ -34658,7 +34649,7 @@
                         <a:defRPr sz="800"/>
                       </a:pPr>
                       <a:r>
-                        <a:t>Head 36RB B G</a:t>
+                        <a:t>Head 40LB B G</a:t>
                       </a:r>
                     </a:p>
                   </a:txBody>
@@ -34708,7 +34699,7 @@
                         <a:defRPr sz="800"/>
                       </a:pPr>
                       <a:r>
-                        <a:t>Head 36RB B Y</a:t>
+                        <a:t>Head 40LB B Y</a:t>
                       </a:r>
                     </a:p>
                   </a:txBody>
@@ -34758,7 +34749,7 @@
                         <a:defRPr sz="800"/>
                       </a:pPr>
                       <a:r>
-                        <a:t>Head 36RB B R</a:t>
+                        <a:t>Head 40LB B R</a:t>
                       </a:r>
                     </a:p>
                   </a:txBody>
@@ -34807,6 +34798,9 @@
                         </a:spcAft>
                         <a:defRPr sz="800"/>
                       </a:pPr>
+                      <a:r>
+                        <a:t>Head 40LA G</a:t>
+                      </a:r>
                     </a:p>
                   </a:txBody>
                   <a:tcPr anchor="t"/>
@@ -34855,7 +34849,7 @@
                         <a:defRPr sz="800"/>
                       </a:pPr>
                       <a:r>
-                        <a:t>C23 RELAY 1</a:t>
+                        <a:t>Head 40LA Y</a:t>
                       </a:r>
                     </a:p>
                   </a:txBody>
@@ -35263,6 +35257,9 @@
                         </a:spcAft>
                         <a:defRPr sz="800"/>
                       </a:pPr>
+                      <a:r>
+                        <a:t>Head 40LA R</a:t>
+                      </a:r>
                     </a:p>
                   </a:txBody>
                   <a:tcPr anchor="t"/>
@@ -35622,7 +35619,7 @@
               <a:defRPr sz="2800" b="1"/>
             </a:pPr>
             <a:r>
-              <a:t>Node C12 (was C2) - North - Lower (East End turnouts 107–112)</a:t>
+              <a:t>Node C12 (was C2) - North - Lower (East End 34 + turnouts 107–112)</a:t>
             </a:r>
           </a:p>
         </p:txBody>
@@ -36184,7 +36181,7 @@
                         <a:defRPr sz="800"/>
                       </a:pPr>
                       <a:r>
-                        <a:t>S2-1 G</a:t>
+                        <a:t>Head 34L T G</a:t>
                       </a:r>
                     </a:p>
                   </a:txBody>
@@ -36234,7 +36231,7 @@
                         <a:defRPr sz="800"/>
                       </a:pPr>
                       <a:r>
-                        <a:t>S2-1 Y</a:t>
+                        <a:t>Head 34L T Y</a:t>
                       </a:r>
                     </a:p>
                   </a:txBody>
@@ -36284,7 +36281,7 @@
                         <a:defRPr sz="800"/>
                       </a:pPr>
                       <a:r>
-                        <a:t>S2-1 R</a:t>
+                        <a:t>Head 34L T R</a:t>
                       </a:r>
                     </a:p>
                   </a:txBody>
@@ -36334,7 +36331,7 @@
                         <a:defRPr sz="800"/>
                       </a:pPr>
                       <a:r>
-                        <a:t>S2-2 G</a:t>
+                        <a:t>Head 34L B G</a:t>
                       </a:r>
                     </a:p>
                   </a:txBody>
@@ -36384,7 +36381,7 @@
                         <a:defRPr sz="800"/>
                       </a:pPr>
                       <a:r>
-                        <a:t>S2-2 Y</a:t>
+                        <a:t>Head 34L B Y</a:t>
                       </a:r>
                     </a:p>
                   </a:txBody>
@@ -36434,7 +36431,7 @@
                         <a:defRPr sz="800"/>
                       </a:pPr>
                       <a:r>
-                        <a:t>S2-2 R</a:t>
+                        <a:t>Head 34L B R</a:t>
                       </a:r>
                     </a:p>
                   </a:txBody>
@@ -36484,7 +36481,7 @@
                         <a:defRPr sz="800"/>
                       </a:pPr>
                       <a:r>
-                        <a:t>S2-8 Y</a:t>
+                        <a:t>Head 32R G</a:t>
                       </a:r>
                     </a:p>
                   </a:txBody>
@@ -36534,7 +36531,7 @@
                         <a:defRPr sz="800"/>
                       </a:pPr>
                       <a:r>
-                        <a:t>C12 RELAY 1</a:t>
+                        <a:t>Head 32R Y</a:t>
                       </a:r>
                     </a:p>
                   </a:txBody>
@@ -36643,7 +36640,7 @@
                         <a:defRPr sz="800"/>
                       </a:pPr>
                       <a:r>
-                        <a:t>S2-9 G</a:t>
+                        <a:t>Head 34R T G</a:t>
                       </a:r>
                     </a:p>
                   </a:txBody>
@@ -36693,7 +36690,7 @@
                         <a:defRPr sz="800"/>
                       </a:pPr>
                       <a:r>
-                        <a:t>S2-9 R</a:t>
+                        <a:t>Head 34R T Y</a:t>
                       </a:r>
                     </a:p>
                   </a:txBody>
@@ -36743,7 +36740,7 @@
                         <a:defRPr sz="800"/>
                       </a:pPr>
                       <a:r>
-                        <a:t>S2-9 Y</a:t>
+                        <a:t>Head 34R T R</a:t>
                       </a:r>
                     </a:p>
                   </a:txBody>
@@ -36793,7 +36790,7 @@
                         <a:defRPr sz="800"/>
                       </a:pPr>
                       <a:r>
-                        <a:t>S2-4 G</a:t>
+                        <a:t>Head 34R B G</a:t>
                       </a:r>
                     </a:p>
                   </a:txBody>
@@ -36843,7 +36840,7 @@
                         <a:defRPr sz="800"/>
                       </a:pPr>
                       <a:r>
-                        <a:t>S2-4 Y</a:t>
+                        <a:t>Head 34R B Y</a:t>
                       </a:r>
                     </a:p>
                   </a:txBody>
@@ -36893,7 +36890,7 @@
                         <a:defRPr sz="800"/>
                       </a:pPr>
                       <a:r>
-                        <a:t>S2-4 R</a:t>
+                        <a:t>Head 34R B R</a:t>
                       </a:r>
                     </a:p>
                   </a:txBody>
@@ -36943,7 +36940,7 @@
                         <a:defRPr sz="800"/>
                       </a:pPr>
                       <a:r>
-                        <a:t>S2-8 G</a:t>
+                        <a:t>Head 32R R</a:t>
                       </a:r>
                     </a:p>
                   </a:txBody>

</xml_diff>

<commit_message>
Reserve pin 8 of the first 5V OU on every block-sensor node for detector calibration.
Digicon lamps that sat on those pins moved to the next leftover channel; relays that were there need a new home.

Co-authored-by: Cursor <cursoragent@cursor.com>
</commit_message>
<xml_diff>
--- a/docs/wiring/Wiring_Schematic.pptx
+++ b/docs/wiring/Wiring_Schematic.pptx
@@ -5842,7 +5842,7 @@
                         <a:defRPr sz="800"/>
                       </a:pPr>
                       <a:r>
-                        <a:t>C23 RELAY 1</a:t>
+                        <a:t>Block sensor calibration</a:t>
                       </a:r>
                     </a:p>
                   </a:txBody>
@@ -8633,7 +8633,7 @@
                         <a:defRPr sz="800"/>
                       </a:pPr>
                       <a:r>
-                        <a:t>C4 RELAY 1</a:t>
+                        <a:t>Block sensor calibration</a:t>
                       </a:r>
                     </a:p>
                   </a:txBody>
@@ -11424,7 +11424,7 @@
                         <a:defRPr sz="800"/>
                       </a:pPr>
                       <a:r>
-                        <a:t>C11 RELAY 1</a:t>
+                        <a:t>Block sensor calibration</a:t>
                       </a:r>
                     </a:p>
                   </a:txBody>
@@ -14200,7 +14200,7 @@
                         <a:defRPr sz="800"/>
                       </a:pPr>
                       <a:r>
-                        <a:t>C32 RELAY 1</a:t>
+                        <a:t>Block sensor calibration</a:t>
                       </a:r>
                     </a:p>
                   </a:txBody>
@@ -16538,7 +16538,7 @@
                         <a:defRPr sz="800"/>
                       </a:pPr>
                       <a:r>
-                        <a:t>C14 RELAY 1</a:t>
+                        <a:t>Block sensor calibration</a:t>
                       </a:r>
                     </a:p>
                   </a:txBody>
@@ -23718,7 +23718,7 @@
                         <a:defRPr sz="800"/>
                       </a:pPr>
                       <a:r>
-                        <a:t>C1 RELAY 1</a:t>
+                        <a:t>Block sensor calibration</a:t>
                       </a:r>
                     </a:p>
                   </a:txBody>
@@ -26035,7 +26035,7 @@
                         <a:defRPr sz="800"/>
                       </a:pPr>
                       <a:r>
-                        <a:t>Head 24RB Y</a:t>
+                        <a:t>Block sensor calibration</a:t>
                       </a:r>
                     </a:p>
                   </a:txBody>
@@ -26946,6 +26946,9 @@
                         </a:spcAft>
                         <a:defRPr sz="800"/>
                       </a:pPr>
+                      <a:r>
+                        <a:t>Head 24RB Y</a:t>
+                      </a:r>
                     </a:p>
                   </a:txBody>
                   <a:tcPr anchor="t"/>
@@ -29276,7 +29279,7 @@
                         <a:defRPr sz="800"/>
                       </a:pPr>
                       <a:r>
-                        <a:t>C3 RELAY 1</a:t>
+                        <a:t>Block sensor calibration</a:t>
                       </a:r>
                     </a:p>
                   </a:txBody>
@@ -32067,7 +32070,7 @@
                         <a:defRPr sz="800"/>
                       </a:pPr>
                       <a:r>
-                        <a:t>Head 6LA Y</a:t>
+                        <a:t>Block sensor calibration</a:t>
                       </a:r>
                     </a:p>
                   </a:txBody>
@@ -32525,6 +32528,9 @@
                         </a:spcAft>
                         <a:defRPr sz="800"/>
                       </a:pPr>
+                      <a:r>
+                        <a:t>Head 6LA Y</a:t>
+                      </a:r>
                     </a:p>
                   </a:txBody>
                   <a:tcPr anchor="t"/>
@@ -34849,7 +34855,7 @@
                         <a:defRPr sz="800"/>
                       </a:pPr>
                       <a:r>
-                        <a:t>Head 40LA Y</a:t>
+                        <a:t>Block sensor calibration</a:t>
                       </a:r>
                     </a:p>
                   </a:txBody>
@@ -35307,6 +35313,9 @@
                         </a:spcAft>
                         <a:defRPr sz="800"/>
                       </a:pPr>
+                      <a:r>
+                        <a:t>Head 40LA Y</a:t>
+                      </a:r>
                     </a:p>
                   </a:txBody>
                   <a:tcPr anchor="t"/>
@@ -36531,7 +36540,7 @@
                         <a:defRPr sz="800"/>
                       </a:pPr>
                       <a:r>
-                        <a:t>Head 32R Y</a:t>
+                        <a:t>Block sensor calibration</a:t>
                       </a:r>
                     </a:p>
                   </a:txBody>
@@ -36990,7 +36999,7 @@
                         <a:defRPr sz="800"/>
                       </a:pPr>
                       <a:r>
-                        <a:t>S2-8 R</a:t>
+                        <a:t>Head 32R Y</a:t>
                       </a:r>
                     </a:p>
                   </a:txBody>
@@ -38857,7 +38866,7 @@
                         <a:defRPr sz="800"/>
                       </a:pPr>
                       <a:r>
-                        <a:t>S3-14 R</a:t>
+                        <a:t>Block sensor calibration</a:t>
                       </a:r>
                     </a:p>
                   </a:txBody>

</xml_diff>

<commit_message>
Restore upper-deck SW1xx plant IDs that v84 concatenated into Switch 10038 / 1127 names.
Those are helix and upper-deck motors, not CTC numbers; leave Switch 27/29 and DCC 100–119 alone.

Co-authored-by: Cursor <cursoragent@cursor.com>
</commit_message>
<xml_diff>
--- a/docs/wiring/Wiring_Schematic.pptx
+++ b/docs/wiring/Wiring_Schematic.pptx
@@ -5033,7 +5033,7 @@
                         <a:defRPr sz="800"/>
                       </a:pPr>
                       <a:r>
-                        <a:t>Switch 10044 N</a:t>
+                        <a:t>SW144 N</a:t>
                       </a:r>
                     </a:p>
                   </a:txBody>
@@ -5083,7 +5083,7 @@
                         <a:defRPr sz="800"/>
                       </a:pPr>
                       <a:r>
-                        <a:t>Switch 10044 R</a:t>
+                        <a:t>SW144 R</a:t>
                       </a:r>
                     </a:p>
                   </a:txBody>
@@ -5133,7 +5133,7 @@
                         <a:defRPr sz="800"/>
                       </a:pPr>
                       <a:r>
-                        <a:t>Switch 10045 N</a:t>
+                        <a:t>SW145 N</a:t>
                       </a:r>
                     </a:p>
                   </a:txBody>
@@ -5183,7 +5183,7 @@
                         <a:defRPr sz="800"/>
                       </a:pPr>
                       <a:r>
-                        <a:t>Switch 10045 R</a:t>
+                        <a:t>SW145 R</a:t>
                       </a:r>
                     </a:p>
                   </a:txBody>
@@ -5233,7 +5233,7 @@
                         <a:defRPr sz="800"/>
                       </a:pPr>
                       <a:r>
-                        <a:t>Switch 10046 N</a:t>
+                        <a:t>SW146 N</a:t>
                       </a:r>
                     </a:p>
                   </a:txBody>
@@ -5283,7 +5283,7 @@
                         <a:defRPr sz="800"/>
                       </a:pPr>
                       <a:r>
-                        <a:t>Switch 10046 R</a:t>
+                        <a:t>SW146 R</a:t>
                       </a:r>
                     </a:p>
                   </a:txBody>
@@ -5333,7 +5333,7 @@
                         <a:defRPr sz="800"/>
                       </a:pPr>
                       <a:r>
-                        <a:t>Switch 10047 N</a:t>
+                        <a:t>SW147 N</a:t>
                       </a:r>
                     </a:p>
                   </a:txBody>
@@ -5383,7 +5383,7 @@
                         <a:defRPr sz="800"/>
                       </a:pPr>
                       <a:r>
-                        <a:t>Switch 10047 R</a:t>
+                        <a:t>SW147 R</a:t>
                       </a:r>
                     </a:p>
                   </a:txBody>
@@ -6410,7 +6410,7 @@
                         <a:defRPr sz="800"/>
                       </a:pPr>
                       <a:r>
-                        <a:t>Switch 10044 N FB</a:t>
+                        <a:t>SW144 N FB</a:t>
                       </a:r>
                     </a:p>
                   </a:txBody>
@@ -6460,7 +6460,7 @@
                         <a:defRPr sz="800"/>
                       </a:pPr>
                       <a:r>
-                        <a:t>Switch 10044 R FB</a:t>
+                        <a:t>SW144 R FB</a:t>
                       </a:r>
                     </a:p>
                   </a:txBody>
@@ -6510,7 +6510,7 @@
                         <a:defRPr sz="800"/>
                       </a:pPr>
                       <a:r>
-                        <a:t>Switch 10045 N FB</a:t>
+                        <a:t>SW145 N FB</a:t>
                       </a:r>
                     </a:p>
                   </a:txBody>
@@ -6560,7 +6560,7 @@
                         <a:defRPr sz="800"/>
                       </a:pPr>
                       <a:r>
-                        <a:t>Switch 10045 R FB</a:t>
+                        <a:t>SW145 R FB</a:t>
                       </a:r>
                     </a:p>
                   </a:txBody>
@@ -6610,7 +6610,7 @@
                         <a:defRPr sz="800"/>
                       </a:pPr>
                       <a:r>
-                        <a:t>Switch 10046 N FB</a:t>
+                        <a:t>SW146 N FB</a:t>
                       </a:r>
                     </a:p>
                   </a:txBody>
@@ -6660,7 +6660,7 @@
                         <a:defRPr sz="800"/>
                       </a:pPr>
                       <a:r>
-                        <a:t>Switch 10046 R FB</a:t>
+                        <a:t>SW146 R FB</a:t>
                       </a:r>
                     </a:p>
                   </a:txBody>
@@ -6710,7 +6710,7 @@
                         <a:defRPr sz="800"/>
                       </a:pPr>
                       <a:r>
-                        <a:t>Switch 10047 N FB</a:t>
+                        <a:t>SW147 N FB</a:t>
                       </a:r>
                     </a:p>
                   </a:txBody>
@@ -6760,7 +6760,7 @@
                         <a:defRPr sz="800"/>
                       </a:pPr>
                       <a:r>
-                        <a:t>Switch 10047 R FB</a:t>
+                        <a:t>SW147 R FB</a:t>
                       </a:r>
                     </a:p>
                   </a:txBody>
@@ -6869,7 +6869,7 @@
                         <a:defRPr sz="800"/>
                       </a:pPr>
                       <a:r>
-                        <a:t>Switch 10044 BTN</a:t>
+                        <a:t>SW144 BTN</a:t>
                       </a:r>
                     </a:p>
                   </a:txBody>
@@ -6919,7 +6919,7 @@
                         <a:defRPr sz="800"/>
                       </a:pPr>
                       <a:r>
-                        <a:t>Switch 10045 BTN</a:t>
+                        <a:t>SW145 BTN</a:t>
                       </a:r>
                     </a:p>
                   </a:txBody>
@@ -6969,7 +6969,7 @@
                         <a:defRPr sz="800"/>
                       </a:pPr>
                       <a:r>
-                        <a:t>Switch 10046 BTN</a:t>
+                        <a:t>SW146 BTN</a:t>
                       </a:r>
                     </a:p>
                   </a:txBody>
@@ -7019,7 +7019,7 @@
                         <a:defRPr sz="800"/>
                       </a:pPr>
                       <a:r>
-                        <a:t>Switch 10047 BTN</a:t>
+                        <a:t>SW147 BTN</a:t>
                       </a:r>
                     </a:p>
                   </a:txBody>
@@ -9301,7 +9301,7 @@
                         <a:defRPr sz="800"/>
                       </a:pPr>
                       <a:r>
-                        <a:t>Switch 1129 N FB</a:t>
+                        <a:t>SW129 N FB</a:t>
                       </a:r>
                     </a:p>
                   </a:txBody>
@@ -9351,7 +9351,7 @@
                         <a:defRPr sz="800"/>
                       </a:pPr>
                       <a:r>
-                        <a:t>Switch 1129 R FB</a:t>
+                        <a:t>SW129 R FB</a:t>
                       </a:r>
                     </a:p>
                   </a:txBody>
@@ -9401,7 +9401,7 @@
                         <a:defRPr sz="800"/>
                       </a:pPr>
                       <a:r>
-                        <a:t>Switch 1127 N FB</a:t>
+                        <a:t>SW127 N FB</a:t>
                       </a:r>
                     </a:p>
                   </a:txBody>
@@ -9451,7 +9451,7 @@
                         <a:defRPr sz="800"/>
                       </a:pPr>
                       <a:r>
-                        <a:t>Switch 1127 R FB</a:t>
+                        <a:t>SW127 R FB</a:t>
                       </a:r>
                     </a:p>
                   </a:txBody>
@@ -9501,7 +9501,7 @@
                         <a:defRPr sz="800"/>
                       </a:pPr>
                       <a:r>
-                        <a:t>Switch 10038 N FB</a:t>
+                        <a:t>SW138 N FB</a:t>
                       </a:r>
                     </a:p>
                   </a:txBody>
@@ -9551,7 +9551,7 @@
                         <a:defRPr sz="800"/>
                       </a:pPr>
                       <a:r>
-                        <a:t>Switch 10038 R FB</a:t>
+                        <a:t>SW138 R FB</a:t>
                       </a:r>
                     </a:p>
                   </a:txBody>
@@ -9710,7 +9710,7 @@
                         <a:defRPr sz="800"/>
                       </a:pPr>
                       <a:r>
-                        <a:t>Switch 1129 BTN</a:t>
+                        <a:t>SW129 BTN</a:t>
                       </a:r>
                     </a:p>
                   </a:txBody>
@@ -9760,7 +9760,7 @@
                         <a:defRPr sz="800"/>
                       </a:pPr>
                       <a:r>
-                        <a:t>Switch 1127 BTN</a:t>
+                        <a:t>SW127 BTN</a:t>
                       </a:r>
                     </a:p>
                   </a:txBody>
@@ -9810,7 +9810,7 @@
                         <a:defRPr sz="800"/>
                       </a:pPr>
                       <a:r>
-                        <a:t>Switch 10038 BTN</a:t>
+                        <a:t>SW138 BTN</a:t>
                       </a:r>
                     </a:p>
                   </a:txBody>
@@ -12192,7 +12192,7 @@
                         <a:defRPr sz="800"/>
                       </a:pPr>
                       <a:r>
-                        <a:t>Switch 1124 N FB</a:t>
+                        <a:t>SW124 N FB</a:t>
                       </a:r>
                     </a:p>
                   </a:txBody>
@@ -12242,7 +12242,7 @@
                         <a:defRPr sz="800"/>
                       </a:pPr>
                       <a:r>
-                        <a:t>Switch 1124 R FB</a:t>
+                        <a:t>SW124 R FB</a:t>
                       </a:r>
                     </a:p>
                   </a:txBody>
@@ -12545,7 +12545,7 @@
                         <a:defRPr sz="800"/>
                       </a:pPr>
                       <a:r>
-                        <a:t>Switch 1124 BTN</a:t>
+                        <a:t>SW124 BTN</a:t>
                       </a:r>
                     </a:p>
                   </a:txBody>
@@ -13497,7 +13497,7 @@
                         <a:defRPr sz="800"/>
                       </a:pPr>
                       <a:r>
-                        <a:t>Switch 10043 N</a:t>
+                        <a:t>SW143 N</a:t>
                       </a:r>
                     </a:p>
                   </a:txBody>
@@ -13547,7 +13547,7 @@
                         <a:defRPr sz="800"/>
                       </a:pPr>
                       <a:r>
-                        <a:t>Switch 10043 R</a:t>
+                        <a:t>SW143 R</a:t>
                       </a:r>
                     </a:p>
                   </a:txBody>
@@ -14868,7 +14868,7 @@
                         <a:defRPr sz="800"/>
                       </a:pPr>
                       <a:r>
-                        <a:t>Switch 10043 N FB</a:t>
+                        <a:t>SW143 N FB</a:t>
                       </a:r>
                     </a:p>
                   </a:txBody>
@@ -14918,7 +14918,7 @@
                         <a:defRPr sz="800"/>
                       </a:pPr>
                       <a:r>
-                        <a:t>Switch 10043 R FB</a:t>
+                        <a:t>SW143 R FB</a:t>
                       </a:r>
                     </a:p>
                   </a:txBody>
@@ -15112,7 +15112,7 @@
                         <a:defRPr sz="800"/>
                       </a:pPr>
                       <a:r>
-                        <a:t>Switch 10043 BTN</a:t>
+                        <a:t>SW143 BTN</a:t>
                       </a:r>
                     </a:p>
                   </a:txBody>
@@ -15729,7 +15729,7 @@
                         <a:defRPr sz="800"/>
                       </a:pPr>
                       <a:r>
-                        <a:t>Switch 10048 N</a:t>
+                        <a:t>SW148 N</a:t>
                       </a:r>
                     </a:p>
                   </a:txBody>
@@ -15779,7 +15779,7 @@
                         <a:defRPr sz="800"/>
                       </a:pPr>
                       <a:r>
-                        <a:t>Switch 10048 R</a:t>
+                        <a:t>SW148 R</a:t>
                       </a:r>
                     </a:p>
                   </a:txBody>
@@ -15829,7 +15829,7 @@
                         <a:defRPr sz="800"/>
                       </a:pPr>
                       <a:r>
-                        <a:t>Switch 10049 N</a:t>
+                        <a:t>SW149 N</a:t>
                       </a:r>
                     </a:p>
                   </a:txBody>
@@ -15879,7 +15879,7 @@
                         <a:defRPr sz="800"/>
                       </a:pPr>
                       <a:r>
-                        <a:t>Switch 10049 R</a:t>
+                        <a:t>SW149 R</a:t>
                       </a:r>
                     </a:p>
                   </a:txBody>
@@ -15929,7 +15929,7 @@
                         <a:defRPr sz="800"/>
                       </a:pPr>
                       <a:r>
-                        <a:t>Switch 10050 N</a:t>
+                        <a:t>SW150 N</a:t>
                       </a:r>
                     </a:p>
                   </a:txBody>
@@ -15979,7 +15979,7 @@
                         <a:defRPr sz="800"/>
                       </a:pPr>
                       <a:r>
-                        <a:t>Switch 10050 R</a:t>
+                        <a:t>SW150 R</a:t>
                       </a:r>
                     </a:p>
                   </a:txBody>
@@ -17100,7 +17100,7 @@
                         <a:defRPr sz="800"/>
                       </a:pPr>
                       <a:r>
-                        <a:t>Switch 10048 N FB</a:t>
+                        <a:t>SW148 N FB</a:t>
                       </a:r>
                     </a:p>
                   </a:txBody>
@@ -17150,7 +17150,7 @@
                         <a:defRPr sz="800"/>
                       </a:pPr>
                       <a:r>
-                        <a:t>Switch 10048 R FB</a:t>
+                        <a:t>SW148 R FB</a:t>
                       </a:r>
                     </a:p>
                   </a:txBody>
@@ -17200,7 +17200,7 @@
                         <a:defRPr sz="800"/>
                       </a:pPr>
                       <a:r>
-                        <a:t>Switch 10049 N FB</a:t>
+                        <a:t>SW149 N FB</a:t>
                       </a:r>
                     </a:p>
                   </a:txBody>
@@ -17250,7 +17250,7 @@
                         <a:defRPr sz="800"/>
                       </a:pPr>
                       <a:r>
-                        <a:t>Switch 10049 R FB</a:t>
+                        <a:t>SW149 R FB</a:t>
                       </a:r>
                     </a:p>
                   </a:txBody>
@@ -17300,7 +17300,7 @@
                         <a:defRPr sz="800"/>
                       </a:pPr>
                       <a:r>
-                        <a:t>Switch 10050 N FB</a:t>
+                        <a:t>SW150 N FB</a:t>
                       </a:r>
                     </a:p>
                   </a:txBody>
@@ -17350,7 +17350,7 @@
                         <a:defRPr sz="800"/>
                       </a:pPr>
                       <a:r>
-                        <a:t>Switch 10050 R FB</a:t>
+                        <a:t>SW150 R FB</a:t>
                       </a:r>
                     </a:p>
                   </a:txBody>
@@ -17553,7 +17553,7 @@
                         <a:defRPr sz="800"/>
                       </a:pPr>
                       <a:r>
-                        <a:t>Switch 10048 BTN</a:t>
+                        <a:t>SW148 BTN</a:t>
                       </a:r>
                     </a:p>
                   </a:txBody>
@@ -17603,7 +17603,7 @@
                         <a:defRPr sz="800"/>
                       </a:pPr>
                       <a:r>
-                        <a:t>Switch 10049 BTN</a:t>
+                        <a:t>SW149 BTN</a:t>
                       </a:r>
                     </a:p>
                   </a:txBody>
@@ -17653,7 +17653,7 @@
                         <a:defRPr sz="800"/>
                       </a:pPr>
                       <a:r>
-                        <a:t>Switch 10050 BTN</a:t>
+                        <a:t>SW150 BTN</a:t>
                       </a:r>
                     </a:p>
                   </a:txBody>
@@ -18505,7 +18505,7 @@
                         <a:defRPr sz="800"/>
                       </a:pPr>
                       <a:r>
-                        <a:t>Switch 1124 N</a:t>
+                        <a:t>SW124 N</a:t>
                       </a:r>
                     </a:p>
                   </a:txBody>
@@ -18555,7 +18555,7 @@
                         <a:defRPr sz="800"/>
                       </a:pPr>
                       <a:r>
-                        <a:t>Switch 1124 R</a:t>
+                        <a:t>SW124 R</a:t>
                       </a:r>
                     </a:p>
                   </a:txBody>
@@ -34052,7 +34052,7 @@
                         <a:defRPr sz="800"/>
                       </a:pPr>
                       <a:r>
-                        <a:t>Switch 1129 N</a:t>
+                        <a:t>SW129 N</a:t>
                       </a:r>
                     </a:p>
                   </a:txBody>
@@ -34102,7 +34102,7 @@
                         <a:defRPr sz="800"/>
                       </a:pPr>
                       <a:r>
-                        <a:t>Switch 1129 R</a:t>
+                        <a:t>SW129 R</a:t>
                       </a:r>
                     </a:p>
                   </a:txBody>
@@ -34152,7 +34152,7 @@
                         <a:defRPr sz="800"/>
                       </a:pPr>
                       <a:r>
-                        <a:t>Switch 1127 N</a:t>
+                        <a:t>SW127 N</a:t>
                       </a:r>
                     </a:p>
                   </a:txBody>
@@ -34202,7 +34202,7 @@
                         <a:defRPr sz="800"/>
                       </a:pPr>
                       <a:r>
-                        <a:t>Switch 1127 R</a:t>
+                        <a:t>SW127 R</a:t>
                       </a:r>
                     </a:p>
                   </a:txBody>
@@ -34252,7 +34252,7 @@
                         <a:defRPr sz="800"/>
                       </a:pPr>
                       <a:r>
-                        <a:t>Switch 10038 N</a:t>
+                        <a:t>SW138 N</a:t>
                       </a:r>
                     </a:p>
                   </a:txBody>
@@ -34302,7 +34302,7 @@
                         <a:defRPr sz="800"/>
                       </a:pPr>
                       <a:r>
-                        <a:t>Switch 10038 R</a:t>
+                        <a:t>SW138 R</a:t>
                       </a:r>
                     </a:p>
                   </a:txBody>

</xml_diff>

<commit_message>
Put 38LA on C1 leftover pins and show CTC switch numbers in the inventory.
38LA G/Y were on OU4 (easy to read as C11) while OU3-7/8 sat empty; they now sit with R on the 36-board leftovers. 24RB is three pins on C2-OU3. DCC 100–119 labels become Switch 1…39.

Co-authored-by: Cursor <cursoragent@cursor.com>
</commit_message>
<xml_diff>
--- a/docs/wiring/Wiring_Schematic.pptx
+++ b/docs/wiring/Wiring_Schematic.pptx
@@ -3590,7 +3590,7 @@
                         <a:defRPr sz="1000"/>
                       </a:pPr>
                       <a:r>
-                        <a:t>West - Lower (103–106 motors)</a:t>
+                        <a:t>West - Lower (Switch 15–21 motors)</a:t>
                       </a:r>
                     </a:p>
                   </a:txBody>
@@ -3943,7 +3943,7 @@
                         <a:defRPr sz="1000"/>
                       </a:pPr>
                       <a:r>
-                        <a:t>North - Lower (East End 34 + turnouts 107–112)</a:t>
+                        <a:t>North - Lower (East End 34 + Switch 25–33)</a:t>
                       </a:r>
                     </a:p>
                   </a:txBody>
@@ -19562,7 +19562,7 @@
                         <a:defRPr sz="800"/>
                       </a:pPr>
                       <a:r>
-                        <a:t>36RA, S1-3, 36RB</a:t>
+                        <a:t>36RA, 36RB</a:t>
                       </a:r>
                     </a:p>
                   </a:txBody>
@@ -19753,7 +19753,7 @@
                         <a:defRPr sz="800"/>
                       </a:pPr>
                       <a:r>
-                        <a:t>Switch 103</a:t>
+                        <a:t>Switch 15</a:t>
                       </a:r>
                     </a:p>
                   </a:txBody>
@@ -19850,7 +19850,7 @@
                         <a:defRPr sz="800"/>
                       </a:pPr>
                       <a:r>
-                        <a:t>Switch 104</a:t>
+                        <a:t>Switch 17</a:t>
                       </a:r>
                     </a:p>
                   </a:txBody>
@@ -19927,7 +19927,7 @@
                         <a:defRPr sz="800"/>
                       </a:pPr>
                       <a:r>
-                        <a:t>Switch 105</a:t>
+                        <a:t>Switch 19</a:t>
                       </a:r>
                     </a:p>
                   </a:txBody>
@@ -20024,7 +20024,7 @@
                         <a:defRPr sz="800"/>
                       </a:pPr>
                       <a:r>
-                        <a:t>Switch 106</a:t>
+                        <a:t>Switch 21</a:t>
                       </a:r>
                     </a:p>
                   </a:txBody>
@@ -20198,7 +20198,7 @@
                         <a:defRPr sz="800"/>
                       </a:pPr>
                       <a:r>
-                        <a:t>Switch 116</a:t>
+                        <a:t>Switch 13</a:t>
                       </a:r>
                     </a:p>
                   </a:txBody>
@@ -20348,7 +20348,7 @@
                         <a:defRPr sz="800"/>
                       </a:pPr>
                       <a:r>
-                        <a:t>S1-1, 4RA, 4RB</a:t>
+                        <a:t>4RA, 4RB</a:t>
                       </a:r>
                     </a:p>
                   </a:txBody>
@@ -20429,7 +20429,7 @@
                         <a:defRPr sz="800"/>
                       </a:pPr>
                       <a:r>
-                        <a:t>6LA, S3-6, 6LB</a:t>
+                        <a:t>6LA, 6LB</a:t>
                       </a:r>
                     </a:p>
                   </a:txBody>
@@ -20717,7 +20717,7 @@
                         <a:defRPr sz="800"/>
                       </a:pPr>
                       <a:r>
-                        <a:t>Switch 107</a:t>
+                        <a:t>Switch 23</a:t>
                       </a:r>
                     </a:p>
                   </a:txBody>
@@ -20747,7 +20747,7 @@
                         <a:defRPr sz="800"/>
                       </a:pPr>
                       <a:r>
-                        <a:t>C12-IN2-1</a:t>
+                        <a:t>C12-IN2-5</a:t>
                       </a:r>
                     </a:p>
                   </a:txBody>
@@ -20762,7 +20762,7 @@
                         <a:defRPr sz="800"/>
                       </a:pPr>
                       <a:r>
-                        <a:t>N:C12-IN1-1, R:C12-IN1-2</a:t>
+                        <a:t>N:C12-IN3-1, R:C12-IN3-2</a:t>
                       </a:r>
                     </a:p>
                   </a:txBody>
@@ -20777,7 +20777,7 @@
                         <a:defRPr sz="800"/>
                       </a:pPr>
                       <a:r>
-                        <a:t>S2-6</a:t>
+                        <a:t>24L, 24RA, 24RB</a:t>
                       </a:r>
                     </a:p>
                   </a:txBody>
@@ -20794,7 +20794,7 @@
                         <a:defRPr sz="800"/>
                       </a:pPr>
                       <a:r>
-                        <a:t>Switch 108</a:t>
+                        <a:t>Switch 25</a:t>
                       </a:r>
                     </a:p>
                   </a:txBody>
@@ -20832,7 +20832,7 @@
                         <a:defRPr sz="800"/>
                       </a:pPr>
                       <a:r>
-                        <a:t>C12-IN2-2</a:t>
+                        <a:t>C12-IN2-1</a:t>
                       </a:r>
                     </a:p>
                   </a:txBody>
@@ -20851,7 +20851,7 @@
                         <a:defRPr sz="800"/>
                       </a:pPr>
                       <a:r>
-                        <a:t>N:C12-IN1-3, R:C12-IN1-4</a:t>
+                        <a:t>N:C12-IN1-1, R:C12-IN1-2</a:t>
                       </a:r>
                     </a:p>
                   </a:txBody>
@@ -20870,7 +20870,7 @@
                         <a:defRPr sz="800"/>
                       </a:pPr>
                       <a:r>
-                        <a:t>S2-7</a:t>
+                        <a:t>S2-6</a:t>
                       </a:r>
                     </a:p>
                   </a:txBody>
@@ -20891,7 +20891,7 @@
                         <a:defRPr sz="800"/>
                       </a:pPr>
                       <a:r>
-                        <a:t>Switch 109</a:t>
+                        <a:t>Switch 27</a:t>
                       </a:r>
                     </a:p>
                   </a:txBody>
@@ -20921,7 +20921,7 @@
                         <a:defRPr sz="800"/>
                       </a:pPr>
                       <a:r>
-                        <a:t>C12-IN2-3</a:t>
+                        <a:t>C12-IN2-2</a:t>
                       </a:r>
                     </a:p>
                   </a:txBody>
@@ -20936,7 +20936,7 @@
                         <a:defRPr sz="800"/>
                       </a:pPr>
                       <a:r>
-                        <a:t>N:C12-IN1-5, R:C12-IN1-6</a:t>
+                        <a:t>N:C12-IN1-3, R:C12-IN1-4</a:t>
                       </a:r>
                     </a:p>
                   </a:txBody>
@@ -20951,7 +20951,7 @@
                         <a:defRPr sz="800"/>
                       </a:pPr>
                       <a:r>
-                        <a:t>S2-8, S2-5</a:t>
+                        <a:t>S2-7</a:t>
                       </a:r>
                     </a:p>
                   </a:txBody>
@@ -20968,7 +20968,7 @@
                         <a:defRPr sz="800"/>
                       </a:pPr>
                       <a:r>
-                        <a:t>Switch 23</a:t>
+                        <a:t>Switch 29</a:t>
                       </a:r>
                     </a:p>
                   </a:txBody>
@@ -21006,7 +21006,7 @@
                         <a:defRPr sz="800"/>
                       </a:pPr>
                       <a:r>
-                        <a:t>C12-IN2-5</a:t>
+                        <a:t>C12-IN2-3</a:t>
                       </a:r>
                     </a:p>
                   </a:txBody>
@@ -21025,7 +21025,7 @@
                         <a:defRPr sz="800"/>
                       </a:pPr>
                       <a:r>
-                        <a:t>N:C12-IN3-1, R:C12-IN3-2</a:t>
+                        <a:t>N:C12-IN1-5, R:C12-IN1-6</a:t>
                       </a:r>
                     </a:p>
                   </a:txBody>
@@ -21044,7 +21044,7 @@
                         <a:defRPr sz="800"/>
                       </a:pPr>
                       <a:r>
-                        <a:t>24L, 24RA, 24RB</a:t>
+                        <a:t>S2-8, S2-5</a:t>
                       </a:r>
                     </a:p>
                   </a:txBody>
@@ -21271,7 +21271,7 @@
                         <a:defRPr sz="800"/>
                       </a:pPr>
                       <a:r>
-                        <a:t>32R, S2-1</a:t>
+                        <a:t>32R</a:t>
                       </a:r>
                     </a:p>
                   </a:txBody>
@@ -21385,7 +21385,7 @@
                         <a:defRPr sz="800"/>
                       </a:pPr>
                       <a:r>
-                        <a:t>Switch 118</a:t>
+                        <a:t>Switch 11</a:t>
                       </a:r>
                     </a:p>
                   </a:txBody>
@@ -21459,7 +21459,7 @@
                         <a:defRPr sz="800"/>
                       </a:pPr>
                       <a:r>
-                        <a:t>Switch 119</a:t>
+                        <a:t>Switch 7</a:t>
                       </a:r>
                     </a:p>
                   </a:txBody>
@@ -21497,7 +21497,7 @@
                         <a:defRPr sz="800"/>
                       </a:pPr>
                       <a:r>
-                        <a:t>C13-IN2-3</a:t>
+                        <a:t>C13-IN2-1</a:t>
                       </a:r>
                     </a:p>
                   </a:txBody>
@@ -21516,7 +21516,7 @@
                         <a:defRPr sz="800"/>
                       </a:pPr>
                       <a:r>
-                        <a:t>N:C13-IN1-5, R:C13-IN1-6</a:t>
+                        <a:t>N:C13-IN1-1, R:C13-IN1-2</a:t>
                       </a:r>
                     </a:p>
                   </a:txBody>
@@ -21534,6 +21534,9 @@
                       <a:pPr>
                         <a:defRPr sz="800"/>
                       </a:pPr>
+                      <a:r>
+                        <a:t>8RA, 8LA, 8LB / 8RB</a:t>
+                      </a:r>
                     </a:p>
                   </a:txBody>
                   <a:tcPr>
@@ -21553,7 +21556,7 @@
                         <a:defRPr sz="800"/>
                       </a:pPr>
                       <a:r>
-                        <a:t>Switch 7</a:t>
+                        <a:t>Switch 9</a:t>
                       </a:r>
                     </a:p>
                   </a:txBody>
@@ -21583,7 +21586,7 @@
                         <a:defRPr sz="800"/>
                       </a:pPr>
                       <a:r>
-                        <a:t>C13-IN2-1</a:t>
+                        <a:t>C13-IN2-3</a:t>
                       </a:r>
                     </a:p>
                   </a:txBody>
@@ -21598,7 +21601,7 @@
                         <a:defRPr sz="800"/>
                       </a:pPr>
                       <a:r>
-                        <a:t>N:C13-IN1-1, R:C13-IN1-2</a:t>
+                        <a:t>N:C13-IN1-5, R:C13-IN1-6</a:t>
                       </a:r>
                     </a:p>
                   </a:txBody>
@@ -21612,9 +21615,6 @@
                       <a:pPr>
                         <a:defRPr sz="800"/>
                       </a:pPr>
-                      <a:r>
-                        <a:t>8RA, 8LA, 8LB / 8RB</a:t>
-                      </a:r>
                     </a:p>
                   </a:txBody>
                   <a:tcPr/>
@@ -22909,7 +22909,7 @@
                         <a:defRPr sz="800"/>
                       </a:pPr>
                       <a:r>
-                        <a:t>Switch 113 N</a:t>
+                        <a:t>Switch 35 N</a:t>
                       </a:r>
                     </a:p>
                   </a:txBody>
@@ -22959,7 +22959,7 @@
                         <a:defRPr sz="800"/>
                       </a:pPr>
                       <a:r>
-                        <a:t>Switch 113 R</a:t>
+                        <a:t>Switch 35 R</a:t>
                       </a:r>
                     </a:p>
                   </a:txBody>
@@ -23009,7 +23009,7 @@
                         <a:defRPr sz="800"/>
                       </a:pPr>
                       <a:r>
-                        <a:t>Switch 114 N</a:t>
+                        <a:t>Switch 37 N</a:t>
                       </a:r>
                     </a:p>
                   </a:txBody>
@@ -23059,7 +23059,7 @@
                         <a:defRPr sz="800"/>
                       </a:pPr>
                       <a:r>
-                        <a:t>Switch 114 R</a:t>
+                        <a:t>Switch 37 R</a:t>
                       </a:r>
                     </a:p>
                   </a:txBody>
@@ -23109,7 +23109,7 @@
                         <a:defRPr sz="800"/>
                       </a:pPr>
                       <a:r>
-                        <a:t>Switch 115 N</a:t>
+                        <a:t>Switch 39 N</a:t>
                       </a:r>
                     </a:p>
                   </a:txBody>
@@ -23159,7 +23159,7 @@
                         <a:defRPr sz="800"/>
                       </a:pPr>
                       <a:r>
-                        <a:t>Switch 115 R</a:t>
+                        <a:t>Switch 39 R</a:t>
                       </a:r>
                     </a:p>
                   </a:txBody>
@@ -24126,6 +24126,9 @@
                         </a:spcAft>
                         <a:defRPr sz="800"/>
                       </a:pPr>
+                      <a:r>
+                        <a:t>Head 38LA G</a:t>
+                      </a:r>
                     </a:p>
                   </a:txBody>
                   <a:tcPr anchor="t"/>
@@ -24173,6 +24176,9 @@
                         </a:spcAft>
                         <a:defRPr sz="800"/>
                       </a:pPr>
+                      <a:r>
+                        <a:t>Head 38LA Y</a:t>
+                      </a:r>
                     </a:p>
                   </a:txBody>
                   <a:tcPr anchor="t"/>
@@ -24280,7 +24286,7 @@
                         <a:defRPr sz="800"/>
                       </a:pPr>
                       <a:r>
-                        <a:t>Switch 113 N FB</a:t>
+                        <a:t>Switch 35 N FB</a:t>
                       </a:r>
                     </a:p>
                   </a:txBody>
@@ -24330,7 +24336,7 @@
                         <a:defRPr sz="800"/>
                       </a:pPr>
                       <a:r>
-                        <a:t>Switch 113 R FB</a:t>
+                        <a:t>Switch 35 R FB</a:t>
                       </a:r>
                     </a:p>
                   </a:txBody>
@@ -24380,7 +24386,7 @@
                         <a:defRPr sz="800"/>
                       </a:pPr>
                       <a:r>
-                        <a:t>Switch 114 N FB</a:t>
+                        <a:t>Switch 37 N FB</a:t>
                       </a:r>
                     </a:p>
                   </a:txBody>
@@ -24430,7 +24436,7 @@
                         <a:defRPr sz="800"/>
                       </a:pPr>
                       <a:r>
-                        <a:t>Switch 114 R FB</a:t>
+                        <a:t>Switch 37 R FB</a:t>
                       </a:r>
                     </a:p>
                   </a:txBody>
@@ -24480,7 +24486,7 @@
                         <a:defRPr sz="800"/>
                       </a:pPr>
                       <a:r>
-                        <a:t>Switch 115 N FB</a:t>
+                        <a:t>Switch 39 N FB</a:t>
                       </a:r>
                     </a:p>
                   </a:txBody>
@@ -24530,7 +24536,7 @@
                         <a:defRPr sz="800"/>
                       </a:pPr>
                       <a:r>
-                        <a:t>Switch 115 R FB</a:t>
+                        <a:t>Switch 39 R FB</a:t>
                       </a:r>
                     </a:p>
                   </a:txBody>
@@ -24733,7 +24739,7 @@
                         <a:defRPr sz="800"/>
                       </a:pPr>
                       <a:r>
-                        <a:t>Switch 113 BTN</a:t>
+                        <a:t>Switch 35 BTN</a:t>
                       </a:r>
                     </a:p>
                   </a:txBody>
@@ -24783,7 +24789,7 @@
                         <a:defRPr sz="800"/>
                       </a:pPr>
                       <a:r>
-                        <a:t>Switch 114 BTN</a:t>
+                        <a:t>Switch 37 BTN</a:t>
                       </a:r>
                     </a:p>
                   </a:txBody>
@@ -24833,7 +24839,7 @@
                         <a:defRPr sz="800"/>
                       </a:pPr>
                       <a:r>
-                        <a:t>Switch 115 BTN</a:t>
+                        <a:t>Switch 39 BTN</a:t>
                       </a:r>
                     </a:p>
                   </a:txBody>
@@ -25277,7 +25283,7 @@
                         <a:defRPr sz="800"/>
                       </a:pPr>
                       <a:r>
-                        <a:t>Switch 114</a:t>
+                        <a:t>Switch 37</a:t>
                       </a:r>
                     </a:p>
                   </a:txBody>
@@ -25327,7 +25333,7 @@
                         <a:defRPr sz="800"/>
                       </a:pPr>
                       <a:r>
-                        <a:t>Switch 115</a:t>
+                        <a:t>Switch 39</a:t>
                       </a:r>
                     </a:p>
                   </a:txBody>
@@ -25377,7 +25383,7 @@
                         <a:defRPr sz="800"/>
                       </a:pPr>
                       <a:r>
-                        <a:t>Switch 113b</a:t>
+                        <a:t>Switch 35b</a:t>
                       </a:r>
                     </a:p>
                   </a:txBody>
@@ -25427,7 +25433,7 @@
                         <a:defRPr sz="800"/>
                       </a:pPr>
                       <a:r>
-                        <a:t>Switch 113a</a:t>
+                        <a:t>Switch 35a</a:t>
                       </a:r>
                     </a:p>
                   </a:txBody>
@@ -25984,9 +25990,6 @@
                         </a:spcAft>
                         <a:defRPr sz="800"/>
                       </a:pPr>
-                      <a:r>
-                        <a:t>Head 24RB G</a:t>
-                      </a:r>
                     </a:p>
                   </a:txBody>
                   <a:tcPr anchor="t"/>
@@ -26444,7 +26447,7 @@
                         <a:defRPr sz="800"/>
                       </a:pPr>
                       <a:r>
-                        <a:t>Head 24RB R</a:t>
+                        <a:t>S2-6 Y</a:t>
                       </a:r>
                     </a:p>
                   </a:txBody>
@@ -26852,6 +26855,9 @@
                         </a:spcAft>
                         <a:defRPr sz="800"/>
                       </a:pPr>
+                      <a:r>
+                        <a:t>Head 24RB G</a:t>
+                      </a:r>
                     </a:p>
                   </a:txBody>
                   <a:tcPr anchor="t"/>
@@ -26899,6 +26905,9 @@
                         </a:spcAft>
                         <a:defRPr sz="800"/>
                       </a:pPr>
+                      <a:r>
+                        <a:t>Head 24RB Y</a:t>
+                      </a:r>
                     </a:p>
                   </a:txBody>
                   <a:tcPr anchor="t"/>
@@ -26947,7 +26956,7 @@
                         <a:defRPr sz="800"/>
                       </a:pPr>
                       <a:r>
-                        <a:t>Head 24RB Y</a:t>
+                        <a:t>Head 24RB R</a:t>
                       </a:r>
                     </a:p>
                   </a:txBody>
@@ -27056,7 +27065,7 @@
                         <a:defRPr sz="800"/>
                       </a:pPr>
                       <a:r>
-                        <a:t>Switch 107 N FB</a:t>
+                        <a:t>Switch 25 N FB</a:t>
                       </a:r>
                     </a:p>
                   </a:txBody>
@@ -27106,7 +27115,7 @@
                         <a:defRPr sz="800"/>
                       </a:pPr>
                       <a:r>
-                        <a:t>Switch 107 R FB</a:t>
+                        <a:t>Switch 25 R FB</a:t>
                       </a:r>
                     </a:p>
                   </a:txBody>
@@ -27156,7 +27165,7 @@
                         <a:defRPr sz="800"/>
                       </a:pPr>
                       <a:r>
-                        <a:t>Switch 108 N FB</a:t>
+                        <a:t>Switch 27 N FB</a:t>
                       </a:r>
                     </a:p>
                   </a:txBody>
@@ -27206,7 +27215,7 @@
                         <a:defRPr sz="800"/>
                       </a:pPr>
                       <a:r>
-                        <a:t>Switch 108 R FB</a:t>
+                        <a:t>Switch 27 R FB</a:t>
                       </a:r>
                     </a:p>
                   </a:txBody>
@@ -27256,7 +27265,7 @@
                         <a:defRPr sz="800"/>
                       </a:pPr>
                       <a:r>
-                        <a:t>Switch 109 N FB</a:t>
+                        <a:t>Switch 29 N FB</a:t>
                       </a:r>
                     </a:p>
                   </a:txBody>
@@ -27306,7 +27315,7 @@
                         <a:defRPr sz="800"/>
                       </a:pPr>
                       <a:r>
-                        <a:t>Switch 109 R FB</a:t>
+                        <a:t>Switch 29 R FB</a:t>
                       </a:r>
                     </a:p>
                   </a:txBody>
@@ -27356,7 +27365,7 @@
                         <a:defRPr sz="800"/>
                       </a:pPr>
                       <a:r>
-                        <a:t>Switch 110 N FB</a:t>
+                        <a:t>Switch 31 N FB</a:t>
                       </a:r>
                     </a:p>
                   </a:txBody>
@@ -27406,7 +27415,7 @@
                         <a:defRPr sz="800"/>
                       </a:pPr>
                       <a:r>
-                        <a:t>Switch 110 R FB</a:t>
+                        <a:t>Switch 31 R FB</a:t>
                       </a:r>
                     </a:p>
                   </a:txBody>
@@ -27515,7 +27524,7 @@
                         <a:defRPr sz="800"/>
                       </a:pPr>
                       <a:r>
-                        <a:t>Switch 107 BTN</a:t>
+                        <a:t>Switch 25 BTN</a:t>
                       </a:r>
                     </a:p>
                   </a:txBody>
@@ -27565,7 +27574,7 @@
                         <a:defRPr sz="800"/>
                       </a:pPr>
                       <a:r>
-                        <a:t>Switch 108 BTN</a:t>
+                        <a:t>Switch 27 BTN</a:t>
                       </a:r>
                     </a:p>
                   </a:txBody>
@@ -27615,7 +27624,7 @@
                         <a:defRPr sz="800"/>
                       </a:pPr>
                       <a:r>
-                        <a:t>Switch 109 BTN</a:t>
+                        <a:t>Switch 29 BTN</a:t>
                       </a:r>
                     </a:p>
                   </a:txBody>
@@ -27665,7 +27674,7 @@
                         <a:defRPr sz="800"/>
                       </a:pPr>
                       <a:r>
-                        <a:t>Switch 110 BTN</a:t>
+                        <a:t>Switch 31 BTN</a:t>
                       </a:r>
                     </a:p>
                   </a:txBody>
@@ -28367,7 +28376,7 @@
               <a:defRPr sz="2800" b="1"/>
             </a:pPr>
             <a:r>
-              <a:t>Node C3 (was C4) - West - Lower (103–106 motors)</a:t>
+              <a:t>Node C3 (was C4) - West - Lower (Switch 15–21 motors)</a:t>
             </a:r>
           </a:p>
         </p:txBody>
@@ -28470,7 +28479,7 @@
                         <a:defRPr sz="800"/>
                       </a:pPr>
                       <a:r>
-                        <a:t>Switch 103 N</a:t>
+                        <a:t>Switch 15 N</a:t>
                       </a:r>
                     </a:p>
                   </a:txBody>
@@ -28520,7 +28529,7 @@
                         <a:defRPr sz="800"/>
                       </a:pPr>
                       <a:r>
-                        <a:t>Switch 103 R</a:t>
+                        <a:t>Switch 15 R</a:t>
                       </a:r>
                     </a:p>
                   </a:txBody>
@@ -28570,7 +28579,7 @@
                         <a:defRPr sz="800"/>
                       </a:pPr>
                       <a:r>
-                        <a:t>Switch 104 N</a:t>
+                        <a:t>Switch 17 N</a:t>
                       </a:r>
                     </a:p>
                   </a:txBody>
@@ -28620,7 +28629,7 @@
                         <a:defRPr sz="800"/>
                       </a:pPr>
                       <a:r>
-                        <a:t>Switch 104 R</a:t>
+                        <a:t>Switch 17 R</a:t>
                       </a:r>
                     </a:p>
                   </a:txBody>
@@ -28670,7 +28679,7 @@
                         <a:defRPr sz="800"/>
                       </a:pPr>
                       <a:r>
-                        <a:t>Switch 105 N</a:t>
+                        <a:t>Switch 19 N</a:t>
                       </a:r>
                     </a:p>
                   </a:txBody>
@@ -28720,7 +28729,7 @@
                         <a:defRPr sz="800"/>
                       </a:pPr>
                       <a:r>
-                        <a:t>Switch 105 R</a:t>
+                        <a:t>Switch 19 R</a:t>
                       </a:r>
                     </a:p>
                   </a:txBody>
@@ -28770,7 +28779,7 @@
                         <a:defRPr sz="800"/>
                       </a:pPr>
                       <a:r>
-                        <a:t>Switch 106 N</a:t>
+                        <a:t>Switch 21 N</a:t>
                       </a:r>
                     </a:p>
                   </a:txBody>
@@ -28820,7 +28829,7 @@
                         <a:defRPr sz="800"/>
                       </a:pPr>
                       <a:r>
-                        <a:t>Switch 106 R</a:t>
+                        <a:t>Switch 21 R</a:t>
                       </a:r>
                     </a:p>
                   </a:txBody>
@@ -29847,7 +29856,7 @@
                         <a:defRPr sz="800"/>
                       </a:pPr>
                       <a:r>
-                        <a:t>Switch 103 N FB</a:t>
+                        <a:t>Switch 15 N FB</a:t>
                       </a:r>
                     </a:p>
                   </a:txBody>
@@ -29897,7 +29906,7 @@
                         <a:defRPr sz="800"/>
                       </a:pPr>
                       <a:r>
-                        <a:t>Switch 103 R FB</a:t>
+                        <a:t>Switch 15 R FB</a:t>
                       </a:r>
                     </a:p>
                   </a:txBody>
@@ -29947,7 +29956,7 @@
                         <a:defRPr sz="800"/>
                       </a:pPr>
                       <a:r>
-                        <a:t>Switch 104 N FB</a:t>
+                        <a:t>Switch 17 N FB</a:t>
                       </a:r>
                     </a:p>
                   </a:txBody>
@@ -29997,7 +30006,7 @@
                         <a:defRPr sz="800"/>
                       </a:pPr>
                       <a:r>
-                        <a:t>Switch 104 R FB</a:t>
+                        <a:t>Switch 17 R FB</a:t>
                       </a:r>
                     </a:p>
                   </a:txBody>
@@ -30047,7 +30056,7 @@
                         <a:defRPr sz="800"/>
                       </a:pPr>
                       <a:r>
-                        <a:t>Switch 105 N FB</a:t>
+                        <a:t>Switch 19 N FB</a:t>
                       </a:r>
                     </a:p>
                   </a:txBody>
@@ -30097,7 +30106,7 @@
                         <a:defRPr sz="800"/>
                       </a:pPr>
                       <a:r>
-                        <a:t>Switch 105 R FB</a:t>
+                        <a:t>Switch 19 R FB</a:t>
                       </a:r>
                     </a:p>
                   </a:txBody>
@@ -30147,7 +30156,7 @@
                         <a:defRPr sz="800"/>
                       </a:pPr>
                       <a:r>
-                        <a:t>Switch 106 N FB</a:t>
+                        <a:t>Switch 21 N FB</a:t>
                       </a:r>
                     </a:p>
                   </a:txBody>
@@ -30197,7 +30206,7 @@
                         <a:defRPr sz="800"/>
                       </a:pPr>
                       <a:r>
-                        <a:t>Switch 106 R FB</a:t>
+                        <a:t>Switch 21 R FB</a:t>
                       </a:r>
                     </a:p>
                   </a:txBody>
@@ -30306,7 +30315,7 @@
                         <a:defRPr sz="800"/>
                       </a:pPr>
                       <a:r>
-                        <a:t>Switch 103 BTN</a:t>
+                        <a:t>Switch 15 BTN</a:t>
                       </a:r>
                     </a:p>
                   </a:txBody>
@@ -30356,7 +30365,7 @@
                         <a:defRPr sz="800"/>
                       </a:pPr>
                       <a:r>
-                        <a:t>Switch 104 BTN</a:t>
+                        <a:t>Switch 17 BTN</a:t>
                       </a:r>
                     </a:p>
                   </a:txBody>
@@ -30406,7 +30415,7 @@
                         <a:defRPr sz="800"/>
                       </a:pPr>
                       <a:r>
-                        <a:t>Switch 105 BTN</a:t>
+                        <a:t>Switch 19 BTN</a:t>
                       </a:r>
                     </a:p>
                   </a:txBody>
@@ -30456,7 +30465,7 @@
                         <a:defRPr sz="800"/>
                       </a:pPr>
                       <a:r>
-                        <a:t>Switch 106 BTN</a:t>
+                        <a:t>Switch 21 BTN</a:t>
                       </a:r>
                     </a:p>
                   </a:txBody>
@@ -30753,7 +30762,7 @@
                         <a:defRPr sz="800"/>
                       </a:pPr>
                       <a:r>
-                        <a:t>Switch 116</a:t>
+                        <a:t>Switch 13</a:t>
                       </a:r>
                     </a:p>
                   </a:txBody>
@@ -30803,7 +30812,7 @@
                         <a:defRPr sz="800"/>
                       </a:pPr>
                       <a:r>
-                        <a:t>Switch 103</a:t>
+                        <a:t>Switch 15</a:t>
                       </a:r>
                     </a:p>
                   </a:txBody>
@@ -30853,7 +30862,7 @@
                         <a:defRPr sz="800"/>
                       </a:pPr>
                       <a:r>
-                        <a:t>Switch 104</a:t>
+                        <a:t>Switch 17</a:t>
                       </a:r>
                     </a:p>
                   </a:txBody>
@@ -30953,7 +30962,7 @@
                         <a:defRPr sz="800"/>
                       </a:pPr>
                       <a:r>
-                        <a:t>Switch 105</a:t>
+                        <a:t>Switch 19</a:t>
                       </a:r>
                     </a:p>
                   </a:txBody>
@@ -31053,7 +31062,7 @@
                         <a:defRPr sz="800"/>
                       </a:pPr>
                       <a:r>
-                        <a:t>Switch 106</a:t>
+                        <a:t>Switch 21</a:t>
                       </a:r>
                     </a:p>
                   </a:txBody>
@@ -31261,7 +31270,7 @@
                         <a:defRPr sz="800"/>
                       </a:pPr>
                       <a:r>
-                        <a:t>Switch 100 N</a:t>
+                        <a:t>Switch 1 N</a:t>
                       </a:r>
                     </a:p>
                   </a:txBody>
@@ -31311,7 +31320,7 @@
                         <a:defRPr sz="800"/>
                       </a:pPr>
                       <a:r>
-                        <a:t>Switch 100 R</a:t>
+                        <a:t>Switch 1 R</a:t>
                       </a:r>
                     </a:p>
                   </a:txBody>
@@ -31361,7 +31370,7 @@
                         <a:defRPr sz="800"/>
                       </a:pPr>
                       <a:r>
-                        <a:t>Switch 101 N</a:t>
+                        <a:t>Switch 3 N</a:t>
                       </a:r>
                     </a:p>
                   </a:txBody>
@@ -31411,7 +31420,7 @@
                         <a:defRPr sz="800"/>
                       </a:pPr>
                       <a:r>
-                        <a:t>Switch 101 R</a:t>
+                        <a:t>Switch 3 R</a:t>
                       </a:r>
                     </a:p>
                   </a:txBody>
@@ -31461,7 +31470,7 @@
                         <a:defRPr sz="800"/>
                       </a:pPr>
                       <a:r>
-                        <a:t>Switch 102 N</a:t>
+                        <a:t>Switch 5 N</a:t>
                       </a:r>
                     </a:p>
                   </a:txBody>
@@ -31511,7 +31520,7 @@
                         <a:defRPr sz="800"/>
                       </a:pPr>
                       <a:r>
-                        <a:t>Switch 102 R</a:t>
+                        <a:t>Switch 5 R</a:t>
                       </a:r>
                     </a:p>
                   </a:txBody>
@@ -31561,7 +31570,7 @@
                         <a:defRPr sz="800"/>
                       </a:pPr>
                       <a:r>
-                        <a:t>Switch 116 N</a:t>
+                        <a:t>Switch 13 N</a:t>
                       </a:r>
                     </a:p>
                   </a:txBody>
@@ -31611,7 +31620,7 @@
                         <a:defRPr sz="800"/>
                       </a:pPr>
                       <a:r>
-                        <a:t>Switch 116 R</a:t>
+                        <a:t>Switch 13 R</a:t>
                       </a:r>
                     </a:p>
                   </a:txBody>
@@ -32638,7 +32647,7 @@
                         <a:defRPr sz="800"/>
                       </a:pPr>
                       <a:r>
-                        <a:t>Switch 100 N FB</a:t>
+                        <a:t>Switch 1 N FB</a:t>
                       </a:r>
                     </a:p>
                   </a:txBody>
@@ -32688,7 +32697,7 @@
                         <a:defRPr sz="800"/>
                       </a:pPr>
                       <a:r>
-                        <a:t>Switch 100 R FB</a:t>
+                        <a:t>Switch 1 R FB</a:t>
                       </a:r>
                     </a:p>
                   </a:txBody>
@@ -32738,7 +32747,7 @@
                         <a:defRPr sz="800"/>
                       </a:pPr>
                       <a:r>
-                        <a:t>Switch 101 N FB</a:t>
+                        <a:t>Switch 3 N FB</a:t>
                       </a:r>
                     </a:p>
                   </a:txBody>
@@ -32788,7 +32797,7 @@
                         <a:defRPr sz="800"/>
                       </a:pPr>
                       <a:r>
-                        <a:t>Switch 101 R FB</a:t>
+                        <a:t>Switch 3 R FB</a:t>
                       </a:r>
                     </a:p>
                   </a:txBody>
@@ -32838,7 +32847,7 @@
                         <a:defRPr sz="800"/>
                       </a:pPr>
                       <a:r>
-                        <a:t>Switch 102 N FB</a:t>
+                        <a:t>Switch 5 N FB</a:t>
                       </a:r>
                     </a:p>
                   </a:txBody>
@@ -32888,7 +32897,7 @@
                         <a:defRPr sz="800"/>
                       </a:pPr>
                       <a:r>
-                        <a:t>Switch 102 R FB</a:t>
+                        <a:t>Switch 5 R FB</a:t>
                       </a:r>
                     </a:p>
                   </a:txBody>
@@ -32938,7 +32947,7 @@
                         <a:defRPr sz="800"/>
                       </a:pPr>
                       <a:r>
-                        <a:t>Switch 116 N FB</a:t>
+                        <a:t>Switch 13 N FB</a:t>
                       </a:r>
                     </a:p>
                   </a:txBody>
@@ -32988,7 +32997,7 @@
                         <a:defRPr sz="800"/>
                       </a:pPr>
                       <a:r>
-                        <a:t>Switch 116 R FB</a:t>
+                        <a:t>Switch 13 R FB</a:t>
                       </a:r>
                     </a:p>
                   </a:txBody>
@@ -33097,7 +33106,7 @@
                         <a:defRPr sz="800"/>
                       </a:pPr>
                       <a:r>
-                        <a:t>Switch 100 BTN</a:t>
+                        <a:t>Switch 1 BTN</a:t>
                       </a:r>
                     </a:p>
                   </a:txBody>
@@ -33147,7 +33156,7 @@
                         <a:defRPr sz="800"/>
                       </a:pPr>
                       <a:r>
-                        <a:t>Switch 101 BTN</a:t>
+                        <a:t>Switch 3 BTN</a:t>
                       </a:r>
                     </a:p>
                   </a:txBody>
@@ -33197,7 +33206,7 @@
                         <a:defRPr sz="800"/>
                       </a:pPr>
                       <a:r>
-                        <a:t>Switch 102 BTN</a:t>
+                        <a:t>Switch 5 BTN</a:t>
                       </a:r>
                     </a:p>
                   </a:txBody>
@@ -33247,7 +33256,7 @@
                         <a:defRPr sz="800"/>
                       </a:pPr>
                       <a:r>
-                        <a:t>Switch 116 BTN</a:t>
+                        <a:t>Switch 13 BTN</a:t>
                       </a:r>
                     </a:p>
                   </a:txBody>
@@ -33544,7 +33553,7 @@
                         <a:defRPr sz="800"/>
                       </a:pPr>
                       <a:r>
-                        <a:t>Switch 101</a:t>
+                        <a:t>Switch 3</a:t>
                       </a:r>
                     </a:p>
                   </a:txBody>
@@ -33594,7 +33603,7 @@
                         <a:defRPr sz="800"/>
                       </a:pPr>
                       <a:r>
-                        <a:t>Switch 100</a:t>
+                        <a:t>Switch 1</a:t>
                       </a:r>
                     </a:p>
                   </a:txBody>
@@ -33744,7 +33753,7 @@
                         <a:defRPr sz="800"/>
                       </a:pPr>
                       <a:r>
-                        <a:t>Switch 102</a:t>
+                        <a:t>Switch 5</a:t>
                       </a:r>
                     </a:p>
                   </a:txBody>
@@ -35628,7 +35637,7 @@
               <a:defRPr sz="2800" b="1"/>
             </a:pPr>
             <a:r>
-              <a:t>Node C12 (was C2) - North - Lower (East End 34 + turnouts 107–112)</a:t>
+              <a:t>Node C12 (was C2) - North - Lower (East End 34 + Switch 25–33)</a:t>
             </a:r>
           </a:p>
         </p:txBody>
@@ -35731,7 +35740,7 @@
                         <a:defRPr sz="800"/>
                       </a:pPr>
                       <a:r>
-                        <a:t>Switch 107 N</a:t>
+                        <a:t>Switch 25 N</a:t>
                       </a:r>
                     </a:p>
                   </a:txBody>
@@ -35781,7 +35790,7 @@
                         <a:defRPr sz="800"/>
                       </a:pPr>
                       <a:r>
-                        <a:t>Switch 107 R</a:t>
+                        <a:t>Switch 25 R</a:t>
                       </a:r>
                     </a:p>
                   </a:txBody>
@@ -35831,7 +35840,7 @@
                         <a:defRPr sz="800"/>
                       </a:pPr>
                       <a:r>
-                        <a:t>Switch 108 N</a:t>
+                        <a:t>Switch 27 N</a:t>
                       </a:r>
                     </a:p>
                   </a:txBody>
@@ -35881,7 +35890,7 @@
                         <a:defRPr sz="800"/>
                       </a:pPr>
                       <a:r>
-                        <a:t>Switch 108 R</a:t>
+                        <a:t>Switch 27 R</a:t>
                       </a:r>
                     </a:p>
                   </a:txBody>
@@ -35931,7 +35940,7 @@
                         <a:defRPr sz="800"/>
                       </a:pPr>
                       <a:r>
-                        <a:t>Switch 109 N</a:t>
+                        <a:t>Switch 29 N</a:t>
                       </a:r>
                     </a:p>
                   </a:txBody>
@@ -35981,7 +35990,7 @@
                         <a:defRPr sz="800"/>
                       </a:pPr>
                       <a:r>
-                        <a:t>Switch 109 R</a:t>
+                        <a:t>Switch 29 R</a:t>
                       </a:r>
                     </a:p>
                   </a:txBody>
@@ -36031,7 +36040,7 @@
                         <a:defRPr sz="800"/>
                       </a:pPr>
                       <a:r>
-                        <a:t>Switch 110 N</a:t>
+                        <a:t>Switch 31 N</a:t>
                       </a:r>
                     </a:p>
                   </a:txBody>
@@ -36081,7 +36090,7 @@
                         <a:defRPr sz="800"/>
                       </a:pPr>
                       <a:r>
-                        <a:t>Switch 110 R</a:t>
+                        <a:t>Switch 31 R</a:t>
                       </a:r>
                     </a:p>
                   </a:txBody>
@@ -37108,7 +37117,7 @@
                         <a:defRPr sz="800"/>
                       </a:pPr>
                       <a:r>
-                        <a:t>Switch 107 N FB</a:t>
+                        <a:t>Switch 25 N FB</a:t>
                       </a:r>
                     </a:p>
                   </a:txBody>
@@ -37158,7 +37167,7 @@
                         <a:defRPr sz="800"/>
                       </a:pPr>
                       <a:r>
-                        <a:t>Switch 107 R FB</a:t>
+                        <a:t>Switch 25 R FB</a:t>
                       </a:r>
                     </a:p>
                   </a:txBody>
@@ -37208,7 +37217,7 @@
                         <a:defRPr sz="800"/>
                       </a:pPr>
                       <a:r>
-                        <a:t>Switch 108 N FB</a:t>
+                        <a:t>Switch 27 N FB</a:t>
                       </a:r>
                     </a:p>
                   </a:txBody>
@@ -37258,7 +37267,7 @@
                         <a:defRPr sz="800"/>
                       </a:pPr>
                       <a:r>
-                        <a:t>Switch 108 R FB</a:t>
+                        <a:t>Switch 27 R FB</a:t>
                       </a:r>
                     </a:p>
                   </a:txBody>
@@ -37308,7 +37317,7 @@
                         <a:defRPr sz="800"/>
                       </a:pPr>
                       <a:r>
-                        <a:t>Switch 109 N FB</a:t>
+                        <a:t>Switch 29 N FB</a:t>
                       </a:r>
                     </a:p>
                   </a:txBody>
@@ -37358,7 +37367,7 @@
                         <a:defRPr sz="800"/>
                       </a:pPr>
                       <a:r>
-                        <a:t>Switch 109 R FB</a:t>
+                        <a:t>Switch 29 R FB</a:t>
                       </a:r>
                     </a:p>
                   </a:txBody>
@@ -37408,7 +37417,7 @@
                         <a:defRPr sz="800"/>
                       </a:pPr>
                       <a:r>
-                        <a:t>Switch 110 N FB</a:t>
+                        <a:t>Switch 31 N FB</a:t>
                       </a:r>
                     </a:p>
                   </a:txBody>
@@ -37458,7 +37467,7 @@
                         <a:defRPr sz="800"/>
                       </a:pPr>
                       <a:r>
-                        <a:t>Switch 110 R FB</a:t>
+                        <a:t>Switch 31 R FB</a:t>
                       </a:r>
                     </a:p>
                   </a:txBody>
@@ -37567,7 +37576,7 @@
                         <a:defRPr sz="800"/>
                       </a:pPr>
                       <a:r>
-                        <a:t>Switch 107 BTN</a:t>
+                        <a:t>Switch 25 BTN</a:t>
                       </a:r>
                     </a:p>
                   </a:txBody>
@@ -37617,7 +37626,7 @@
                         <a:defRPr sz="800"/>
                       </a:pPr>
                       <a:r>
-                        <a:t>Switch 108 BTN</a:t>
+                        <a:t>Switch 27 BTN</a:t>
                       </a:r>
                     </a:p>
                   </a:txBody>
@@ -37667,7 +37676,7 @@
                         <a:defRPr sz="800"/>
                       </a:pPr>
                       <a:r>
-                        <a:t>Switch 109 BTN</a:t>
+                        <a:t>Switch 29 BTN</a:t>
                       </a:r>
                     </a:p>
                   </a:txBody>
@@ -37717,7 +37726,7 @@
                         <a:defRPr sz="800"/>
                       </a:pPr>
                       <a:r>
-                        <a:t>Switch 110 BTN</a:t>
+                        <a:t>Switch 31 BTN</a:t>
                       </a:r>
                     </a:p>
                   </a:txBody>
@@ -37767,7 +37776,7 @@
                         <a:defRPr sz="800"/>
                       </a:pPr>
                       <a:r>
-                        <a:t>Switch 111 BTN</a:t>
+                        <a:t>Switch 23 BTN</a:t>
                       </a:r>
                     </a:p>
                   </a:txBody>
@@ -37817,7 +37826,7 @@
                         <a:defRPr sz="800"/>
                       </a:pPr>
                       <a:r>
-                        <a:t>Switch 112 BTN</a:t>
+                        <a:t>Switch 33 BTN</a:t>
                       </a:r>
                     </a:p>
                   </a:txBody>
@@ -38020,7 +38029,7 @@
                         <a:defRPr sz="800"/>
                       </a:pPr>
                       <a:r>
-                        <a:t>Switch 111 N FB</a:t>
+                        <a:t>Switch 23 N FB</a:t>
                       </a:r>
                     </a:p>
                   </a:txBody>
@@ -38070,7 +38079,7 @@
                         <a:defRPr sz="800"/>
                       </a:pPr>
                       <a:r>
-                        <a:t>Switch 111 R FB</a:t>
+                        <a:t>Switch 23 R FB</a:t>
                       </a:r>
                     </a:p>
                   </a:txBody>
@@ -38120,7 +38129,7 @@
                         <a:defRPr sz="800"/>
                       </a:pPr>
                       <a:r>
-                        <a:t>Switch 112 N FB</a:t>
+                        <a:t>Switch 33 N FB</a:t>
                       </a:r>
                     </a:p>
                   </a:txBody>
@@ -38170,7 +38179,7 @@
                         <a:defRPr sz="800"/>
                       </a:pPr>
                       <a:r>
-                        <a:t>Switch 112 R FB</a:t>
+                        <a:t>Switch 33 R FB</a:t>
                       </a:r>
                     </a:p>
                   </a:txBody>
@@ -39434,7 +39443,7 @@
                         <a:defRPr sz="800"/>
                       </a:pPr>
                       <a:r>
-                        <a:t>Switch 117 N</a:t>
+                        <a:t>Switch 7 N</a:t>
                       </a:r>
                     </a:p>
                   </a:txBody>
@@ -39484,7 +39493,7 @@
                         <a:defRPr sz="800"/>
                       </a:pPr>
                       <a:r>
-                        <a:t>Switch 117 R</a:t>
+                        <a:t>Switch 7 R</a:t>
                       </a:r>
                     </a:p>
                   </a:txBody>
@@ -39534,7 +39543,7 @@
                         <a:defRPr sz="800"/>
                       </a:pPr>
                       <a:r>
-                        <a:t>Switch 118 N</a:t>
+                        <a:t>Switch 11 N</a:t>
                       </a:r>
                     </a:p>
                   </a:txBody>
@@ -39584,7 +39593,7 @@
                         <a:defRPr sz="800"/>
                       </a:pPr>
                       <a:r>
-                        <a:t>Switch 118 R</a:t>
+                        <a:t>Switch 11 R</a:t>
                       </a:r>
                     </a:p>
                   </a:txBody>
@@ -39634,7 +39643,7 @@
                         <a:defRPr sz="800"/>
                       </a:pPr>
                       <a:r>
-                        <a:t>Switch 119 N</a:t>
+                        <a:t>Switch 9 N</a:t>
                       </a:r>
                     </a:p>
                   </a:txBody>
@@ -39684,7 +39693,7 @@
                         <a:defRPr sz="800"/>
                       </a:pPr>
                       <a:r>
-                        <a:t>Switch 119 R</a:t>
+                        <a:t>Switch 9 R</a:t>
                       </a:r>
                     </a:p>
                   </a:txBody>
@@ -39887,7 +39896,7 @@
                         <a:defRPr sz="800"/>
                       </a:pPr>
                       <a:r>
-                        <a:t>Switch 117 N FB</a:t>
+                        <a:t>Switch 7 N FB</a:t>
                       </a:r>
                     </a:p>
                   </a:txBody>
@@ -39937,7 +39946,7 @@
                         <a:defRPr sz="800"/>
                       </a:pPr>
                       <a:r>
-                        <a:t>Switch 117 R FB</a:t>
+                        <a:t>Switch 7 R FB</a:t>
                       </a:r>
                     </a:p>
                   </a:txBody>
@@ -39987,7 +39996,7 @@
                         <a:defRPr sz="800"/>
                       </a:pPr>
                       <a:r>
-                        <a:t>Switch 118 N FB</a:t>
+                        <a:t>Switch 11 N FB</a:t>
                       </a:r>
                     </a:p>
                   </a:txBody>
@@ -40037,7 +40046,7 @@
                         <a:defRPr sz="800"/>
                       </a:pPr>
                       <a:r>
-                        <a:t>Switch 118 R FB</a:t>
+                        <a:t>Switch 11 R FB</a:t>
                       </a:r>
                     </a:p>
                   </a:txBody>
@@ -40087,7 +40096,7 @@
                         <a:defRPr sz="800"/>
                       </a:pPr>
                       <a:r>
-                        <a:t>Switch 119 N FB</a:t>
+                        <a:t>Switch 9 N FB</a:t>
                       </a:r>
                     </a:p>
                   </a:txBody>
@@ -40137,7 +40146,7 @@
                         <a:defRPr sz="800"/>
                       </a:pPr>
                       <a:r>
-                        <a:t>Switch 119 R FB</a:t>
+                        <a:t>Switch 9 R FB</a:t>
                       </a:r>
                     </a:p>
                   </a:txBody>
@@ -40340,7 +40349,7 @@
                         <a:defRPr sz="800"/>
                       </a:pPr>
                       <a:r>
-                        <a:t>Switch 117 BTN</a:t>
+                        <a:t>Switch 7 BTN</a:t>
                       </a:r>
                     </a:p>
                   </a:txBody>
@@ -40390,7 +40399,7 @@
                         <a:defRPr sz="800"/>
                       </a:pPr>
                       <a:r>
-                        <a:t>Switch 118 BTN</a:t>
+                        <a:t>Switch 11 BTN</a:t>
                       </a:r>
                     </a:p>
                   </a:txBody>
@@ -40440,7 +40449,7 @@
                         <a:defRPr sz="800"/>
                       </a:pPr>
                       <a:r>
-                        <a:t>Switch 119 BTN</a:t>
+                        <a:t>Switch 9 BTN</a:t>
                       </a:r>
                     </a:p>
                   </a:txBody>
@@ -40834,7 +40843,7 @@
                         <a:defRPr sz="800"/>
                       </a:pPr>
                       <a:r>
-                        <a:t>Switch 118</a:t>
+                        <a:t>Switch 11</a:t>
                       </a:r>
                     </a:p>
                   </a:txBody>
@@ -40884,7 +40893,7 @@
                         <a:defRPr sz="800"/>
                       </a:pPr>
                       <a:r>
-                        <a:t>Switch 117 (TO8)</a:t>
+                        <a:t>Switch 7 (TO8)</a:t>
                       </a:r>
                     </a:p>
                   </a:txBody>
@@ -40934,7 +40943,7 @@
                         <a:defRPr sz="800"/>
                       </a:pPr>
                       <a:r>
-                        <a:t>Switch 117 (TO6)</a:t>
+                        <a:t>Switch 7 (TO6)</a:t>
                       </a:r>
                     </a:p>
                   </a:txBody>
@@ -41134,7 +41143,7 @@
                         <a:defRPr sz="800"/>
                       </a:pPr>
                       <a:r>
-                        <a:t>Switch 119</a:t>
+                        <a:t>Switch 9</a:t>
                       </a:r>
                     </a:p>
                   </a:txBody>

</xml_diff>

<commit_message>
Put 40LA on three consecutive C11-OU3 pins; 2035/2036 sit as separate dwarfs.
Refresh the Desktop wiring pack so C1 motors show Switch 35/37/39 instead of DCC 113–115.

Co-authored-by: Cursor <cursoragent@cursor.com>
</commit_message>
<xml_diff>
--- a/docs/wiring/Wiring_Schematic.pptx
+++ b/docs/wiring/Wiring_Schematic.pptx
@@ -34814,7 +34814,7 @@
                         <a:defRPr sz="800"/>
                       </a:pPr>
                       <a:r>
-                        <a:t>Head 40LA G</a:t>
+                        <a:t>Head 2035 R</a:t>
                       </a:r>
                     </a:p>
                   </a:txBody>
@@ -34973,6 +34973,156 @@
                         <a:defRPr sz="800"/>
                       </a:pPr>
                       <a:r>
+                        <a:t>Head 40LA G</a:t>
+                      </a:r>
+                    </a:p>
+                  </a:txBody>
+                  <a:tcPr anchor="t"/>
+                </a:tc>
+              </a:tr>
+              <a:tr h="172720">
+                <a:tc>
+                  <a:txBody>
+                    <a:bodyPr/>
+                    <a:lstStyle/>
+                    <a:p>
+                      <a:pPr>
+                        <a:lnSpc>
+                          <a:spcPct val="90000"/>
+                        </a:lnSpc>
+                        <a:spcBef>
+                          <a:spcPts val="0"/>
+                        </a:spcBef>
+                        <a:spcAft>
+                          <a:spcPts val="0"/>
+                        </a:spcAft>
+                        <a:defRPr sz="800"/>
+                      </a:pPr>
+                      <a:r>
+                        <a:t>C11-OU3-2</a:t>
+                      </a:r>
+                    </a:p>
+                  </a:txBody>
+                  <a:tcPr anchor="t"/>
+                </a:tc>
+                <a:tc>
+                  <a:txBody>
+                    <a:bodyPr/>
+                    <a:lstStyle/>
+                    <a:p>
+                      <a:pPr>
+                        <a:lnSpc>
+                          <a:spcPct val="90000"/>
+                        </a:lnSpc>
+                        <a:spcBef>
+                          <a:spcPts val="0"/>
+                        </a:spcBef>
+                        <a:spcAft>
+                          <a:spcPts val="0"/>
+                        </a:spcAft>
+                        <a:defRPr sz="800"/>
+                      </a:pPr>
+                      <a:r>
+                        <a:t>Head 40LA Y</a:t>
+                      </a:r>
+                    </a:p>
+                  </a:txBody>
+                  <a:tcPr anchor="t"/>
+                </a:tc>
+              </a:tr>
+              <a:tr h="172720">
+                <a:tc>
+                  <a:txBody>
+                    <a:bodyPr/>
+                    <a:lstStyle/>
+                    <a:p>
+                      <a:pPr>
+                        <a:lnSpc>
+                          <a:spcPct val="90000"/>
+                        </a:lnSpc>
+                        <a:spcBef>
+                          <a:spcPts val="0"/>
+                        </a:spcBef>
+                        <a:spcAft>
+                          <a:spcPts val="0"/>
+                        </a:spcAft>
+                        <a:defRPr sz="800"/>
+                      </a:pPr>
+                      <a:r>
+                        <a:t>C11-OU3-3</a:t>
+                      </a:r>
+                    </a:p>
+                  </a:txBody>
+                  <a:tcPr anchor="t"/>
+                </a:tc>
+                <a:tc>
+                  <a:txBody>
+                    <a:bodyPr/>
+                    <a:lstStyle/>
+                    <a:p>
+                      <a:pPr>
+                        <a:lnSpc>
+                          <a:spcPct val="90000"/>
+                        </a:lnSpc>
+                        <a:spcBef>
+                          <a:spcPts val="0"/>
+                        </a:spcBef>
+                        <a:spcAft>
+                          <a:spcPts val="0"/>
+                        </a:spcAft>
+                        <a:defRPr sz="800"/>
+                      </a:pPr>
+                      <a:r>
+                        <a:t>Head 40LA R</a:t>
+                      </a:r>
+                    </a:p>
+                  </a:txBody>
+                  <a:tcPr anchor="t"/>
+                </a:tc>
+              </a:tr>
+              <a:tr h="172720">
+                <a:tc>
+                  <a:txBody>
+                    <a:bodyPr/>
+                    <a:lstStyle/>
+                    <a:p>
+                      <a:pPr>
+                        <a:lnSpc>
+                          <a:spcPct val="90000"/>
+                        </a:lnSpc>
+                        <a:spcBef>
+                          <a:spcPts val="0"/>
+                        </a:spcBef>
+                        <a:spcAft>
+                          <a:spcPts val="0"/>
+                        </a:spcAft>
+                        <a:defRPr sz="800"/>
+                      </a:pPr>
+                      <a:r>
+                        <a:t>C11-OU3-4</a:t>
+                      </a:r>
+                    </a:p>
+                  </a:txBody>
+                  <a:tcPr anchor="t"/>
+                </a:tc>
+                <a:tc>
+                  <a:txBody>
+                    <a:bodyPr/>
+                    <a:lstStyle/>
+                    <a:p>
+                      <a:pPr>
+                        <a:lnSpc>
+                          <a:spcPct val="90000"/>
+                        </a:lnSpc>
+                        <a:spcBef>
+                          <a:spcPts val="0"/>
+                        </a:spcBef>
+                        <a:spcAft>
+                          <a:spcPts val="0"/>
+                        </a:spcAft>
+                        <a:defRPr sz="800"/>
+                      </a:pPr>
+                      <a:r>
                         <a:t>Head 2036 G</a:t>
                       </a:r>
                     </a:p>
@@ -34999,7 +35149,7 @@
                         <a:defRPr sz="800"/>
                       </a:pPr>
                       <a:r>
-                        <a:t>C11-OU3-2</a:t>
+                        <a:t>C11-OU3-5</a:t>
                       </a:r>
                     </a:p>
                   </a:txBody>
@@ -35049,7 +35199,7 @@
                         <a:defRPr sz="800"/>
                       </a:pPr>
                       <a:r>
-                        <a:t>C11-OU3-3</a:t>
+                        <a:t>C11-OU3-6</a:t>
                       </a:r>
                     </a:p>
                   </a:txBody>
@@ -35099,7 +35249,7 @@
                         <a:defRPr sz="800"/>
                       </a:pPr>
                       <a:r>
-                        <a:t>C11-OU3-4</a:t>
+                        <a:t>C11-OU3-7</a:t>
                       </a:r>
                     </a:p>
                   </a:txBody>
@@ -35149,7 +35299,7 @@
                         <a:defRPr sz="800"/>
                       </a:pPr>
                       <a:r>
-                        <a:t>C11-OU3-5</a:t>
+                        <a:t>C11-OU3-8</a:t>
                       </a:r>
                     </a:p>
                   </a:txBody>
@@ -35174,156 +35324,6 @@
                       </a:pPr>
                       <a:r>
                         <a:t>Head 2035 Y</a:t>
-                      </a:r>
-                    </a:p>
-                  </a:txBody>
-                  <a:tcPr anchor="t"/>
-                </a:tc>
-              </a:tr>
-              <a:tr h="172720">
-                <a:tc>
-                  <a:txBody>
-                    <a:bodyPr/>
-                    <a:lstStyle/>
-                    <a:p>
-                      <a:pPr>
-                        <a:lnSpc>
-                          <a:spcPct val="90000"/>
-                        </a:lnSpc>
-                        <a:spcBef>
-                          <a:spcPts val="0"/>
-                        </a:spcBef>
-                        <a:spcAft>
-                          <a:spcPts val="0"/>
-                        </a:spcAft>
-                        <a:defRPr sz="800"/>
-                      </a:pPr>
-                      <a:r>
-                        <a:t>C11-OU3-6</a:t>
-                      </a:r>
-                    </a:p>
-                  </a:txBody>
-                  <a:tcPr anchor="t"/>
-                </a:tc>
-                <a:tc>
-                  <a:txBody>
-                    <a:bodyPr/>
-                    <a:lstStyle/>
-                    <a:p>
-                      <a:pPr>
-                        <a:lnSpc>
-                          <a:spcPct val="90000"/>
-                        </a:lnSpc>
-                        <a:spcBef>
-                          <a:spcPts val="0"/>
-                        </a:spcBef>
-                        <a:spcAft>
-                          <a:spcPts val="0"/>
-                        </a:spcAft>
-                        <a:defRPr sz="800"/>
-                      </a:pPr>
-                      <a:r>
-                        <a:t>Head 2035 R</a:t>
-                      </a:r>
-                    </a:p>
-                  </a:txBody>
-                  <a:tcPr anchor="t"/>
-                </a:tc>
-              </a:tr>
-              <a:tr h="172720">
-                <a:tc>
-                  <a:txBody>
-                    <a:bodyPr/>
-                    <a:lstStyle/>
-                    <a:p>
-                      <a:pPr>
-                        <a:lnSpc>
-                          <a:spcPct val="90000"/>
-                        </a:lnSpc>
-                        <a:spcBef>
-                          <a:spcPts val="0"/>
-                        </a:spcBef>
-                        <a:spcAft>
-                          <a:spcPts val="0"/>
-                        </a:spcAft>
-                        <a:defRPr sz="800"/>
-                      </a:pPr>
-                      <a:r>
-                        <a:t>C11-OU3-7</a:t>
-                      </a:r>
-                    </a:p>
-                  </a:txBody>
-                  <a:tcPr anchor="t"/>
-                </a:tc>
-                <a:tc>
-                  <a:txBody>
-                    <a:bodyPr/>
-                    <a:lstStyle/>
-                    <a:p>
-                      <a:pPr>
-                        <a:lnSpc>
-                          <a:spcPct val="90000"/>
-                        </a:lnSpc>
-                        <a:spcBef>
-                          <a:spcPts val="0"/>
-                        </a:spcBef>
-                        <a:spcAft>
-                          <a:spcPts val="0"/>
-                        </a:spcAft>
-                        <a:defRPr sz="800"/>
-                      </a:pPr>
-                      <a:r>
-                        <a:t>Head 40LA R</a:t>
-                      </a:r>
-                    </a:p>
-                  </a:txBody>
-                  <a:tcPr anchor="t"/>
-                </a:tc>
-              </a:tr>
-              <a:tr h="172720">
-                <a:tc>
-                  <a:txBody>
-                    <a:bodyPr/>
-                    <a:lstStyle/>
-                    <a:p>
-                      <a:pPr>
-                        <a:lnSpc>
-                          <a:spcPct val="90000"/>
-                        </a:lnSpc>
-                        <a:spcBef>
-                          <a:spcPts val="0"/>
-                        </a:spcBef>
-                        <a:spcAft>
-                          <a:spcPts val="0"/>
-                        </a:spcAft>
-                        <a:defRPr sz="800"/>
-                      </a:pPr>
-                      <a:r>
-                        <a:t>C11-OU3-8</a:t>
-                      </a:r>
-                    </a:p>
-                  </a:txBody>
-                  <a:tcPr anchor="t"/>
-                </a:tc>
-                <a:tc>
-                  <a:txBody>
-                    <a:bodyPr/>
-                    <a:lstStyle/>
-                    <a:p>
-                      <a:pPr>
-                        <a:lnSpc>
-                          <a:spcPct val="90000"/>
-                        </a:lnSpc>
-                        <a:spcBef>
-                          <a:spcPts val="0"/>
-                        </a:spcBef>
-                        <a:spcAft>
-                          <a:spcPts val="0"/>
-                        </a:spcAft>
-                        <a:defRPr sz="800"/>
-                      </a:pPr>
-                      <a:r>
-                        <a:t>Head 40LA Y</a:t>
                       </a:r>
                     </a:p>
                   </a:txBody>

</xml_diff>

<commit_message>
Drop leftover C3 S3 RGB (and OU3) and label remaining S4/S5/S6 as CP4–CP6 heads.
Switch 15–21 are motors only; v8 switch columns use CTC names. S4-4/S4-5 share SW138; S5-6/S5-7 are reverse heads on DJE/SW124.

Co-authored-by: Cursor <cursoragent@cursor.com>
</commit_message>
<xml_diff>
--- a/docs/wiring/Wiring_Schematic.pptx
+++ b/docs/wiring/Wiring_Schematic.pptx
@@ -3635,7 +3635,7 @@
                         <a:defRPr sz="1000"/>
                       </a:pPr>
                       <a:r>
-                        <a:t>2</a:t>
+                        <a:t>1</a:t>
                       </a:r>
                     </a:p>
                   </a:txBody>
@@ -5492,7 +5492,7 @@
                         <a:defRPr sz="800"/>
                       </a:pPr>
                       <a:r>
-                        <a:t>S6-2 G</a:t>
+                        <a:t>Head S6-2 G</a:t>
                       </a:r>
                     </a:p>
                   </a:txBody>
@@ -5542,7 +5542,7 @@
                         <a:defRPr sz="800"/>
                       </a:pPr>
                       <a:r>
-                        <a:t>S6-2 Y</a:t>
+                        <a:t>Head S6-2 Y</a:t>
                       </a:r>
                     </a:p>
                   </a:txBody>
@@ -5592,7 +5592,7 @@
                         <a:defRPr sz="800"/>
                       </a:pPr>
                       <a:r>
-                        <a:t>S6-2 R</a:t>
+                        <a:t>Head S6-2 R</a:t>
                       </a:r>
                     </a:p>
                   </a:txBody>
@@ -5642,7 +5642,7 @@
                         <a:defRPr sz="800"/>
                       </a:pPr>
                       <a:r>
-                        <a:t>S6-13 G</a:t>
+                        <a:t>Head S6-13 G</a:t>
                       </a:r>
                     </a:p>
                   </a:txBody>
@@ -5692,7 +5692,7 @@
                         <a:defRPr sz="800"/>
                       </a:pPr>
                       <a:r>
-                        <a:t>S6-13 R</a:t>
+                        <a:t>Head S6-13 R</a:t>
                       </a:r>
                     </a:p>
                   </a:txBody>
@@ -5742,7 +5742,7 @@
                         <a:defRPr sz="800"/>
                       </a:pPr>
                       <a:r>
-                        <a:t>S6-13 Y</a:t>
+                        <a:t>Head S6-13 Y</a:t>
                       </a:r>
                     </a:p>
                   </a:txBody>
@@ -5792,7 +5792,7 @@
                         <a:defRPr sz="800"/>
                       </a:pPr>
                       <a:r>
-                        <a:t>S6-11 Y</a:t>
+                        <a:t>Head S6-11 Y</a:t>
                       </a:r>
                     </a:p>
                   </a:txBody>
@@ -5951,7 +5951,7 @@
                         <a:defRPr sz="800"/>
                       </a:pPr>
                       <a:r>
-                        <a:t>S6-1 G</a:t>
+                        <a:t>Head S6-1 G</a:t>
                       </a:r>
                     </a:p>
                   </a:txBody>
@@ -6001,7 +6001,7 @@
                         <a:defRPr sz="800"/>
                       </a:pPr>
                       <a:r>
-                        <a:t>S6-1 Y</a:t>
+                        <a:t>Head S6-1 Y</a:t>
                       </a:r>
                     </a:p>
                   </a:txBody>
@@ -6051,7 +6051,7 @@
                         <a:defRPr sz="800"/>
                       </a:pPr>
                       <a:r>
-                        <a:t>S6-1 R</a:t>
+                        <a:t>Head S6-1 R</a:t>
                       </a:r>
                     </a:p>
                   </a:txBody>
@@ -6101,7 +6101,7 @@
                         <a:defRPr sz="800"/>
                       </a:pPr>
                       <a:r>
-                        <a:t>S6-5 G</a:t>
+                        <a:t>Head S6-5 G</a:t>
                       </a:r>
                     </a:p>
                   </a:txBody>
@@ -6151,7 +6151,7 @@
                         <a:defRPr sz="800"/>
                       </a:pPr>
                       <a:r>
-                        <a:t>S6-5 Y</a:t>
+                        <a:t>Head S6-5 Y</a:t>
                       </a:r>
                     </a:p>
                   </a:txBody>
@@ -6201,7 +6201,7 @@
                         <a:defRPr sz="800"/>
                       </a:pPr>
                       <a:r>
-                        <a:t>S6-5 R</a:t>
+                        <a:t>Head S6-5 R</a:t>
                       </a:r>
                     </a:p>
                   </a:txBody>
@@ -6251,7 +6251,7 @@
                         <a:defRPr sz="800"/>
                       </a:pPr>
                       <a:r>
-                        <a:t>S6-11 G</a:t>
+                        <a:t>Head S6-11 G</a:t>
                       </a:r>
                     </a:p>
                   </a:txBody>
@@ -6301,7 +6301,7 @@
                         <a:defRPr sz="800"/>
                       </a:pPr>
                       <a:r>
-                        <a:t>S6-11 R</a:t>
+                        <a:t>Head S6-11 R</a:t>
                       </a:r>
                     </a:p>
                   </a:txBody>
@@ -8283,7 +8283,7 @@
                         <a:defRPr sz="800"/>
                       </a:pPr>
                       <a:r>
-                        <a:t>S4-1 G</a:t>
+                        <a:t>Head S4-1 G</a:t>
                       </a:r>
                     </a:p>
                   </a:txBody>
@@ -8333,7 +8333,7 @@
                         <a:defRPr sz="800"/>
                       </a:pPr>
                       <a:r>
-                        <a:t>S4-1 Y</a:t>
+                        <a:t>Head S4-1 Y</a:t>
                       </a:r>
                     </a:p>
                   </a:txBody>
@@ -8383,7 +8383,7 @@
                         <a:defRPr sz="800"/>
                       </a:pPr>
                       <a:r>
-                        <a:t>S4-1 R</a:t>
+                        <a:t>Head S4-1 R</a:t>
                       </a:r>
                     </a:p>
                   </a:txBody>
@@ -8433,7 +8433,7 @@
                         <a:defRPr sz="800"/>
                       </a:pPr>
                       <a:r>
-                        <a:t>S4-2 G</a:t>
+                        <a:t>Head S4-2 G</a:t>
                       </a:r>
                     </a:p>
                   </a:txBody>
@@ -8483,7 +8483,7 @@
                         <a:defRPr sz="800"/>
                       </a:pPr>
                       <a:r>
-                        <a:t>S4-2 Y</a:t>
+                        <a:t>Head S4-2 Y</a:t>
                       </a:r>
                     </a:p>
                   </a:txBody>
@@ -8533,7 +8533,7 @@
                         <a:defRPr sz="800"/>
                       </a:pPr>
                       <a:r>
-                        <a:t>S4-2 R</a:t>
+                        <a:t>Head S4-2 R</a:t>
                       </a:r>
                     </a:p>
                   </a:txBody>
@@ -8583,7 +8583,7 @@
                         <a:defRPr sz="800"/>
                       </a:pPr>
                       <a:r>
-                        <a:t>S4-5 Y</a:t>
+                        <a:t>Head S4-5 Y</a:t>
                       </a:r>
                     </a:p>
                   </a:txBody>
@@ -8742,7 +8742,7 @@
                         <a:defRPr sz="800"/>
                       </a:pPr>
                       <a:r>
-                        <a:t>S4-3 G</a:t>
+                        <a:t>Head S4-3 G</a:t>
                       </a:r>
                     </a:p>
                   </a:txBody>
@@ -8792,7 +8792,7 @@
                         <a:defRPr sz="800"/>
                       </a:pPr>
                       <a:r>
-                        <a:t>S4-3 Y</a:t>
+                        <a:t>Head S4-3 Y</a:t>
                       </a:r>
                     </a:p>
                   </a:txBody>
@@ -8842,7 +8842,7 @@
                         <a:defRPr sz="800"/>
                       </a:pPr>
                       <a:r>
-                        <a:t>S4-3 R</a:t>
+                        <a:t>Head S4-3 R</a:t>
                       </a:r>
                     </a:p>
                   </a:txBody>
@@ -8892,7 +8892,7 @@
                         <a:defRPr sz="800"/>
                       </a:pPr>
                       <a:r>
-                        <a:t>S4-4 G</a:t>
+                        <a:t>Head S4-4 G</a:t>
                       </a:r>
                     </a:p>
                   </a:txBody>
@@ -8942,7 +8942,7 @@
                         <a:defRPr sz="800"/>
                       </a:pPr>
                       <a:r>
-                        <a:t>S4-4 Y</a:t>
+                        <a:t>Head S4-4 Y</a:t>
                       </a:r>
                     </a:p>
                   </a:txBody>
@@ -8992,7 +8992,7 @@
                         <a:defRPr sz="800"/>
                       </a:pPr>
                       <a:r>
-                        <a:t>S4-4 R</a:t>
+                        <a:t>Head S4-4 R</a:t>
                       </a:r>
                     </a:p>
                   </a:txBody>
@@ -9042,7 +9042,7 @@
                         <a:defRPr sz="800"/>
                       </a:pPr>
                       <a:r>
-                        <a:t>S4-5 G</a:t>
+                        <a:t>Head S4-5 G</a:t>
                       </a:r>
                     </a:p>
                   </a:txBody>
@@ -9092,7 +9092,7 @@
                         <a:defRPr sz="800"/>
                       </a:pPr>
                       <a:r>
-                        <a:t>S4-5 R</a:t>
+                        <a:t>Head S4-5 R</a:t>
                       </a:r>
                     </a:p>
                   </a:txBody>
@@ -11074,7 +11074,7 @@
                         <a:defRPr sz="800"/>
                       </a:pPr>
                       <a:r>
-                        <a:t>S5-1 G</a:t>
+                        <a:t>Head S5-1 G</a:t>
                       </a:r>
                     </a:p>
                   </a:txBody>
@@ -11124,7 +11124,7 @@
                         <a:defRPr sz="800"/>
                       </a:pPr>
                       <a:r>
-                        <a:t>S5-1 Y</a:t>
+                        <a:t>Head S5-1 Y</a:t>
                       </a:r>
                     </a:p>
                   </a:txBody>
@@ -11174,7 +11174,7 @@
                         <a:defRPr sz="800"/>
                       </a:pPr>
                       <a:r>
-                        <a:t>S5-1 R</a:t>
+                        <a:t>Head S5-1 R</a:t>
                       </a:r>
                     </a:p>
                   </a:txBody>
@@ -11224,7 +11224,7 @@
                         <a:defRPr sz="800"/>
                       </a:pPr>
                       <a:r>
-                        <a:t>S5-2 G</a:t>
+                        <a:t>Head S5-2 G</a:t>
                       </a:r>
                     </a:p>
                   </a:txBody>
@@ -11274,7 +11274,7 @@
                         <a:defRPr sz="800"/>
                       </a:pPr>
                       <a:r>
-                        <a:t>S5-2 Y</a:t>
+                        <a:t>Head S5-2 Y</a:t>
                       </a:r>
                     </a:p>
                   </a:txBody>
@@ -11324,7 +11324,7 @@
                         <a:defRPr sz="800"/>
                       </a:pPr>
                       <a:r>
-                        <a:t>S5-2 R</a:t>
+                        <a:t>Head S5-2 R</a:t>
                       </a:r>
                     </a:p>
                   </a:txBody>
@@ -11374,7 +11374,7 @@
                         <a:defRPr sz="800"/>
                       </a:pPr>
                       <a:r>
-                        <a:t>S5-5 Y</a:t>
+                        <a:t>Head S5-5 Y</a:t>
                       </a:r>
                     </a:p>
                   </a:txBody>
@@ -11533,7 +11533,7 @@
                         <a:defRPr sz="800"/>
                       </a:pPr>
                       <a:r>
-                        <a:t>S5-3 G</a:t>
+                        <a:t>Head S5-3 G</a:t>
                       </a:r>
                     </a:p>
                   </a:txBody>
@@ -11583,7 +11583,7 @@
                         <a:defRPr sz="800"/>
                       </a:pPr>
                       <a:r>
-                        <a:t>S5-3 Y</a:t>
+                        <a:t>Head S5-3 Y</a:t>
                       </a:r>
                     </a:p>
                   </a:txBody>
@@ -11633,7 +11633,7 @@
                         <a:defRPr sz="800"/>
                       </a:pPr>
                       <a:r>
-                        <a:t>S5-3 R</a:t>
+                        <a:t>Head S5-3 R</a:t>
                       </a:r>
                     </a:p>
                   </a:txBody>
@@ -11683,7 +11683,7 @@
                         <a:defRPr sz="800"/>
                       </a:pPr>
                       <a:r>
-                        <a:t>S5-4 G</a:t>
+                        <a:t>Head S5-4 G</a:t>
                       </a:r>
                     </a:p>
                   </a:txBody>
@@ -11733,7 +11733,7 @@
                         <a:defRPr sz="800"/>
                       </a:pPr>
                       <a:r>
-                        <a:t>S5-4 Y</a:t>
+                        <a:t>Head S5-4 Y</a:t>
                       </a:r>
                     </a:p>
                   </a:txBody>
@@ -11783,7 +11783,7 @@
                         <a:defRPr sz="800"/>
                       </a:pPr>
                       <a:r>
-                        <a:t>S5-4 R</a:t>
+                        <a:t>Head S5-4 R</a:t>
                       </a:r>
                     </a:p>
                   </a:txBody>
@@ -11833,7 +11833,7 @@
                         <a:defRPr sz="800"/>
                       </a:pPr>
                       <a:r>
-                        <a:t>S5-5 G</a:t>
+                        <a:t>Head S5-5 G</a:t>
                       </a:r>
                     </a:p>
                   </a:txBody>
@@ -11883,7 +11883,7 @@
                         <a:defRPr sz="800"/>
                       </a:pPr>
                       <a:r>
-                        <a:t>S5-5 R</a:t>
+                        <a:t>Head S5-5 R</a:t>
                       </a:r>
                     </a:p>
                   </a:txBody>
@@ -13850,7 +13850,7 @@
                         <a:defRPr sz="800"/>
                       </a:pPr>
                       <a:r>
-                        <a:t>S6-6 G</a:t>
+                        <a:t>Head S6-6 G</a:t>
                       </a:r>
                     </a:p>
                   </a:txBody>
@@ -13900,7 +13900,7 @@
                         <a:defRPr sz="800"/>
                       </a:pPr>
                       <a:r>
-                        <a:t>S6-6 Y</a:t>
+                        <a:t>Head S6-6 Y</a:t>
                       </a:r>
                     </a:p>
                   </a:txBody>
@@ -13950,7 +13950,7 @@
                         <a:defRPr sz="800"/>
                       </a:pPr>
                       <a:r>
-                        <a:t>S6-6 R</a:t>
+                        <a:t>Head S6-6 R</a:t>
                       </a:r>
                     </a:p>
                   </a:txBody>
@@ -14000,7 +14000,7 @@
                         <a:defRPr sz="800"/>
                       </a:pPr>
                       <a:r>
-                        <a:t>S6-8 G</a:t>
+                        <a:t>Head S6-8 G</a:t>
                       </a:r>
                     </a:p>
                   </a:txBody>
@@ -14050,7 +14050,7 @@
                         <a:defRPr sz="800"/>
                       </a:pPr>
                       <a:r>
-                        <a:t>S6-8 Y</a:t>
+                        <a:t>Head S6-8 Y</a:t>
                       </a:r>
                     </a:p>
                   </a:txBody>
@@ -14100,7 +14100,7 @@
                         <a:defRPr sz="800"/>
                       </a:pPr>
                       <a:r>
-                        <a:t>S6-8 R</a:t>
+                        <a:t>Head S6-8 R</a:t>
                       </a:r>
                     </a:p>
                   </a:txBody>
@@ -14150,7 +14150,7 @@
                         <a:defRPr sz="800"/>
                       </a:pPr>
                       <a:r>
-                        <a:t>S6-12 Y</a:t>
+                        <a:t>Head S6-12 Y</a:t>
                       </a:r>
                     </a:p>
                   </a:txBody>
@@ -14309,7 +14309,7 @@
                         <a:defRPr sz="800"/>
                       </a:pPr>
                       <a:r>
-                        <a:t>S6-15 G</a:t>
+                        <a:t>Head S6-15 G</a:t>
                       </a:r>
                     </a:p>
                   </a:txBody>
@@ -14359,7 +14359,7 @@
                         <a:defRPr sz="800"/>
                       </a:pPr>
                       <a:r>
-                        <a:t>S6-15 R</a:t>
+                        <a:t>Head S6-15 R</a:t>
                       </a:r>
                     </a:p>
                   </a:txBody>
@@ -14409,7 +14409,7 @@
                         <a:defRPr sz="800"/>
                       </a:pPr>
                       <a:r>
-                        <a:t>S6-15 Y</a:t>
+                        <a:t>Head S6-15 Y</a:t>
                       </a:r>
                     </a:p>
                   </a:txBody>
@@ -14459,7 +14459,7 @@
                         <a:defRPr sz="800"/>
                       </a:pPr>
                       <a:r>
-                        <a:t>S6-14 G</a:t>
+                        <a:t>Head S6-14 G</a:t>
                       </a:r>
                     </a:p>
                   </a:txBody>
@@ -14509,7 +14509,7 @@
                         <a:defRPr sz="800"/>
                       </a:pPr>
                       <a:r>
-                        <a:t>S6-14 R</a:t>
+                        <a:t>Head S6-14 R</a:t>
                       </a:r>
                     </a:p>
                   </a:txBody>
@@ -14559,7 +14559,7 @@
                         <a:defRPr sz="800"/>
                       </a:pPr>
                       <a:r>
-                        <a:t>S6-14 Y</a:t>
+                        <a:t>Head S6-14 Y</a:t>
                       </a:r>
                     </a:p>
                   </a:txBody>
@@ -14609,7 +14609,7 @@
                         <a:defRPr sz="800"/>
                       </a:pPr>
                       <a:r>
-                        <a:t>S6-12 G</a:t>
+                        <a:t>Head S6-12 G</a:t>
                       </a:r>
                     </a:p>
                   </a:txBody>
@@ -14659,7 +14659,7 @@
                         <a:defRPr sz="800"/>
                       </a:pPr>
                       <a:r>
-                        <a:t>S6-12 R</a:t>
+                        <a:t>Head S6-12 R</a:t>
                       </a:r>
                     </a:p>
                   </a:txBody>
@@ -16029,7 +16029,7 @@
                         <a:defRPr sz="800"/>
                       </a:pPr>
                       <a:r>
-                        <a:t>S6-10 G</a:t>
+                        <a:t>Head S6-10 G</a:t>
                       </a:r>
                     </a:p>
                   </a:txBody>
@@ -16079,7 +16079,7 @@
                         <a:defRPr sz="800"/>
                       </a:pPr>
                       <a:r>
-                        <a:t>S6-10 R</a:t>
+                        <a:t>Head S6-10 R</a:t>
                       </a:r>
                     </a:p>
                   </a:txBody>
@@ -16188,7 +16188,7 @@
                         <a:defRPr sz="800"/>
                       </a:pPr>
                       <a:r>
-                        <a:t>S6-3 G</a:t>
+                        <a:t>Head S6-3 G</a:t>
                       </a:r>
                     </a:p>
                   </a:txBody>
@@ -16238,7 +16238,7 @@
                         <a:defRPr sz="800"/>
                       </a:pPr>
                       <a:r>
-                        <a:t>S6-3 Y</a:t>
+                        <a:t>Head S6-3 Y</a:t>
                       </a:r>
                     </a:p>
                   </a:txBody>
@@ -16288,7 +16288,7 @@
                         <a:defRPr sz="800"/>
                       </a:pPr>
                       <a:r>
-                        <a:t>S6-3 R</a:t>
+                        <a:t>Head S6-3 R</a:t>
                       </a:r>
                     </a:p>
                   </a:txBody>
@@ -16338,7 +16338,7 @@
                         <a:defRPr sz="800"/>
                       </a:pPr>
                       <a:r>
-                        <a:t>S6-9 G</a:t>
+                        <a:t>Head S6-9 G</a:t>
                       </a:r>
                     </a:p>
                   </a:txBody>
@@ -16388,7 +16388,7 @@
                         <a:defRPr sz="800"/>
                       </a:pPr>
                       <a:r>
-                        <a:t>S6-9 Y</a:t>
+                        <a:t>Head S6-9 Y</a:t>
                       </a:r>
                     </a:p>
                   </a:txBody>
@@ -16438,7 +16438,7 @@
                         <a:defRPr sz="800"/>
                       </a:pPr>
                       <a:r>
-                        <a:t>S6-9 R</a:t>
+                        <a:t>Head S6-9 R</a:t>
                       </a:r>
                     </a:p>
                   </a:txBody>
@@ -16488,7 +16488,7 @@
                         <a:defRPr sz="800"/>
                       </a:pPr>
                       <a:r>
-                        <a:t>S6-10 Y</a:t>
+                        <a:t>Head S6-10 Y</a:t>
                       </a:r>
                     </a:p>
                   </a:txBody>
@@ -16647,7 +16647,7 @@
                         <a:defRPr sz="800"/>
                       </a:pPr>
                       <a:r>
-                        <a:t>S6-4 G</a:t>
+                        <a:t>Head S6-4 G</a:t>
                       </a:r>
                     </a:p>
                   </a:txBody>
@@ -16697,7 +16697,7 @@
                         <a:defRPr sz="800"/>
                       </a:pPr>
                       <a:r>
-                        <a:t>S6-4 Y</a:t>
+                        <a:t>Head S6-4 Y</a:t>
                       </a:r>
                     </a:p>
                   </a:txBody>
@@ -16747,7 +16747,7 @@
                         <a:defRPr sz="800"/>
                       </a:pPr>
                       <a:r>
-                        <a:t>S6-4 R</a:t>
+                        <a:t>Head S6-4 R</a:t>
                       </a:r>
                     </a:p>
                   </a:txBody>
@@ -16797,7 +16797,7 @@
                         <a:defRPr sz="800"/>
                       </a:pPr>
                       <a:r>
-                        <a:t>S6-7 G</a:t>
+                        <a:t>Head S6-7 G</a:t>
                       </a:r>
                     </a:p>
                   </a:txBody>
@@ -16847,7 +16847,7 @@
                         <a:defRPr sz="800"/>
                       </a:pPr>
                       <a:r>
-                        <a:t>S6-7 Y</a:t>
+                        <a:t>Head S6-7 Y</a:t>
                       </a:r>
                     </a:p>
                   </a:txBody>
@@ -16897,7 +16897,7 @@
                         <a:defRPr sz="800"/>
                       </a:pPr>
                       <a:r>
-                        <a:t>S6-7 R</a:t>
+                        <a:t>Head S6-7 R</a:t>
                       </a:r>
                     </a:p>
                   </a:txBody>
@@ -18946,7 +18946,7 @@
                         <a:defRPr sz="800"/>
                       </a:pPr>
                       <a:r>
-                        <a:t>S5-6 G</a:t>
+                        <a:t>Head S5-6 G</a:t>
                       </a:r>
                     </a:p>
                   </a:txBody>
@@ -18996,7 +18996,7 @@
                         <a:defRPr sz="800"/>
                       </a:pPr>
                       <a:r>
-                        <a:t>S5-6 Y</a:t>
+                        <a:t>Head S5-6 Y</a:t>
                       </a:r>
                     </a:p>
                   </a:txBody>
@@ -19046,7 +19046,7 @@
                         <a:defRPr sz="800"/>
                       </a:pPr>
                       <a:r>
-                        <a:t>S5-6 R</a:t>
+                        <a:t>Head S5-6 R</a:t>
                       </a:r>
                     </a:p>
                   </a:txBody>
@@ -19096,7 +19096,7 @@
                         <a:defRPr sz="800"/>
                       </a:pPr>
                       <a:r>
-                        <a:t>S5-7 G</a:t>
+                        <a:t>Head S5-7 G</a:t>
                       </a:r>
                     </a:p>
                   </a:txBody>
@@ -19146,7 +19146,7 @@
                         <a:defRPr sz="800"/>
                       </a:pPr>
                       <a:r>
-                        <a:t>S5-7 R</a:t>
+                        <a:t>Head S5-7 R</a:t>
                       </a:r>
                     </a:p>
                   </a:txBody>
@@ -19196,7 +19196,7 @@
                         <a:defRPr sz="800"/>
                       </a:pPr>
                       <a:r>
-                        <a:t>S5-7 Y</a:t>
+                        <a:t>Head S5-7 Y</a:t>
                       </a:r>
                     </a:p>
                   </a:txBody>
@@ -19828,9 +19828,6 @@
                       <a:pPr>
                         <a:defRPr sz="800"/>
                       </a:pPr>
-                      <a:r>
-                        <a:t>S3-10, S3-7</a:t>
-                      </a:r>
                     </a:p>
                   </a:txBody>
                   <a:tcPr>
@@ -19909,9 +19906,6 @@
                       <a:pPr>
                         <a:defRPr sz="800"/>
                       </a:pPr>
-                      <a:r>
-                        <a:t>S3-11</a:t>
-                      </a:r>
                     </a:p>
                   </a:txBody>
                   <a:tcPr/>
@@ -20002,9 +19996,6 @@
                       <a:pPr>
                         <a:defRPr sz="800"/>
                       </a:pPr>
-                      <a:r>
-                        <a:t>S3-12</a:t>
-                      </a:r>
                     </a:p>
                   </a:txBody>
                   <a:tcPr>
@@ -20083,9 +20074,6 @@
                       <a:pPr>
                         <a:defRPr sz="800"/>
                       </a:pPr>
-                      <a:r>
-                        <a:t>S3-13</a:t>
-                      </a:r>
                     </a:p>
                   </a:txBody>
                   <a:tcPr/>
@@ -28937,9 +28925,6 @@
                         </a:spcAft>
                         <a:defRPr sz="800"/>
                       </a:pPr>
-                      <a:r>
-                        <a:t>S3-6 G</a:t>
-                      </a:r>
                     </a:p>
                   </a:txBody>
                   <a:tcPr anchor="t"/>
@@ -28987,9 +28972,6 @@
                         </a:spcAft>
                         <a:defRPr sz="800"/>
                       </a:pPr>
-                      <a:r>
-                        <a:t>S3-6 Y</a:t>
-                      </a:r>
                     </a:p>
                   </a:txBody>
                   <a:tcPr anchor="t"/>
@@ -29037,9 +29019,6 @@
                         </a:spcAft>
                         <a:defRPr sz="800"/>
                       </a:pPr>
-                      <a:r>
-                        <a:t>S3-6 R</a:t>
-                      </a:r>
                     </a:p>
                   </a:txBody>
                   <a:tcPr anchor="t"/>
@@ -29087,9 +29066,6 @@
                         </a:spcAft>
                         <a:defRPr sz="800"/>
                       </a:pPr>
-                      <a:r>
-                        <a:t>S3-7 G</a:t>
-                      </a:r>
                     </a:p>
                   </a:txBody>
                   <a:tcPr anchor="t"/>
@@ -29137,9 +29113,6 @@
                         </a:spcAft>
                         <a:defRPr sz="800"/>
                       </a:pPr>
-                      <a:r>
-                        <a:t>S3-7 Y</a:t>
-                      </a:r>
                     </a:p>
                   </a:txBody>
                   <a:tcPr anchor="t"/>
@@ -29187,9 +29160,6 @@
                         </a:spcAft>
                         <a:defRPr sz="800"/>
                       </a:pPr>
-                      <a:r>
-                        <a:t>S3-7 R</a:t>
-                      </a:r>
                     </a:p>
                   </a:txBody>
                   <a:tcPr anchor="t"/>
@@ -29237,9 +29207,6 @@
                         </a:spcAft>
                         <a:defRPr sz="800"/>
                       </a:pPr>
-                      <a:r>
-                        <a:t>S3-11 Y</a:t>
-                      </a:r>
                     </a:p>
                   </a:txBody>
                   <a:tcPr anchor="t"/>
@@ -29302,465 +29269,6 @@
       <p:graphicFrame>
         <p:nvGraphicFramePr>
           <p:cNvPr id="5" name="Table 4"/>
-          <p:cNvGraphicFramePr>
-            <a:graphicFrameLocks noGrp="1"/>
-          </p:cNvGraphicFramePr>
-          <p:nvPr/>
-        </p:nvGraphicFramePr>
-        <p:xfrm>
-          <a:off x="457200" y="4818888"/>
-          <a:ext cx="4114800" cy="1554480"/>
-        </p:xfrm>
-        <a:graphic>
-          <a:graphicData uri="http://schemas.openxmlformats.org/drawingml/2006/table">
-            <a:tbl>
-              <a:tblPr firstRow="1" bandRow="1">
-                <a:tableStyleId>{5C22544A-7EE6-4342-B048-85BDC9FD1C3A}</a:tableStyleId>
-              </a:tblPr>
-              <a:tblGrid>
-                <a:gridCol w="2057400"/>
-                <a:gridCol w="2057400"/>
-              </a:tblGrid>
-              <a:tr h="172720">
-                <a:tc gridSpan="2">
-                  <a:txBody>
-                    <a:bodyPr/>
-                    <a:lstStyle/>
-                    <a:p>
-                      <a:pPr algn="ctr">
-                        <a:defRPr b="1" sz="1000">
-                          <a:solidFill>
-                            <a:srgbClr val="FFFFFF"/>
-                          </a:solidFill>
-                        </a:defRPr>
-                      </a:pPr>
-                      <a:r>
-                        <a:t>C3-OU3</a:t>
-                      </a:r>
-                    </a:p>
-                  </a:txBody>
-                  <a:tcPr>
-                    <a:solidFill>
-                      <a:srgbClr val="4472C4"/>
-                    </a:solidFill>
-                  </a:tcPr>
-                </a:tc>
-                <a:tc hMerge="1">
-                  <a:txBody>
-                    <a:bodyPr/>
-                    <a:lstStyle/>
-                    <a:p/>
-                  </a:txBody>
-                  <a:tcPr/>
-                </a:tc>
-              </a:tr>
-              <a:tr h="172720">
-                <a:tc>
-                  <a:txBody>
-                    <a:bodyPr/>
-                    <a:lstStyle/>
-                    <a:p>
-                      <a:pPr>
-                        <a:lnSpc>
-                          <a:spcPct val="90000"/>
-                        </a:lnSpc>
-                        <a:spcBef>
-                          <a:spcPts val="0"/>
-                        </a:spcBef>
-                        <a:spcAft>
-                          <a:spcPts val="0"/>
-                        </a:spcAft>
-                        <a:defRPr sz="800"/>
-                      </a:pPr>
-                      <a:r>
-                        <a:t>C3-OU3-1</a:t>
-                      </a:r>
-                    </a:p>
-                  </a:txBody>
-                  <a:tcPr anchor="t"/>
-                </a:tc>
-                <a:tc>
-                  <a:txBody>
-                    <a:bodyPr/>
-                    <a:lstStyle/>
-                    <a:p>
-                      <a:pPr>
-                        <a:lnSpc>
-                          <a:spcPct val="90000"/>
-                        </a:lnSpc>
-                        <a:spcBef>
-                          <a:spcPts val="0"/>
-                        </a:spcBef>
-                        <a:spcAft>
-                          <a:spcPts val="0"/>
-                        </a:spcAft>
-                        <a:defRPr sz="800"/>
-                      </a:pPr>
-                      <a:r>
-                        <a:t>S3-8 G</a:t>
-                      </a:r>
-                    </a:p>
-                  </a:txBody>
-                  <a:tcPr anchor="t"/>
-                </a:tc>
-              </a:tr>
-              <a:tr h="172720">
-                <a:tc>
-                  <a:txBody>
-                    <a:bodyPr/>
-                    <a:lstStyle/>
-                    <a:p>
-                      <a:pPr>
-                        <a:lnSpc>
-                          <a:spcPct val="90000"/>
-                        </a:lnSpc>
-                        <a:spcBef>
-                          <a:spcPts val="0"/>
-                        </a:spcBef>
-                        <a:spcAft>
-                          <a:spcPts val="0"/>
-                        </a:spcAft>
-                        <a:defRPr sz="800"/>
-                      </a:pPr>
-                      <a:r>
-                        <a:t>C3-OU3-2</a:t>
-                      </a:r>
-                    </a:p>
-                  </a:txBody>
-                  <a:tcPr anchor="t"/>
-                </a:tc>
-                <a:tc>
-                  <a:txBody>
-                    <a:bodyPr/>
-                    <a:lstStyle/>
-                    <a:p>
-                      <a:pPr>
-                        <a:lnSpc>
-                          <a:spcPct val="90000"/>
-                        </a:lnSpc>
-                        <a:spcBef>
-                          <a:spcPts val="0"/>
-                        </a:spcBef>
-                        <a:spcAft>
-                          <a:spcPts val="0"/>
-                        </a:spcAft>
-                        <a:defRPr sz="800"/>
-                      </a:pPr>
-                      <a:r>
-                        <a:t>S3-8 Y</a:t>
-                      </a:r>
-                    </a:p>
-                  </a:txBody>
-                  <a:tcPr anchor="t"/>
-                </a:tc>
-              </a:tr>
-              <a:tr h="172720">
-                <a:tc>
-                  <a:txBody>
-                    <a:bodyPr/>
-                    <a:lstStyle/>
-                    <a:p>
-                      <a:pPr>
-                        <a:lnSpc>
-                          <a:spcPct val="90000"/>
-                        </a:lnSpc>
-                        <a:spcBef>
-                          <a:spcPts val="0"/>
-                        </a:spcBef>
-                        <a:spcAft>
-                          <a:spcPts val="0"/>
-                        </a:spcAft>
-                        <a:defRPr sz="800"/>
-                      </a:pPr>
-                      <a:r>
-                        <a:t>C3-OU3-3</a:t>
-                      </a:r>
-                    </a:p>
-                  </a:txBody>
-                  <a:tcPr anchor="t"/>
-                </a:tc>
-                <a:tc>
-                  <a:txBody>
-                    <a:bodyPr/>
-                    <a:lstStyle/>
-                    <a:p>
-                      <a:pPr>
-                        <a:lnSpc>
-                          <a:spcPct val="90000"/>
-                        </a:lnSpc>
-                        <a:spcBef>
-                          <a:spcPts val="0"/>
-                        </a:spcBef>
-                        <a:spcAft>
-                          <a:spcPts val="0"/>
-                        </a:spcAft>
-                        <a:defRPr sz="800"/>
-                      </a:pPr>
-                      <a:r>
-                        <a:t>S3-8 R</a:t>
-                      </a:r>
-                    </a:p>
-                  </a:txBody>
-                  <a:tcPr anchor="t"/>
-                </a:tc>
-              </a:tr>
-              <a:tr h="172720">
-                <a:tc>
-                  <a:txBody>
-                    <a:bodyPr/>
-                    <a:lstStyle/>
-                    <a:p>
-                      <a:pPr>
-                        <a:lnSpc>
-                          <a:spcPct val="90000"/>
-                        </a:lnSpc>
-                        <a:spcBef>
-                          <a:spcPts val="0"/>
-                        </a:spcBef>
-                        <a:spcAft>
-                          <a:spcPts val="0"/>
-                        </a:spcAft>
-                        <a:defRPr sz="800"/>
-                      </a:pPr>
-                      <a:r>
-                        <a:t>C3-OU3-4</a:t>
-                      </a:r>
-                    </a:p>
-                  </a:txBody>
-                  <a:tcPr anchor="t"/>
-                </a:tc>
-                <a:tc>
-                  <a:txBody>
-                    <a:bodyPr/>
-                    <a:lstStyle/>
-                    <a:p>
-                      <a:pPr>
-                        <a:lnSpc>
-                          <a:spcPct val="90000"/>
-                        </a:lnSpc>
-                        <a:spcBef>
-                          <a:spcPts val="0"/>
-                        </a:spcBef>
-                        <a:spcAft>
-                          <a:spcPts val="0"/>
-                        </a:spcAft>
-                        <a:defRPr sz="800"/>
-                      </a:pPr>
-                      <a:r>
-                        <a:t>S3-9 G</a:t>
-                      </a:r>
-                    </a:p>
-                  </a:txBody>
-                  <a:tcPr anchor="t"/>
-                </a:tc>
-              </a:tr>
-              <a:tr h="172720">
-                <a:tc>
-                  <a:txBody>
-                    <a:bodyPr/>
-                    <a:lstStyle/>
-                    <a:p>
-                      <a:pPr>
-                        <a:lnSpc>
-                          <a:spcPct val="90000"/>
-                        </a:lnSpc>
-                        <a:spcBef>
-                          <a:spcPts val="0"/>
-                        </a:spcBef>
-                        <a:spcAft>
-                          <a:spcPts val="0"/>
-                        </a:spcAft>
-                        <a:defRPr sz="800"/>
-                      </a:pPr>
-                      <a:r>
-                        <a:t>C3-OU3-5</a:t>
-                      </a:r>
-                    </a:p>
-                  </a:txBody>
-                  <a:tcPr anchor="t"/>
-                </a:tc>
-                <a:tc>
-                  <a:txBody>
-                    <a:bodyPr/>
-                    <a:lstStyle/>
-                    <a:p>
-                      <a:pPr>
-                        <a:lnSpc>
-                          <a:spcPct val="90000"/>
-                        </a:lnSpc>
-                        <a:spcBef>
-                          <a:spcPts val="0"/>
-                        </a:spcBef>
-                        <a:spcAft>
-                          <a:spcPts val="0"/>
-                        </a:spcAft>
-                        <a:defRPr sz="800"/>
-                      </a:pPr>
-                      <a:r>
-                        <a:t>S3-9 Y</a:t>
-                      </a:r>
-                    </a:p>
-                  </a:txBody>
-                  <a:tcPr anchor="t"/>
-                </a:tc>
-              </a:tr>
-              <a:tr h="172720">
-                <a:tc>
-                  <a:txBody>
-                    <a:bodyPr/>
-                    <a:lstStyle/>
-                    <a:p>
-                      <a:pPr>
-                        <a:lnSpc>
-                          <a:spcPct val="90000"/>
-                        </a:lnSpc>
-                        <a:spcBef>
-                          <a:spcPts val="0"/>
-                        </a:spcBef>
-                        <a:spcAft>
-                          <a:spcPts val="0"/>
-                        </a:spcAft>
-                        <a:defRPr sz="800"/>
-                      </a:pPr>
-                      <a:r>
-                        <a:t>C3-OU3-6</a:t>
-                      </a:r>
-                    </a:p>
-                  </a:txBody>
-                  <a:tcPr anchor="t"/>
-                </a:tc>
-                <a:tc>
-                  <a:txBody>
-                    <a:bodyPr/>
-                    <a:lstStyle/>
-                    <a:p>
-                      <a:pPr>
-                        <a:lnSpc>
-                          <a:spcPct val="90000"/>
-                        </a:lnSpc>
-                        <a:spcBef>
-                          <a:spcPts val="0"/>
-                        </a:spcBef>
-                        <a:spcAft>
-                          <a:spcPts val="0"/>
-                        </a:spcAft>
-                        <a:defRPr sz="800"/>
-                      </a:pPr>
-                      <a:r>
-                        <a:t>S3-9 R</a:t>
-                      </a:r>
-                    </a:p>
-                  </a:txBody>
-                  <a:tcPr anchor="t"/>
-                </a:tc>
-              </a:tr>
-              <a:tr h="172720">
-                <a:tc>
-                  <a:txBody>
-                    <a:bodyPr/>
-                    <a:lstStyle/>
-                    <a:p>
-                      <a:pPr>
-                        <a:lnSpc>
-                          <a:spcPct val="90000"/>
-                        </a:lnSpc>
-                        <a:spcBef>
-                          <a:spcPts val="0"/>
-                        </a:spcBef>
-                        <a:spcAft>
-                          <a:spcPts val="0"/>
-                        </a:spcAft>
-                        <a:defRPr sz="800"/>
-                      </a:pPr>
-                      <a:r>
-                        <a:t>C3-OU3-7</a:t>
-                      </a:r>
-                    </a:p>
-                  </a:txBody>
-                  <a:tcPr anchor="t"/>
-                </a:tc>
-                <a:tc>
-                  <a:txBody>
-                    <a:bodyPr/>
-                    <a:lstStyle/>
-                    <a:p>
-                      <a:pPr>
-                        <a:lnSpc>
-                          <a:spcPct val="90000"/>
-                        </a:lnSpc>
-                        <a:spcBef>
-                          <a:spcPts val="0"/>
-                        </a:spcBef>
-                        <a:spcAft>
-                          <a:spcPts val="0"/>
-                        </a:spcAft>
-                        <a:defRPr sz="800"/>
-                      </a:pPr>
-                      <a:r>
-                        <a:t>S3-11 G</a:t>
-                      </a:r>
-                    </a:p>
-                  </a:txBody>
-                  <a:tcPr anchor="t"/>
-                </a:tc>
-              </a:tr>
-              <a:tr h="172720">
-                <a:tc>
-                  <a:txBody>
-                    <a:bodyPr/>
-                    <a:lstStyle/>
-                    <a:p>
-                      <a:pPr>
-                        <a:lnSpc>
-                          <a:spcPct val="90000"/>
-                        </a:lnSpc>
-                        <a:spcBef>
-                          <a:spcPts val="0"/>
-                        </a:spcBef>
-                        <a:spcAft>
-                          <a:spcPts val="0"/>
-                        </a:spcAft>
-                        <a:defRPr sz="800"/>
-                      </a:pPr>
-                      <a:r>
-                        <a:t>C3-OU3-8</a:t>
-                      </a:r>
-                    </a:p>
-                  </a:txBody>
-                  <a:tcPr anchor="t"/>
-                </a:tc>
-                <a:tc>
-                  <a:txBody>
-                    <a:bodyPr/>
-                    <a:lstStyle/>
-                    <a:p>
-                      <a:pPr>
-                        <a:lnSpc>
-                          <a:spcPct val="90000"/>
-                        </a:lnSpc>
-                        <a:spcBef>
-                          <a:spcPts val="0"/>
-                        </a:spcBef>
-                        <a:spcAft>
-                          <a:spcPts val="0"/>
-                        </a:spcAft>
-                        <a:defRPr sz="800"/>
-                      </a:pPr>
-                      <a:r>
-                        <a:t>S3-11 R</a:t>
-                      </a:r>
-                    </a:p>
-                  </a:txBody>
-                  <a:tcPr anchor="t"/>
-                </a:tc>
-              </a:tr>
-            </a:tbl>
-          </a:graphicData>
-        </a:graphic>
-      </p:graphicFrame>
-      <p:graphicFrame>
-        <p:nvGraphicFramePr>
-          <p:cNvPr id="6" name="Table 5"/>
           <p:cNvGraphicFramePr>
             <a:graphicFrameLocks noGrp="1"/>
           </p:cNvGraphicFramePr>
@@ -30219,7 +29727,7 @@
       </p:graphicFrame>
       <p:graphicFrame>
         <p:nvGraphicFramePr>
-          <p:cNvPr id="7" name="Table 6"/>
+          <p:cNvPr id="6" name="Table 5"/>
           <p:cNvGraphicFramePr>
             <a:graphicFrameLocks noGrp="1"/>
           </p:cNvGraphicFramePr>
@@ -30666,7 +30174,7 @@
       </p:graphicFrame>
       <p:graphicFrame>
         <p:nvGraphicFramePr>
-          <p:cNvPr id="8" name="Table 7"/>
+          <p:cNvPr id="7" name="Table 6"/>
           <p:cNvGraphicFramePr>
             <a:graphicFrameLocks noGrp="1"/>
           </p:cNvGraphicFramePr>
@@ -38824,9 +38332,6 @@
                         </a:spcAft>
                         <a:defRPr sz="800"/>
                       </a:pPr>
-                      <a:r>
-                        <a:t>S3-14 G</a:t>
-                      </a:r>
                     </a:p>
                   </a:txBody>
                   <a:tcPr anchor="t"/>

</xml_diff>

<commit_message>
Number upper-deck plants from Switch 61 / 62L and drop leftover C2 S2 RGB.
Same odd-switch even-signal pattern as the lower deck. C2-OU3 stays because 24RB still needs three pins.

Co-authored-by: Cursor <cursoragent@cursor.com>
</commit_message>
<xml_diff>
--- a/docs/wiring/Wiring_Schematic.pptx
+++ b/docs/wiring/Wiring_Schematic.pptx
@@ -5033,7 +5033,7 @@
                         <a:defRPr sz="800"/>
                       </a:pPr>
                       <a:r>
-                        <a:t>SW144 N</a:t>
+                        <a:t>Switch 79 N</a:t>
                       </a:r>
                     </a:p>
                   </a:txBody>
@@ -5083,7 +5083,7 @@
                         <a:defRPr sz="800"/>
                       </a:pPr>
                       <a:r>
-                        <a:t>SW144 R</a:t>
+                        <a:t>Switch 79 R</a:t>
                       </a:r>
                     </a:p>
                   </a:txBody>
@@ -5133,7 +5133,7 @@
                         <a:defRPr sz="800"/>
                       </a:pPr>
                       <a:r>
-                        <a:t>SW145 N</a:t>
+                        <a:t>Switch 81 N</a:t>
                       </a:r>
                     </a:p>
                   </a:txBody>
@@ -5183,7 +5183,7 @@
                         <a:defRPr sz="800"/>
                       </a:pPr>
                       <a:r>
-                        <a:t>SW145 R</a:t>
+                        <a:t>Switch 81 R</a:t>
                       </a:r>
                     </a:p>
                   </a:txBody>
@@ -5233,7 +5233,7 @@
                         <a:defRPr sz="800"/>
                       </a:pPr>
                       <a:r>
-                        <a:t>SW146 N</a:t>
+                        <a:t>Switch 83 N</a:t>
                       </a:r>
                     </a:p>
                   </a:txBody>
@@ -5283,7 +5283,7 @@
                         <a:defRPr sz="800"/>
                       </a:pPr>
                       <a:r>
-                        <a:t>SW146 R</a:t>
+                        <a:t>Switch 83 R</a:t>
                       </a:r>
                     </a:p>
                   </a:txBody>
@@ -5333,7 +5333,7 @@
                         <a:defRPr sz="800"/>
                       </a:pPr>
                       <a:r>
-                        <a:t>SW147 N</a:t>
+                        <a:t>Switch 85 N</a:t>
                       </a:r>
                     </a:p>
                   </a:txBody>
@@ -5383,7 +5383,7 @@
                         <a:defRPr sz="800"/>
                       </a:pPr>
                       <a:r>
-                        <a:t>SW147 R</a:t>
+                        <a:t>Switch 85 R</a:t>
                       </a:r>
                     </a:p>
                   </a:txBody>
@@ -5492,7 +5492,7 @@
                         <a:defRPr sz="800"/>
                       </a:pPr>
                       <a:r>
-                        <a:t>Head S6-2 G</a:t>
+                        <a:t>Head 76R G</a:t>
                       </a:r>
                     </a:p>
                   </a:txBody>
@@ -5542,7 +5542,7 @@
                         <a:defRPr sz="800"/>
                       </a:pPr>
                       <a:r>
-                        <a:t>Head S6-2 Y</a:t>
+                        <a:t>Head 76R Y</a:t>
                       </a:r>
                     </a:p>
                   </a:txBody>
@@ -5592,7 +5592,7 @@
                         <a:defRPr sz="800"/>
                       </a:pPr>
                       <a:r>
-                        <a:t>Head S6-2 R</a:t>
+                        <a:t>Head 76R R</a:t>
                       </a:r>
                     </a:p>
                   </a:txBody>
@@ -5642,7 +5642,7 @@
                         <a:defRPr sz="800"/>
                       </a:pPr>
                       <a:r>
-                        <a:t>Head S6-13 G</a:t>
+                        <a:t>Head 86L G</a:t>
                       </a:r>
                     </a:p>
                   </a:txBody>
@@ -5692,7 +5692,7 @@
                         <a:defRPr sz="800"/>
                       </a:pPr>
                       <a:r>
-                        <a:t>Head S6-13 R</a:t>
+                        <a:t>Head 86L R</a:t>
                       </a:r>
                     </a:p>
                   </a:txBody>
@@ -5742,7 +5742,7 @@
                         <a:defRPr sz="800"/>
                       </a:pPr>
                       <a:r>
-                        <a:t>Head S6-13 Y</a:t>
+                        <a:t>Head 86L Y</a:t>
                       </a:r>
                     </a:p>
                   </a:txBody>
@@ -5792,7 +5792,7 @@
                         <a:defRPr sz="800"/>
                       </a:pPr>
                       <a:r>
-                        <a:t>Head S6-11 Y</a:t>
+                        <a:t>Head 84RA Y</a:t>
                       </a:r>
                     </a:p>
                   </a:txBody>
@@ -5951,7 +5951,7 @@
                         <a:defRPr sz="800"/>
                       </a:pPr>
                       <a:r>
-                        <a:t>Head S6-1 G</a:t>
+                        <a:t>Head 76L G</a:t>
                       </a:r>
                     </a:p>
                   </a:txBody>
@@ -6001,7 +6001,7 @@
                         <a:defRPr sz="800"/>
                       </a:pPr>
                       <a:r>
-                        <a:t>Head S6-1 Y</a:t>
+                        <a:t>Head 76L Y</a:t>
                       </a:r>
                     </a:p>
                   </a:txBody>
@@ -6051,7 +6051,7 @@
                         <a:defRPr sz="800"/>
                       </a:pPr>
                       <a:r>
-                        <a:t>Head S6-1 R</a:t>
+                        <a:t>Head 76L R</a:t>
                       </a:r>
                     </a:p>
                   </a:txBody>
@@ -6101,7 +6101,7 @@
                         <a:defRPr sz="800"/>
                       </a:pPr>
                       <a:r>
-                        <a:t>Head S6-5 G</a:t>
+                        <a:t>Head 78RB G</a:t>
                       </a:r>
                     </a:p>
                   </a:txBody>
@@ -6151,7 +6151,7 @@
                         <a:defRPr sz="800"/>
                       </a:pPr>
                       <a:r>
-                        <a:t>Head S6-5 Y</a:t>
+                        <a:t>Head 78RB Y</a:t>
                       </a:r>
                     </a:p>
                   </a:txBody>
@@ -6201,7 +6201,7 @@
                         <a:defRPr sz="800"/>
                       </a:pPr>
                       <a:r>
-                        <a:t>Head S6-5 R</a:t>
+                        <a:t>Head 78RB R</a:t>
                       </a:r>
                     </a:p>
                   </a:txBody>
@@ -6251,7 +6251,7 @@
                         <a:defRPr sz="800"/>
                       </a:pPr>
                       <a:r>
-                        <a:t>Head S6-11 G</a:t>
+                        <a:t>Head 84RA G</a:t>
                       </a:r>
                     </a:p>
                   </a:txBody>
@@ -6301,7 +6301,7 @@
                         <a:defRPr sz="800"/>
                       </a:pPr>
                       <a:r>
-                        <a:t>Head S6-11 R</a:t>
+                        <a:t>Head 84RA R</a:t>
                       </a:r>
                     </a:p>
                   </a:txBody>
@@ -6410,7 +6410,7 @@
                         <a:defRPr sz="800"/>
                       </a:pPr>
                       <a:r>
-                        <a:t>SW144 N FB</a:t>
+                        <a:t>Switch 79 N FB</a:t>
                       </a:r>
                     </a:p>
                   </a:txBody>
@@ -6460,7 +6460,7 @@
                         <a:defRPr sz="800"/>
                       </a:pPr>
                       <a:r>
-                        <a:t>SW144 R FB</a:t>
+                        <a:t>Switch 79 R FB</a:t>
                       </a:r>
                     </a:p>
                   </a:txBody>
@@ -6510,7 +6510,7 @@
                         <a:defRPr sz="800"/>
                       </a:pPr>
                       <a:r>
-                        <a:t>SW145 N FB</a:t>
+                        <a:t>Switch 81 N FB</a:t>
                       </a:r>
                     </a:p>
                   </a:txBody>
@@ -6560,7 +6560,7 @@
                         <a:defRPr sz="800"/>
                       </a:pPr>
                       <a:r>
-                        <a:t>SW145 R FB</a:t>
+                        <a:t>Switch 81 R FB</a:t>
                       </a:r>
                     </a:p>
                   </a:txBody>
@@ -6610,7 +6610,7 @@
                         <a:defRPr sz="800"/>
                       </a:pPr>
                       <a:r>
-                        <a:t>SW146 N FB</a:t>
+                        <a:t>Switch 83 N FB</a:t>
                       </a:r>
                     </a:p>
                   </a:txBody>
@@ -6660,7 +6660,7 @@
                         <a:defRPr sz="800"/>
                       </a:pPr>
                       <a:r>
-                        <a:t>SW146 R FB</a:t>
+                        <a:t>Switch 83 R FB</a:t>
                       </a:r>
                     </a:p>
                   </a:txBody>
@@ -6710,7 +6710,7 @@
                         <a:defRPr sz="800"/>
                       </a:pPr>
                       <a:r>
-                        <a:t>SW147 N FB</a:t>
+                        <a:t>Switch 85 N FB</a:t>
                       </a:r>
                     </a:p>
                   </a:txBody>
@@ -6760,7 +6760,7 @@
                         <a:defRPr sz="800"/>
                       </a:pPr>
                       <a:r>
-                        <a:t>SW147 R FB</a:t>
+                        <a:t>Switch 85 R FB</a:t>
                       </a:r>
                     </a:p>
                   </a:txBody>
@@ -6869,7 +6869,7 @@
                         <a:defRPr sz="800"/>
                       </a:pPr>
                       <a:r>
-                        <a:t>SW144 BTN</a:t>
+                        <a:t>Switch 79 BTN</a:t>
                       </a:r>
                     </a:p>
                   </a:txBody>
@@ -6919,7 +6919,7 @@
                         <a:defRPr sz="800"/>
                       </a:pPr>
                       <a:r>
-                        <a:t>SW145 BTN</a:t>
+                        <a:t>Switch 81 BTN</a:t>
                       </a:r>
                     </a:p>
                   </a:txBody>
@@ -6969,7 +6969,7 @@
                         <a:defRPr sz="800"/>
                       </a:pPr>
                       <a:r>
-                        <a:t>SW146 BTN</a:t>
+                        <a:t>Switch 83 BTN</a:t>
                       </a:r>
                     </a:p>
                   </a:txBody>
@@ -7019,7 +7019,7 @@
                         <a:defRPr sz="800"/>
                       </a:pPr>
                       <a:r>
-                        <a:t>SW147 BTN</a:t>
+                        <a:t>Switch 85 BTN</a:t>
                       </a:r>
                     </a:p>
                   </a:txBody>
@@ -7316,7 +7316,7 @@
                         <a:defRPr sz="800"/>
                       </a:pPr>
                       <a:r>
-                        <a:t>SW143</a:t>
+                        <a:t>Switch 77</a:t>
                       </a:r>
                     </a:p>
                   </a:txBody>
@@ -7366,7 +7366,7 @@
                         <a:defRPr sz="800"/>
                       </a:pPr>
                       <a:r>
-                        <a:t>SW144</a:t>
+                        <a:t>Switch 79</a:t>
                       </a:r>
                     </a:p>
                   </a:txBody>
@@ -7416,7 +7416,7 @@
                         <a:defRPr sz="800"/>
                       </a:pPr>
                       <a:r>
-                        <a:t>SW145</a:t>
+                        <a:t>Switch 81</a:t>
                       </a:r>
                     </a:p>
                   </a:txBody>
@@ -7466,7 +7466,7 @@
                         <a:defRPr sz="800"/>
                       </a:pPr>
                       <a:r>
-                        <a:t>SW146</a:t>
+                        <a:t>Switch 83</a:t>
                       </a:r>
                     </a:p>
                   </a:txBody>
@@ -7516,7 +7516,7 @@
                         <a:defRPr sz="800"/>
                       </a:pPr>
                       <a:r>
-                        <a:t>SW147</a:t>
+                        <a:t>Switch 85</a:t>
                       </a:r>
                     </a:p>
                   </a:txBody>
@@ -7824,7 +7824,7 @@
                         <a:defRPr sz="800"/>
                       </a:pPr>
                       <a:r>
-                        <a:t>NIX N</a:t>
+                        <a:t>Switch 61 N</a:t>
                       </a:r>
                     </a:p>
                   </a:txBody>
@@ -7874,7 +7874,7 @@
                         <a:defRPr sz="800"/>
                       </a:pPr>
                       <a:r>
-                        <a:t>NIX R</a:t>
+                        <a:t>Switch 61 R</a:t>
                       </a:r>
                     </a:p>
                   </a:txBody>
@@ -8283,7 +8283,7 @@
                         <a:defRPr sz="800"/>
                       </a:pPr>
                       <a:r>
-                        <a:t>Head S4-1 G</a:t>
+                        <a:t>Head 64R G</a:t>
                       </a:r>
                     </a:p>
                   </a:txBody>
@@ -8333,7 +8333,7 @@
                         <a:defRPr sz="800"/>
                       </a:pPr>
                       <a:r>
-                        <a:t>Head S4-1 Y</a:t>
+                        <a:t>Head 64R Y</a:t>
                       </a:r>
                     </a:p>
                   </a:txBody>
@@ -8383,7 +8383,7 @@
                         <a:defRPr sz="800"/>
                       </a:pPr>
                       <a:r>
-                        <a:t>Head S4-1 R</a:t>
+                        <a:t>Head 64R R</a:t>
                       </a:r>
                     </a:p>
                   </a:txBody>
@@ -8433,7 +8433,7 @@
                         <a:defRPr sz="800"/>
                       </a:pPr>
                       <a:r>
-                        <a:t>Head S4-2 G</a:t>
+                        <a:t>Head 68L G</a:t>
                       </a:r>
                     </a:p>
                   </a:txBody>
@@ -8483,7 +8483,7 @@
                         <a:defRPr sz="800"/>
                       </a:pPr>
                       <a:r>
-                        <a:t>Head S4-2 Y</a:t>
+                        <a:t>Head 68L Y</a:t>
                       </a:r>
                     </a:p>
                   </a:txBody>
@@ -8533,7 +8533,7 @@
                         <a:defRPr sz="800"/>
                       </a:pPr>
                       <a:r>
-                        <a:t>Head S4-2 R</a:t>
+                        <a:t>Head 68L R</a:t>
                       </a:r>
                     </a:p>
                   </a:txBody>
@@ -8583,7 +8583,7 @@
                         <a:defRPr sz="800"/>
                       </a:pPr>
                       <a:r>
-                        <a:t>Head S4-5 Y</a:t>
+                        <a:t>Head 66RB Y</a:t>
                       </a:r>
                     </a:p>
                   </a:txBody>
@@ -8742,7 +8742,7 @@
                         <a:defRPr sz="800"/>
                       </a:pPr>
                       <a:r>
-                        <a:t>Head S4-3 G</a:t>
+                        <a:t>Head 64L G</a:t>
                       </a:r>
                     </a:p>
                   </a:txBody>
@@ -8792,7 +8792,7 @@
                         <a:defRPr sz="800"/>
                       </a:pPr>
                       <a:r>
-                        <a:t>Head S4-3 Y</a:t>
+                        <a:t>Head 64L Y</a:t>
                       </a:r>
                     </a:p>
                   </a:txBody>
@@ -8842,7 +8842,7 @@
                         <a:defRPr sz="800"/>
                       </a:pPr>
                       <a:r>
-                        <a:t>Head S4-3 R</a:t>
+                        <a:t>Head 64L R</a:t>
                       </a:r>
                     </a:p>
                   </a:txBody>
@@ -8892,7 +8892,7 @@
                         <a:defRPr sz="800"/>
                       </a:pPr>
                       <a:r>
-                        <a:t>Head S4-4 G</a:t>
+                        <a:t>Head 66RA G</a:t>
                       </a:r>
                     </a:p>
                   </a:txBody>
@@ -8942,7 +8942,7 @@
                         <a:defRPr sz="800"/>
                       </a:pPr>
                       <a:r>
-                        <a:t>Head S4-4 Y</a:t>
+                        <a:t>Head 66RA Y</a:t>
                       </a:r>
                     </a:p>
                   </a:txBody>
@@ -8992,7 +8992,7 @@
                         <a:defRPr sz="800"/>
                       </a:pPr>
                       <a:r>
-                        <a:t>Head S4-4 R</a:t>
+                        <a:t>Head 66RA R</a:t>
                       </a:r>
                     </a:p>
                   </a:txBody>
@@ -9042,7 +9042,7 @@
                         <a:defRPr sz="800"/>
                       </a:pPr>
                       <a:r>
-                        <a:t>Head S4-5 G</a:t>
+                        <a:t>Head 66RB G</a:t>
                       </a:r>
                     </a:p>
                   </a:txBody>
@@ -9092,7 +9092,7 @@
                         <a:defRPr sz="800"/>
                       </a:pPr>
                       <a:r>
-                        <a:t>Head S4-5 R</a:t>
+                        <a:t>Head 66RB R</a:t>
                       </a:r>
                     </a:p>
                   </a:txBody>
@@ -9201,7 +9201,7 @@
                         <a:defRPr sz="800"/>
                       </a:pPr>
                       <a:r>
-                        <a:t>NIX N FB</a:t>
+                        <a:t>Switch 61 N FB</a:t>
                       </a:r>
                     </a:p>
                   </a:txBody>
@@ -9251,7 +9251,7 @@
                         <a:defRPr sz="800"/>
                       </a:pPr>
                       <a:r>
-                        <a:t>NIX R FB</a:t>
+                        <a:t>Switch 61 R FB</a:t>
                       </a:r>
                     </a:p>
                   </a:txBody>
@@ -9301,7 +9301,7 @@
                         <a:defRPr sz="800"/>
                       </a:pPr>
                       <a:r>
-                        <a:t>SW129 N FB</a:t>
+                        <a:t>Switch 67 N FB</a:t>
                       </a:r>
                     </a:p>
                   </a:txBody>
@@ -9351,7 +9351,7 @@
                         <a:defRPr sz="800"/>
                       </a:pPr>
                       <a:r>
-                        <a:t>SW129 R FB</a:t>
+                        <a:t>Switch 67 R FB</a:t>
                       </a:r>
                     </a:p>
                   </a:txBody>
@@ -9401,7 +9401,7 @@
                         <a:defRPr sz="800"/>
                       </a:pPr>
                       <a:r>
-                        <a:t>SW127 N FB</a:t>
+                        <a:t>Switch 63 N FB</a:t>
                       </a:r>
                     </a:p>
                   </a:txBody>
@@ -9451,7 +9451,7 @@
                         <a:defRPr sz="800"/>
                       </a:pPr>
                       <a:r>
-                        <a:t>SW127 R FB</a:t>
+                        <a:t>Switch 63 R FB</a:t>
                       </a:r>
                     </a:p>
                   </a:txBody>
@@ -9501,7 +9501,7 @@
                         <a:defRPr sz="800"/>
                       </a:pPr>
                       <a:r>
-                        <a:t>SW138 N FB</a:t>
+                        <a:t>Switch 65 N FB</a:t>
                       </a:r>
                     </a:p>
                   </a:txBody>
@@ -9551,7 +9551,7 @@
                         <a:defRPr sz="800"/>
                       </a:pPr>
                       <a:r>
-                        <a:t>SW138 R FB</a:t>
+                        <a:t>Switch 65 R FB</a:t>
                       </a:r>
                     </a:p>
                   </a:txBody>
@@ -9660,7 +9660,7 @@
                         <a:defRPr sz="800"/>
                       </a:pPr>
                       <a:r>
-                        <a:t>NIX BTN</a:t>
+                        <a:t>Switch 61 BTN</a:t>
                       </a:r>
                     </a:p>
                   </a:txBody>
@@ -9710,7 +9710,7 @@
                         <a:defRPr sz="800"/>
                       </a:pPr>
                       <a:r>
-                        <a:t>SW129 BTN</a:t>
+                        <a:t>Switch 67 BTN</a:t>
                       </a:r>
                     </a:p>
                   </a:txBody>
@@ -9760,7 +9760,7 @@
                         <a:defRPr sz="800"/>
                       </a:pPr>
                       <a:r>
-                        <a:t>SW127 BTN</a:t>
+                        <a:t>Switch 63 BTN</a:t>
                       </a:r>
                     </a:p>
                   </a:txBody>
@@ -9810,7 +9810,7 @@
                         <a:defRPr sz="800"/>
                       </a:pPr>
                       <a:r>
-                        <a:t>SW138 BTN</a:t>
+                        <a:t>Switch 65 BTN</a:t>
                       </a:r>
                     </a:p>
                   </a:txBody>
@@ -10207,7 +10207,7 @@
                         <a:defRPr sz="800"/>
                       </a:pPr>
                       <a:r>
-                        <a:t>SW129</a:t>
+                        <a:t>Switch 67</a:t>
                       </a:r>
                     </a:p>
                   </a:txBody>
@@ -10307,7 +10307,7 @@
                         <a:defRPr sz="800"/>
                       </a:pPr>
                       <a:r>
-                        <a:t>SW127</a:t>
+                        <a:t>Switch 63</a:t>
                       </a:r>
                     </a:p>
                   </a:txBody>
@@ -10357,7 +10357,7 @@
                         <a:defRPr sz="800"/>
                       </a:pPr>
                       <a:r>
-                        <a:t>SW138</a:t>
+                        <a:t>Switch 65</a:t>
                       </a:r>
                     </a:p>
                   </a:txBody>
@@ -10407,7 +10407,7 @@
                         <a:defRPr sz="800"/>
                       </a:pPr>
                       <a:r>
-                        <a:t>SW139,140</a:t>
+                        <a:t>Switch 61c,140</a:t>
                       </a:r>
                     </a:p>
                   </a:txBody>
@@ -10457,7 +10457,7 @@
                         <a:defRPr sz="800"/>
                       </a:pPr>
                       <a:r>
-                        <a:t>SW125,126</a:t>
+                        <a:t>Switch 61a,126</a:t>
                       </a:r>
                     </a:p>
                   </a:txBody>
@@ -10615,7 +10615,7 @@
                         <a:defRPr sz="800"/>
                       </a:pPr>
                       <a:r>
-                        <a:t>DJE N</a:t>
+                        <a:t>Switch 69 N</a:t>
                       </a:r>
                     </a:p>
                   </a:txBody>
@@ -10665,7 +10665,7 @@
                         <a:defRPr sz="800"/>
                       </a:pPr>
                       <a:r>
-                        <a:t>DJE R</a:t>
+                        <a:t>Switch 69 R</a:t>
                       </a:r>
                     </a:p>
                   </a:txBody>
@@ -10715,7 +10715,7 @@
                         <a:defRPr sz="800"/>
                       </a:pPr>
                       <a:r>
-                        <a:t>DJW N</a:t>
+                        <a:t>Switch 71 N</a:t>
                       </a:r>
                     </a:p>
                   </a:txBody>
@@ -10765,7 +10765,7 @@
                         <a:defRPr sz="800"/>
                       </a:pPr>
                       <a:r>
-                        <a:t>DJW R</a:t>
+                        <a:t>Switch 71 R</a:t>
                       </a:r>
                     </a:p>
                   </a:txBody>
@@ -11074,7 +11074,7 @@
                         <a:defRPr sz="800"/>
                       </a:pPr>
                       <a:r>
-                        <a:t>Head S5-1 G</a:t>
+                        <a:t>Head 70L G</a:t>
                       </a:r>
                     </a:p>
                   </a:txBody>
@@ -11124,7 +11124,7 @@
                         <a:defRPr sz="800"/>
                       </a:pPr>
                       <a:r>
-                        <a:t>Head S5-1 Y</a:t>
+                        <a:t>Head 70L Y</a:t>
                       </a:r>
                     </a:p>
                   </a:txBody>
@@ -11174,7 +11174,7 @@
                         <a:defRPr sz="800"/>
                       </a:pPr>
                       <a:r>
-                        <a:t>Head S5-1 R</a:t>
+                        <a:t>Head 70L R</a:t>
                       </a:r>
                     </a:p>
                   </a:txBody>
@@ -11224,7 +11224,7 @@
                         <a:defRPr sz="800"/>
                       </a:pPr>
                       <a:r>
-                        <a:t>Head S5-2 G</a:t>
+                        <a:t>Head 72L G</a:t>
                       </a:r>
                     </a:p>
                   </a:txBody>
@@ -11274,7 +11274,7 @@
                         <a:defRPr sz="800"/>
                       </a:pPr>
                       <a:r>
-                        <a:t>Head S5-2 Y</a:t>
+                        <a:t>Head 72L Y</a:t>
                       </a:r>
                     </a:p>
                   </a:txBody>
@@ -11324,7 +11324,7 @@
                         <a:defRPr sz="800"/>
                       </a:pPr>
                       <a:r>
-                        <a:t>Head S5-2 R</a:t>
+                        <a:t>Head 72L R</a:t>
                       </a:r>
                     </a:p>
                   </a:txBody>
@@ -11374,7 +11374,7 @@
                         <a:defRPr sz="800"/>
                       </a:pPr>
                       <a:r>
-                        <a:t>Head S5-5 Y</a:t>
+                        <a:t>Head 70RA Y</a:t>
                       </a:r>
                     </a:p>
                   </a:txBody>
@@ -11533,7 +11533,7 @@
                         <a:defRPr sz="800"/>
                       </a:pPr>
                       <a:r>
-                        <a:t>Head S5-3 G</a:t>
+                        <a:t>Head 74L G</a:t>
                       </a:r>
                     </a:p>
                   </a:txBody>
@@ -11583,7 +11583,7 @@
                         <a:defRPr sz="800"/>
                       </a:pPr>
                       <a:r>
-                        <a:t>Head S5-3 Y</a:t>
+                        <a:t>Head 74L Y</a:t>
                       </a:r>
                     </a:p>
                   </a:txBody>
@@ -11633,7 +11633,7 @@
                         <a:defRPr sz="800"/>
                       </a:pPr>
                       <a:r>
-                        <a:t>Head S5-3 R</a:t>
+                        <a:t>Head 74L R</a:t>
                       </a:r>
                     </a:p>
                   </a:txBody>
@@ -11683,7 +11683,7 @@
                         <a:defRPr sz="800"/>
                       </a:pPr>
                       <a:r>
-                        <a:t>Head S5-4 G</a:t>
+                        <a:t>Head 74RA G</a:t>
                       </a:r>
                     </a:p>
                   </a:txBody>
@@ -11733,7 +11733,7 @@
                         <a:defRPr sz="800"/>
                       </a:pPr>
                       <a:r>
-                        <a:t>Head S5-4 Y</a:t>
+                        <a:t>Head 74RA Y</a:t>
                       </a:r>
                     </a:p>
                   </a:txBody>
@@ -11783,7 +11783,7 @@
                         <a:defRPr sz="800"/>
                       </a:pPr>
                       <a:r>
-                        <a:t>Head S5-4 R</a:t>
+                        <a:t>Head 74RA R</a:t>
                       </a:r>
                     </a:p>
                   </a:txBody>
@@ -11833,7 +11833,7 @@
                         <a:defRPr sz="800"/>
                       </a:pPr>
                       <a:r>
-                        <a:t>Head S5-5 G</a:t>
+                        <a:t>Head 70RA G</a:t>
                       </a:r>
                     </a:p>
                   </a:txBody>
@@ -11883,7 +11883,7 @@
                         <a:defRPr sz="800"/>
                       </a:pPr>
                       <a:r>
-                        <a:t>Head S5-5 R</a:t>
+                        <a:t>Head 70RA R</a:t>
                       </a:r>
                     </a:p>
                   </a:txBody>
@@ -11992,7 +11992,7 @@
                         <a:defRPr sz="800"/>
                       </a:pPr>
                       <a:r>
-                        <a:t>DJE N FB</a:t>
+                        <a:t>Switch 69 N FB</a:t>
                       </a:r>
                     </a:p>
                   </a:txBody>
@@ -12042,7 +12042,7 @@
                         <a:defRPr sz="800"/>
                       </a:pPr>
                       <a:r>
-                        <a:t>DJE R FB</a:t>
+                        <a:t>Switch 69 R FB</a:t>
                       </a:r>
                     </a:p>
                   </a:txBody>
@@ -12092,7 +12092,7 @@
                         <a:defRPr sz="800"/>
                       </a:pPr>
                       <a:r>
-                        <a:t>DJW N FB</a:t>
+                        <a:t>Switch 71 N FB</a:t>
                       </a:r>
                     </a:p>
                   </a:txBody>
@@ -12142,7 +12142,7 @@
                         <a:defRPr sz="800"/>
                       </a:pPr>
                       <a:r>
-                        <a:t>DJW R FB</a:t>
+                        <a:t>Switch 71 R FB</a:t>
                       </a:r>
                     </a:p>
                   </a:txBody>
@@ -12192,7 +12192,7 @@
                         <a:defRPr sz="800"/>
                       </a:pPr>
                       <a:r>
-                        <a:t>SW124 N FB</a:t>
+                        <a:t>Switch 73 N FB</a:t>
                       </a:r>
                     </a:p>
                   </a:txBody>
@@ -12242,7 +12242,7 @@
                         <a:defRPr sz="800"/>
                       </a:pPr>
                       <a:r>
-                        <a:t>SW124 R FB</a:t>
+                        <a:t>Switch 73 R FB</a:t>
                       </a:r>
                     </a:p>
                   </a:txBody>
@@ -12445,7 +12445,7 @@
                         <a:defRPr sz="800"/>
                       </a:pPr>
                       <a:r>
-                        <a:t>DJE BTN</a:t>
+                        <a:t>Switch 69 BTN</a:t>
                       </a:r>
                     </a:p>
                   </a:txBody>
@@ -12495,7 +12495,7 @@
                         <a:defRPr sz="800"/>
                       </a:pPr>
                       <a:r>
-                        <a:t>DJW BTN</a:t>
+                        <a:t>Switch 71 BTN</a:t>
                       </a:r>
                     </a:p>
                   </a:txBody>
@@ -12545,7 +12545,7 @@
                         <a:defRPr sz="800"/>
                       </a:pPr>
                       <a:r>
-                        <a:t>SW124 BTN</a:t>
+                        <a:t>Switch 73 BTN</a:t>
                       </a:r>
                     </a:p>
                   </a:txBody>
@@ -12989,7 +12989,7 @@
                         <a:defRPr sz="800"/>
                       </a:pPr>
                       <a:r>
-                        <a:t>SW124</a:t>
+                        <a:t>Switch 73</a:t>
                       </a:r>
                     </a:p>
                   </a:txBody>
@@ -13039,7 +13039,7 @@
                         <a:defRPr sz="800"/>
                       </a:pPr>
                       <a:r>
-                        <a:t>SW122,123</a:t>
+                        <a:t>Switch 71b,123</a:t>
                       </a:r>
                     </a:p>
                   </a:txBody>
@@ -13089,7 +13089,7 @@
                         <a:defRPr sz="800"/>
                       </a:pPr>
                       <a:r>
-                        <a:t>SW120</a:t>
+                        <a:t>Switch 71a</a:t>
                       </a:r>
                     </a:p>
                   </a:txBody>
@@ -13139,7 +13139,7 @@
                         <a:defRPr sz="800"/>
                       </a:pPr>
                       <a:r>
-                        <a:t>SW121</a:t>
+                        <a:t>Switch 69a</a:t>
                       </a:r>
                     </a:p>
                   </a:txBody>
@@ -13397,7 +13397,7 @@
                         <a:defRPr sz="800"/>
                       </a:pPr>
                       <a:r>
-                        <a:t>CBX N</a:t>
+                        <a:t>Switch 75 N</a:t>
                       </a:r>
                     </a:p>
                   </a:txBody>
@@ -13447,7 +13447,7 @@
                         <a:defRPr sz="800"/>
                       </a:pPr>
                       <a:r>
-                        <a:t>CBX R</a:t>
+                        <a:t>Switch 75 R</a:t>
                       </a:r>
                     </a:p>
                   </a:txBody>
@@ -13497,7 +13497,7 @@
                         <a:defRPr sz="800"/>
                       </a:pPr>
                       <a:r>
-                        <a:t>SW143 N</a:t>
+                        <a:t>Switch 77 N</a:t>
                       </a:r>
                     </a:p>
                   </a:txBody>
@@ -13547,7 +13547,7 @@
                         <a:defRPr sz="800"/>
                       </a:pPr>
                       <a:r>
-                        <a:t>SW143 R</a:t>
+                        <a:t>Switch 77 R</a:t>
                       </a:r>
                     </a:p>
                   </a:txBody>
@@ -13850,7 +13850,7 @@
                         <a:defRPr sz="800"/>
                       </a:pPr>
                       <a:r>
-                        <a:t>Head S6-6 G</a:t>
+                        <a:t>Head 78R G</a:t>
                       </a:r>
                     </a:p>
                   </a:txBody>
@@ -13900,7 +13900,7 @@
                         <a:defRPr sz="800"/>
                       </a:pPr>
                       <a:r>
-                        <a:t>Head S6-6 Y</a:t>
+                        <a:t>Head 78R Y</a:t>
                       </a:r>
                     </a:p>
                   </a:txBody>
@@ -13950,7 +13950,7 @@
                         <a:defRPr sz="800"/>
                       </a:pPr>
                       <a:r>
-                        <a:t>Head S6-6 R</a:t>
+                        <a:t>Head 78R R</a:t>
                       </a:r>
                     </a:p>
                   </a:txBody>
@@ -14000,7 +14000,7 @@
                         <a:defRPr sz="800"/>
                       </a:pPr>
                       <a:r>
-                        <a:t>Head S6-8 G</a:t>
+                        <a:t>Head 88R G</a:t>
                       </a:r>
                     </a:p>
                   </a:txBody>
@@ -14050,7 +14050,7 @@
                         <a:defRPr sz="800"/>
                       </a:pPr>
                       <a:r>
-                        <a:t>Head S6-8 Y</a:t>
+                        <a:t>Head 88R Y</a:t>
                       </a:r>
                     </a:p>
                   </a:txBody>
@@ -14100,7 +14100,7 @@
                         <a:defRPr sz="800"/>
                       </a:pPr>
                       <a:r>
-                        <a:t>Head S6-8 R</a:t>
+                        <a:t>Head 88R R</a:t>
                       </a:r>
                     </a:p>
                   </a:txBody>
@@ -14150,7 +14150,7 @@
                         <a:defRPr sz="800"/>
                       </a:pPr>
                       <a:r>
-                        <a:t>Head S6-12 Y</a:t>
+                        <a:t>Head 84RB Y</a:t>
                       </a:r>
                     </a:p>
                   </a:txBody>
@@ -14309,7 +14309,7 @@
                         <a:defRPr sz="800"/>
                       </a:pPr>
                       <a:r>
-                        <a:t>Head S6-15 G</a:t>
+                        <a:t>Head 92L G</a:t>
                       </a:r>
                     </a:p>
                   </a:txBody>
@@ -14359,7 +14359,7 @@
                         <a:defRPr sz="800"/>
                       </a:pPr>
                       <a:r>
-                        <a:t>Head S6-15 R</a:t>
+                        <a:t>Head 92L R</a:t>
                       </a:r>
                     </a:p>
                   </a:txBody>
@@ -14409,7 +14409,7 @@
                         <a:defRPr sz="800"/>
                       </a:pPr>
                       <a:r>
-                        <a:t>Head S6-15 Y</a:t>
+                        <a:t>Head 92L Y</a:t>
                       </a:r>
                     </a:p>
                   </a:txBody>
@@ -14459,7 +14459,7 @@
                         <a:defRPr sz="800"/>
                       </a:pPr>
                       <a:r>
-                        <a:t>Head S6-14 G</a:t>
+                        <a:t>Head 90L G</a:t>
                       </a:r>
                     </a:p>
                   </a:txBody>
@@ -14509,7 +14509,7 @@
                         <a:defRPr sz="800"/>
                       </a:pPr>
                       <a:r>
-                        <a:t>Head S6-14 R</a:t>
+                        <a:t>Head 90L R</a:t>
                       </a:r>
                     </a:p>
                   </a:txBody>
@@ -14559,7 +14559,7 @@
                         <a:defRPr sz="800"/>
                       </a:pPr>
                       <a:r>
-                        <a:t>Head S6-14 Y</a:t>
+                        <a:t>Head 90L Y</a:t>
                       </a:r>
                     </a:p>
                   </a:txBody>
@@ -14609,7 +14609,7 @@
                         <a:defRPr sz="800"/>
                       </a:pPr>
                       <a:r>
-                        <a:t>Head S6-12 G</a:t>
+                        <a:t>Head 84RB G</a:t>
                       </a:r>
                     </a:p>
                   </a:txBody>
@@ -14659,7 +14659,7 @@
                         <a:defRPr sz="800"/>
                       </a:pPr>
                       <a:r>
-                        <a:t>Head S6-12 R</a:t>
+                        <a:t>Head 84RB R</a:t>
                       </a:r>
                     </a:p>
                   </a:txBody>
@@ -14768,7 +14768,7 @@
                         <a:defRPr sz="800"/>
                       </a:pPr>
                       <a:r>
-                        <a:t>CBX N FB</a:t>
+                        <a:t>Switch 75 N FB</a:t>
                       </a:r>
                     </a:p>
                   </a:txBody>
@@ -14818,7 +14818,7 @@
                         <a:defRPr sz="800"/>
                       </a:pPr>
                       <a:r>
-                        <a:t>CBX R FB</a:t>
+                        <a:t>Switch 75 R FB</a:t>
                       </a:r>
                     </a:p>
                   </a:txBody>
@@ -14868,7 +14868,7 @@
                         <a:defRPr sz="800"/>
                       </a:pPr>
                       <a:r>
-                        <a:t>SW143 N FB</a:t>
+                        <a:t>Switch 77 N FB</a:t>
                       </a:r>
                     </a:p>
                   </a:txBody>
@@ -14918,7 +14918,7 @@
                         <a:defRPr sz="800"/>
                       </a:pPr>
                       <a:r>
-                        <a:t>SW143 R FB</a:t>
+                        <a:t>Switch 77 R FB</a:t>
                       </a:r>
                     </a:p>
                   </a:txBody>
@@ -15062,7 +15062,7 @@
                         <a:defRPr sz="800"/>
                       </a:pPr>
                       <a:r>
-                        <a:t>CBX BTN</a:t>
+                        <a:t>Switch 75 BTN</a:t>
                       </a:r>
                     </a:p>
                   </a:txBody>
@@ -15112,7 +15112,7 @@
                         <a:defRPr sz="800"/>
                       </a:pPr>
                       <a:r>
-                        <a:t>SW143 BTN</a:t>
+                        <a:t>Switch 77 BTN</a:t>
                       </a:r>
                     </a:p>
                   </a:txBody>
@@ -15521,7 +15521,7 @@
                         <a:defRPr sz="800"/>
                       </a:pPr>
                       <a:r>
-                        <a:t>SW141</a:t>
+                        <a:t>Switch 75a</a:t>
                       </a:r>
                     </a:p>
                   </a:txBody>
@@ -15571,7 +15571,7 @@
                         <a:defRPr sz="800"/>
                       </a:pPr>
                       <a:r>
-                        <a:t>SW142</a:t>
+                        <a:t>Switch 75b</a:t>
                       </a:r>
                     </a:p>
                   </a:txBody>
@@ -15729,7 +15729,7 @@
                         <a:defRPr sz="800"/>
                       </a:pPr>
                       <a:r>
-                        <a:t>SW148 N</a:t>
+                        <a:t>Switch 87 N</a:t>
                       </a:r>
                     </a:p>
                   </a:txBody>
@@ -15779,7 +15779,7 @@
                         <a:defRPr sz="800"/>
                       </a:pPr>
                       <a:r>
-                        <a:t>SW148 R</a:t>
+                        <a:t>Switch 87 R</a:t>
                       </a:r>
                     </a:p>
                   </a:txBody>
@@ -15829,7 +15829,7 @@
                         <a:defRPr sz="800"/>
                       </a:pPr>
                       <a:r>
-                        <a:t>SW149 N</a:t>
+                        <a:t>Switch 89 N</a:t>
                       </a:r>
                     </a:p>
                   </a:txBody>
@@ -15879,7 +15879,7 @@
                         <a:defRPr sz="800"/>
                       </a:pPr>
                       <a:r>
-                        <a:t>SW149 R</a:t>
+                        <a:t>Switch 89 R</a:t>
                       </a:r>
                     </a:p>
                   </a:txBody>
@@ -15929,7 +15929,7 @@
                         <a:defRPr sz="800"/>
                       </a:pPr>
                       <a:r>
-                        <a:t>SW150 N</a:t>
+                        <a:t>Switch 91 N</a:t>
                       </a:r>
                     </a:p>
                   </a:txBody>
@@ -15979,7 +15979,7 @@
                         <a:defRPr sz="800"/>
                       </a:pPr>
                       <a:r>
-                        <a:t>SW150 R</a:t>
+                        <a:t>Switch 91 R</a:t>
                       </a:r>
                     </a:p>
                   </a:txBody>
@@ -16029,7 +16029,7 @@
                         <a:defRPr sz="800"/>
                       </a:pPr>
                       <a:r>
-                        <a:t>Head S6-10 G</a:t>
+                        <a:t>Head 82L G</a:t>
                       </a:r>
                     </a:p>
                   </a:txBody>
@@ -16079,7 +16079,7 @@
                         <a:defRPr sz="800"/>
                       </a:pPr>
                       <a:r>
-                        <a:t>Head S6-10 R</a:t>
+                        <a:t>Head 82L R</a:t>
                       </a:r>
                     </a:p>
                   </a:txBody>
@@ -16188,7 +16188,7 @@
                         <a:defRPr sz="800"/>
                       </a:pPr>
                       <a:r>
-                        <a:t>Head S6-3 G</a:t>
+                        <a:t>Head 78L G</a:t>
                       </a:r>
                     </a:p>
                   </a:txBody>
@@ -16238,7 +16238,7 @@
                         <a:defRPr sz="800"/>
                       </a:pPr>
                       <a:r>
-                        <a:t>Head S6-3 Y</a:t>
+                        <a:t>Head 78L Y</a:t>
                       </a:r>
                     </a:p>
                   </a:txBody>
@@ -16288,7 +16288,7 @@
                         <a:defRPr sz="800"/>
                       </a:pPr>
                       <a:r>
-                        <a:t>Head S6-3 R</a:t>
+                        <a:t>Head 78L R</a:t>
                       </a:r>
                     </a:p>
                   </a:txBody>
@@ -16338,7 +16338,7 @@
                         <a:defRPr sz="800"/>
                       </a:pPr>
                       <a:r>
-                        <a:t>Head S6-9 G</a:t>
+                        <a:t>Head 88RA G</a:t>
                       </a:r>
                     </a:p>
                   </a:txBody>
@@ -16388,7 +16388,7 @@
                         <a:defRPr sz="800"/>
                       </a:pPr>
                       <a:r>
-                        <a:t>Head S6-9 Y</a:t>
+                        <a:t>Head 88RA Y</a:t>
                       </a:r>
                     </a:p>
                   </a:txBody>
@@ -16438,7 +16438,7 @@
                         <a:defRPr sz="800"/>
                       </a:pPr>
                       <a:r>
-                        <a:t>Head S6-9 R</a:t>
+                        <a:t>Head 88RA R</a:t>
                       </a:r>
                     </a:p>
                   </a:txBody>
@@ -16488,7 +16488,7 @@
                         <a:defRPr sz="800"/>
                       </a:pPr>
                       <a:r>
-                        <a:t>Head S6-10 Y</a:t>
+                        <a:t>Head 82L Y</a:t>
                       </a:r>
                     </a:p>
                   </a:txBody>
@@ -16647,7 +16647,7 @@
                         <a:defRPr sz="800"/>
                       </a:pPr>
                       <a:r>
-                        <a:t>Head S6-4 G</a:t>
+                        <a:t>Head 78RA G</a:t>
                       </a:r>
                     </a:p>
                   </a:txBody>
@@ -16697,7 +16697,7 @@
                         <a:defRPr sz="800"/>
                       </a:pPr>
                       <a:r>
-                        <a:t>Head S6-4 Y</a:t>
+                        <a:t>Head 78RA Y</a:t>
                       </a:r>
                     </a:p>
                   </a:txBody>
@@ -16747,7 +16747,7 @@
                         <a:defRPr sz="800"/>
                       </a:pPr>
                       <a:r>
-                        <a:t>Head S6-4 R</a:t>
+                        <a:t>Head 78RA R</a:t>
                       </a:r>
                     </a:p>
                   </a:txBody>
@@ -16797,7 +16797,7 @@
                         <a:defRPr sz="800"/>
                       </a:pPr>
                       <a:r>
-                        <a:t>Head S6-7 G</a:t>
+                        <a:t>Head 88L G</a:t>
                       </a:r>
                     </a:p>
                   </a:txBody>
@@ -16847,7 +16847,7 @@
                         <a:defRPr sz="800"/>
                       </a:pPr>
                       <a:r>
-                        <a:t>Head S6-7 Y</a:t>
+                        <a:t>Head 88L Y</a:t>
                       </a:r>
                     </a:p>
                   </a:txBody>
@@ -16897,7 +16897,7 @@
                         <a:defRPr sz="800"/>
                       </a:pPr>
                       <a:r>
-                        <a:t>Head S6-7 R</a:t>
+                        <a:t>Head 88L R</a:t>
                       </a:r>
                     </a:p>
                   </a:txBody>
@@ -17100,7 +17100,7 @@
                         <a:defRPr sz="800"/>
                       </a:pPr>
                       <a:r>
-                        <a:t>SW148 N FB</a:t>
+                        <a:t>Switch 87 N FB</a:t>
                       </a:r>
                     </a:p>
                   </a:txBody>
@@ -17150,7 +17150,7 @@
                         <a:defRPr sz="800"/>
                       </a:pPr>
                       <a:r>
-                        <a:t>SW148 R FB</a:t>
+                        <a:t>Switch 87 R FB</a:t>
                       </a:r>
                     </a:p>
                   </a:txBody>
@@ -17200,7 +17200,7 @@
                         <a:defRPr sz="800"/>
                       </a:pPr>
                       <a:r>
-                        <a:t>SW149 N FB</a:t>
+                        <a:t>Switch 89 N FB</a:t>
                       </a:r>
                     </a:p>
                   </a:txBody>
@@ -17250,7 +17250,7 @@
                         <a:defRPr sz="800"/>
                       </a:pPr>
                       <a:r>
-                        <a:t>SW149 R FB</a:t>
+                        <a:t>Switch 89 R FB</a:t>
                       </a:r>
                     </a:p>
                   </a:txBody>
@@ -17300,7 +17300,7 @@
                         <a:defRPr sz="800"/>
                       </a:pPr>
                       <a:r>
-                        <a:t>SW150 N FB</a:t>
+                        <a:t>Switch 91 N FB</a:t>
                       </a:r>
                     </a:p>
                   </a:txBody>
@@ -17350,7 +17350,7 @@
                         <a:defRPr sz="800"/>
                       </a:pPr>
                       <a:r>
-                        <a:t>SW150 R FB</a:t>
+                        <a:t>Switch 91 R FB</a:t>
                       </a:r>
                     </a:p>
                   </a:txBody>
@@ -17553,7 +17553,7 @@
                         <a:defRPr sz="800"/>
                       </a:pPr>
                       <a:r>
-                        <a:t>SW148 BTN</a:t>
+                        <a:t>Switch 87 BTN</a:t>
                       </a:r>
                     </a:p>
                   </a:txBody>
@@ -17603,7 +17603,7 @@
                         <a:defRPr sz="800"/>
                       </a:pPr>
                       <a:r>
-                        <a:t>SW149 BTN</a:t>
+                        <a:t>Switch 89 BTN</a:t>
                       </a:r>
                     </a:p>
                   </a:txBody>
@@ -17653,7 +17653,7 @@
                         <a:defRPr sz="800"/>
                       </a:pPr>
                       <a:r>
-                        <a:t>SW150 BTN</a:t>
+                        <a:t>Switch 91 BTN</a:t>
                       </a:r>
                     </a:p>
                   </a:txBody>
@@ -17997,7 +17997,7 @@
                         <a:defRPr sz="800"/>
                       </a:pPr>
                       <a:r>
-                        <a:t>SW148</a:t>
+                        <a:t>Switch 87</a:t>
                       </a:r>
                     </a:p>
                   </a:txBody>
@@ -18047,7 +18047,7 @@
                         <a:defRPr sz="800"/>
                       </a:pPr>
                       <a:r>
-                        <a:t>SW149</a:t>
+                        <a:t>Switch 89</a:t>
                       </a:r>
                     </a:p>
                   </a:txBody>
@@ -18097,7 +18097,7 @@
                         <a:defRPr sz="800"/>
                       </a:pPr>
                       <a:r>
-                        <a:t>SW150</a:t>
+                        <a:t>Switch 91</a:t>
                       </a:r>
                     </a:p>
                   </a:txBody>
@@ -18505,7 +18505,7 @@
                         <a:defRPr sz="800"/>
                       </a:pPr>
                       <a:r>
-                        <a:t>SW124 N</a:t>
+                        <a:t>Switch 73 N</a:t>
                       </a:r>
                     </a:p>
                   </a:txBody>
@@ -18555,7 +18555,7 @@
                         <a:defRPr sz="800"/>
                       </a:pPr>
                       <a:r>
-                        <a:t>SW124 R</a:t>
+                        <a:t>Switch 73 R</a:t>
                       </a:r>
                     </a:p>
                   </a:txBody>
@@ -18946,7 +18946,7 @@
                         <a:defRPr sz="800"/>
                       </a:pPr>
                       <a:r>
-                        <a:t>Head S5-6 G</a:t>
+                        <a:t>Head 70RB G</a:t>
                       </a:r>
                     </a:p>
                   </a:txBody>
@@ -18996,7 +18996,7 @@
                         <a:defRPr sz="800"/>
                       </a:pPr>
                       <a:r>
-                        <a:t>Head S5-6 Y</a:t>
+                        <a:t>Head 70RB Y</a:t>
                       </a:r>
                     </a:p>
                   </a:txBody>
@@ -19046,7 +19046,7 @@
                         <a:defRPr sz="800"/>
                       </a:pPr>
                       <a:r>
-                        <a:t>Head S5-6 R</a:t>
+                        <a:t>Head 70RB R</a:t>
                       </a:r>
                     </a:p>
                   </a:txBody>
@@ -19096,7 +19096,7 @@
                         <a:defRPr sz="800"/>
                       </a:pPr>
                       <a:r>
-                        <a:t>Head S5-7 G</a:t>
+                        <a:t>Head 74RB G</a:t>
                       </a:r>
                     </a:p>
                   </a:txBody>
@@ -19146,7 +19146,7 @@
                         <a:defRPr sz="800"/>
                       </a:pPr>
                       <a:r>
-                        <a:t>Head S5-7 R</a:t>
+                        <a:t>Head 74RB R</a:t>
                       </a:r>
                     </a:p>
                   </a:txBody>
@@ -19196,7 +19196,7 @@
                         <a:defRPr sz="800"/>
                       </a:pPr>
                       <a:r>
-                        <a:t>Head S5-7 Y</a:t>
+                        <a:t>Head 74RB Y</a:t>
                       </a:r>
                     </a:p>
                   </a:txBody>
@@ -20434,7 +20434,7 @@
                         <a:defRPr sz="800"/>
                       </a:pPr>
                       <a:r>
-                        <a:t>SW127</a:t>
+                        <a:t>Switch 63</a:t>
                       </a:r>
                     </a:p>
                   </a:txBody>
@@ -20510,7 +20510,7 @@
                         <a:defRPr sz="800"/>
                       </a:pPr>
                       <a:r>
-                        <a:t>S4-3, S4-1</a:t>
+                        <a:t>64L, 64R</a:t>
                       </a:r>
                     </a:p>
                   </a:txBody>
@@ -20531,7 +20531,7 @@
                         <a:defRPr sz="800"/>
                       </a:pPr>
                       <a:r>
-                        <a:t>SW129</a:t>
+                        <a:t>Switch 65</a:t>
                       </a:r>
                     </a:p>
                   </a:txBody>
@@ -20561,7 +20561,7 @@
                         <a:defRPr sz="800"/>
                       </a:pPr>
                       <a:r>
-                        <a:t>C21-IN2-2</a:t>
+                        <a:t>C21-IN2-4</a:t>
                       </a:r>
                     </a:p>
                   </a:txBody>
@@ -20576,7 +20576,7 @@
                         <a:defRPr sz="800"/>
                       </a:pPr>
                       <a:r>
-                        <a:t>N:C21-IN1-3, R:C21-IN1-4</a:t>
+                        <a:t>N:C21-IN1-7, R:C21-IN1-8</a:t>
                       </a:r>
                     </a:p>
                   </a:txBody>
@@ -20591,7 +20591,7 @@
                         <a:defRPr sz="800"/>
                       </a:pPr>
                       <a:r>
-                        <a:t>S4-2</a:t>
+                        <a:t>66RA, 66RB</a:t>
                       </a:r>
                     </a:p>
                   </a:txBody>
@@ -20608,7 +20608,7 @@
                         <a:defRPr sz="800"/>
                       </a:pPr>
                       <a:r>
-                        <a:t>SW138</a:t>
+                        <a:t>Switch 67</a:t>
                       </a:r>
                     </a:p>
                   </a:txBody>
@@ -20646,7 +20646,7 @@
                         <a:defRPr sz="800"/>
                       </a:pPr>
                       <a:r>
-                        <a:t>C21-IN2-4</a:t>
+                        <a:t>C21-IN2-2</a:t>
                       </a:r>
                     </a:p>
                   </a:txBody>
@@ -20665,7 +20665,7 @@
                         <a:defRPr sz="800"/>
                       </a:pPr>
                       <a:r>
-                        <a:t>N:C21-IN1-7, R:C21-IN1-8</a:t>
+                        <a:t>N:C21-IN1-3, R:C21-IN1-4</a:t>
                       </a:r>
                     </a:p>
                   </a:txBody>
@@ -20684,7 +20684,7 @@
                         <a:defRPr sz="800"/>
                       </a:pPr>
                       <a:r>
-                        <a:t>S4-4, S4-5</a:t>
+                        <a:t>68L</a:t>
                       </a:r>
                     </a:p>
                   </a:txBody>
@@ -20857,9 +20857,6 @@
                       <a:pPr>
                         <a:defRPr sz="800"/>
                       </a:pPr>
-                      <a:r>
-                        <a:t>S2-6</a:t>
-                      </a:r>
                     </a:p>
                   </a:txBody>
                   <a:tcPr>
@@ -20938,9 +20935,6 @@
                       <a:pPr>
                         <a:defRPr sz="800"/>
                       </a:pPr>
-                      <a:r>
-                        <a:t>S2-7</a:t>
-                      </a:r>
                     </a:p>
                   </a:txBody>
                   <a:tcPr/>
@@ -21031,9 +21025,6 @@
                       <a:pPr>
                         <a:defRPr sz="800"/>
                       </a:pPr>
-                      <a:r>
-                        <a:t>S2-8, S2-5</a:t>
-                      </a:r>
                     </a:p>
                   </a:txBody>
                   <a:tcPr>
@@ -21618,7 +21609,7 @@
                         <a:defRPr sz="800"/>
                       </a:pPr>
                       <a:r>
-                        <a:t>SW144</a:t>
+                        <a:t>Switch 79</a:t>
                       </a:r>
                     </a:p>
                   </a:txBody>
@@ -21694,7 +21685,7 @@
                         <a:defRPr sz="800"/>
                       </a:pPr>
                       <a:r>
-                        <a:t>S6-1, S6-4</a:t>
+                        <a:t>76L, 78RA</a:t>
                       </a:r>
                     </a:p>
                   </a:txBody>
@@ -21715,7 +21706,7 @@
                         <a:defRPr sz="800"/>
                       </a:pPr>
                       <a:r>
-                        <a:t>SW145</a:t>
+                        <a:t>Switch 81</a:t>
                       </a:r>
                     </a:p>
                   </a:txBody>
@@ -21775,7 +21766,7 @@
                         <a:defRPr sz="800"/>
                       </a:pPr>
                       <a:r>
-                        <a:t>S6-10</a:t>
+                        <a:t>82L</a:t>
                       </a:r>
                     </a:p>
                   </a:txBody>
@@ -21792,7 +21783,7 @@
                         <a:defRPr sz="800"/>
                       </a:pPr>
                       <a:r>
-                        <a:t>SW146</a:t>
+                        <a:t>Switch 83</a:t>
                       </a:r>
                     </a:p>
                   </a:txBody>
@@ -21868,7 +21859,7 @@
                         <a:defRPr sz="800"/>
                       </a:pPr>
                       <a:r>
-                        <a:t>S6-11, S6-12</a:t>
+                        <a:t>84RA, 84RB</a:t>
                       </a:r>
                     </a:p>
                   </a:txBody>
@@ -21889,7 +21880,7 @@
                         <a:defRPr sz="800"/>
                       </a:pPr>
                       <a:r>
-                        <a:t>SW147</a:t>
+                        <a:t>Switch 85</a:t>
                       </a:r>
                     </a:p>
                   </a:txBody>
@@ -21963,7 +21954,7 @@
                         <a:defRPr sz="800"/>
                       </a:pPr>
                       <a:r>
-                        <a:t>NIX</a:t>
+                        <a:t>Switch 61</a:t>
                       </a:r>
                     </a:p>
                   </a:txBody>
@@ -22039,7 +22030,7 @@
                         <a:defRPr sz="800"/>
                       </a:pPr>
                       <a:r>
-                        <a:t>S4-6, S4-5, S4-4</a:t>
+                        <a:t>62L, 66RB, 66RA</a:t>
                       </a:r>
                     </a:p>
                   </a:txBody>
@@ -22060,7 +22051,7 @@
                         <a:defRPr sz="800"/>
                       </a:pPr>
                       <a:r>
-                        <a:t>DJE</a:t>
+                        <a:t>Switch 69</a:t>
                       </a:r>
                     </a:p>
                   </a:txBody>
@@ -22120,7 +22111,7 @@
                         <a:defRPr sz="800"/>
                       </a:pPr>
                       <a:r>
-                        <a:t>S5-1, S5-5, S5-6</a:t>
+                        <a:t>70L, 70RA, 70RB</a:t>
                       </a:r>
                     </a:p>
                   </a:txBody>
@@ -22137,7 +22128,7 @@
                         <a:defRPr sz="800"/>
                       </a:pPr>
                       <a:r>
-                        <a:t>DJW</a:t>
+                        <a:t>Switch 71</a:t>
                       </a:r>
                     </a:p>
                   </a:txBody>
@@ -22213,7 +22204,7 @@
                         <a:defRPr sz="800"/>
                       </a:pPr>
                       <a:r>
-                        <a:t>S5-2, S5-4</a:t>
+                        <a:t>72L, 74RA</a:t>
                       </a:r>
                     </a:p>
                   </a:txBody>
@@ -22234,7 +22225,7 @@
                         <a:defRPr sz="800"/>
                       </a:pPr>
                       <a:r>
-                        <a:t>CBX</a:t>
+                        <a:t>Switch 75</a:t>
                       </a:r>
                     </a:p>
                   </a:txBody>
@@ -22294,7 +22285,7 @@
                         <a:defRPr sz="800"/>
                       </a:pPr>
                       <a:r>
-                        <a:t>S6-1, S6-2</a:t>
+                        <a:t>76L, 76R</a:t>
                       </a:r>
                     </a:p>
                   </a:txBody>
@@ -22311,7 +22302,7 @@
                         <a:defRPr sz="800"/>
                       </a:pPr>
                       <a:r>
-                        <a:t>SW143</a:t>
+                        <a:t>Switch 77</a:t>
                       </a:r>
                     </a:p>
                   </a:txBody>
@@ -22387,7 +22378,7 @@
                         <a:defRPr sz="800"/>
                       </a:pPr>
                       <a:r>
-                        <a:t>S6-4, S6-5</a:t>
+                        <a:t>78RA, 78RB</a:t>
                       </a:r>
                     </a:p>
                   </a:txBody>
@@ -22408,7 +22399,7 @@
                         <a:defRPr sz="800"/>
                       </a:pPr>
                       <a:r>
-                        <a:t>SW148</a:t>
+                        <a:t>Switch 87</a:t>
                       </a:r>
                     </a:p>
                   </a:txBody>
@@ -22468,7 +22459,7 @@
                         <a:defRPr sz="800"/>
                       </a:pPr>
                       <a:r>
-                        <a:t>S6-1, S6-5</a:t>
+                        <a:t>76L, 78RB</a:t>
                       </a:r>
                     </a:p>
                   </a:txBody>
@@ -22485,7 +22476,7 @@
                         <a:defRPr sz="800"/>
                       </a:pPr>
                       <a:r>
-                        <a:t>SW149</a:t>
+                        <a:t>Switch 89</a:t>
                       </a:r>
                     </a:p>
                   </a:txBody>
@@ -22561,7 +22552,7 @@
                         <a:defRPr sz="800"/>
                       </a:pPr>
                       <a:r>
-                        <a:t>S6-14</a:t>
+                        <a:t>90L</a:t>
                       </a:r>
                     </a:p>
                   </a:txBody>
@@ -22582,7 +22573,7 @@
                         <a:defRPr sz="800"/>
                       </a:pPr>
                       <a:r>
-                        <a:t>SW150</a:t>
+                        <a:t>Switch 91</a:t>
                       </a:r>
                     </a:p>
                   </a:txBody>
@@ -22642,7 +22633,7 @@
                         <a:defRPr sz="800"/>
                       </a:pPr>
                       <a:r>
-                        <a:t>S6-15</a:t>
+                        <a:t>92L</a:t>
                       </a:r>
                     </a:p>
                   </a:txBody>
@@ -22659,7 +22650,7 @@
                         <a:defRPr sz="800"/>
                       </a:pPr>
                       <a:r>
-                        <a:t>SW124</a:t>
+                        <a:t>Switch 73</a:t>
                       </a:r>
                     </a:p>
                   </a:txBody>
@@ -22735,7 +22726,7 @@
                         <a:defRPr sz="800"/>
                       </a:pPr>
                       <a:r>
-                        <a:t>S5-3, S5-4, S5-7</a:t>
+                        <a:t>74L, 74RA, 74RB</a:t>
                       </a:r>
                     </a:p>
                   </a:txBody>
@@ -26434,9 +26425,6 @@
                         </a:spcAft>
                         <a:defRPr sz="800"/>
                       </a:pPr>
-                      <a:r>
-                        <a:t>S2-6 Y</a:t>
-                      </a:r>
                     </a:p>
                   </a:txBody>
                   <a:tcPr anchor="t"/>
@@ -26593,9 +26581,6 @@
                         </a:spcAft>
                         <a:defRPr sz="800"/>
                       </a:pPr>
-                      <a:r>
-                        <a:t>S2-6 G</a:t>
-                      </a:r>
                     </a:p>
                   </a:txBody>
                   <a:tcPr anchor="t"/>
@@ -26643,9 +26628,6 @@
                         </a:spcAft>
                         <a:defRPr sz="800"/>
                       </a:pPr>
-                      <a:r>
-                        <a:t>S2-6 R</a:t>
-                      </a:r>
                     </a:p>
                   </a:txBody>
                   <a:tcPr anchor="t"/>
@@ -26693,9 +26675,6 @@
                         </a:spcAft>
                         <a:defRPr sz="800"/>
                       </a:pPr>
-                      <a:r>
-                        <a:t>S2-7 G</a:t>
-                      </a:r>
                     </a:p>
                   </a:txBody>
                   <a:tcPr anchor="t"/>
@@ -26743,9 +26722,6 @@
                         </a:spcAft>
                         <a:defRPr sz="800"/>
                       </a:pPr>
-                      <a:r>
-                        <a:t>S2-7 R</a:t>
-                      </a:r>
                     </a:p>
                   </a:txBody>
                   <a:tcPr anchor="t"/>
@@ -26793,9 +26769,6 @@
                         </a:spcAft>
                         <a:defRPr sz="800"/>
                       </a:pPr>
-                      <a:r>
-                        <a:t>S2-7 Y</a:t>
-                      </a:r>
                     </a:p>
                   </a:txBody>
                   <a:tcPr anchor="t"/>
@@ -33569,7 +33542,7 @@
                         <a:defRPr sz="800"/>
                       </a:pPr>
                       <a:r>
-                        <a:t>SW129 N</a:t>
+                        <a:t>Switch 67 N</a:t>
                       </a:r>
                     </a:p>
                   </a:txBody>
@@ -33619,7 +33592,7 @@
                         <a:defRPr sz="800"/>
                       </a:pPr>
                       <a:r>
-                        <a:t>SW129 R</a:t>
+                        <a:t>Switch 67 R</a:t>
                       </a:r>
                     </a:p>
                   </a:txBody>
@@ -33669,7 +33642,7 @@
                         <a:defRPr sz="800"/>
                       </a:pPr>
                       <a:r>
-                        <a:t>SW127 N</a:t>
+                        <a:t>Switch 63 N</a:t>
                       </a:r>
                     </a:p>
                   </a:txBody>
@@ -33719,7 +33692,7 @@
                         <a:defRPr sz="800"/>
                       </a:pPr>
                       <a:r>
-                        <a:t>SW127 R</a:t>
+                        <a:t>Switch 63 R</a:t>
                       </a:r>
                     </a:p>
                   </a:txBody>
@@ -33769,7 +33742,7 @@
                         <a:defRPr sz="800"/>
                       </a:pPr>
                       <a:r>
-                        <a:t>SW138 N</a:t>
+                        <a:t>Switch 65 N</a:t>
                       </a:r>
                     </a:p>
                   </a:txBody>
@@ -33819,7 +33792,7 @@
                         <a:defRPr sz="800"/>
                       </a:pPr>
                       <a:r>
-                        <a:t>SW138 R</a:t>
+                        <a:t>Switch 65 R</a:t>
                       </a:r>
                     </a:p>
                   </a:txBody>

</xml_diff>